<commit_message>
Add Phase 7 story to article, README, and exec deck
- Article: new section "The best catch was human" — review-predicted
  price-storm bottleneck, proven at 517k MV/s saturation, fixed by
  conflation (240x less work); framing now 7 prompts / 7 phases /
  6 bugs + 1 design flaw
- README: headline results row for price storms; provenance updated to
  Phase-7; test count 18
- Deck: 7th phase card, review-driven Case 3 on the load-test slide,
  stat tiles refreshed (7 prompts, ~$200, 6+1 findings)

Co-Authored-By: Claude Fable 5 <noreply@anthropic.com>
</commit_message>
<xml_diff>
--- a/docs/flink-demo-exec-briefing.pptx
+++ b/docs/flink-demo-exec-briefing.pptx
@@ -4749,7 +4749,7 @@
                   <a:srgbClr val="52514E"/>
                 </a:solidFill>
               </a:rPr>
-              <a:t>Six phases — each ended in something reviewable and running</a:t>
+              <a:t>Seven phases — each ended in something reviewable and running</a:t>
             </a:r>
           </a:p>
         </p:txBody>
@@ -4762,8 +4762,8 @@
         </p:nvSpPr>
         <p:spPr>
           <a:xfrm>
-            <a:off x="502920" y="2011680"/>
-            <a:ext cx="1783080" cy="1463040"/>
+            <a:off x="411480" y="2011680"/>
+            <a:ext cx="1536192" cy="1463040"/>
           </a:xfrm>
           <a:prstGeom prst="roundRect">
             <a:avLst/>
@@ -4797,7 +4797,7 @@
           <a:p>
             <a:pPr algn="ctr"/>
             <a:r>
-              <a:rPr sz="1400" b="1">
+              <a:rPr sz="1200" b="1">
                 <a:solidFill>
                   <a:srgbClr val="0B0B0B"/>
                 </a:solidFill>
@@ -4808,7 +4808,7 @@
           <a:p>
             <a:pPr algn="ctr"/>
             <a:r>
-              <a:rPr sz="1200" b="0">
+              <a:rPr sz="1000" b="0">
                 <a:solidFill>
                   <a:srgbClr val="0B0B0B"/>
                 </a:solidFill>
@@ -4819,7 +4819,7 @@
           <a:p>
             <a:pPr algn="ctr"/>
             <a:r>
-              <a:rPr sz="1200" b="0">
+              <a:rPr sz="1000" b="0">
                 <a:solidFill>
                   <a:srgbClr val="0B0B0B"/>
                 </a:solidFill>
@@ -4837,8 +4837,8 @@
         </p:nvSpPr>
         <p:spPr>
           <a:xfrm>
-            <a:off x="2450591" y="2011680"/>
-            <a:ext cx="1783080" cy="1463040"/>
+            <a:off x="2048256" y="2011680"/>
+            <a:ext cx="1536192" cy="1463040"/>
           </a:xfrm>
           <a:prstGeom prst="roundRect">
             <a:avLst/>
@@ -4872,7 +4872,7 @@
           <a:p>
             <a:pPr algn="ctr"/>
             <a:r>
-              <a:rPr sz="1400" b="1">
+              <a:rPr sz="1200" b="1">
                 <a:solidFill>
                   <a:srgbClr val="0B0B0B"/>
                 </a:solidFill>
@@ -4883,7 +4883,7 @@
           <a:p>
             <a:pPr algn="ctr"/>
             <a:r>
-              <a:rPr sz="1200" b="0">
+              <a:rPr sz="1000" b="0">
                 <a:solidFill>
                   <a:srgbClr val="0B0B0B"/>
                 </a:solidFill>
@@ -4894,7 +4894,7 @@
           <a:p>
             <a:pPr algn="ctr"/>
             <a:r>
-              <a:rPr sz="1200" b="0">
+              <a:rPr sz="1000" b="0">
                 <a:solidFill>
                   <a:srgbClr val="0B0B0B"/>
                 </a:solidFill>
@@ -4912,8 +4912,8 @@
         </p:nvSpPr>
         <p:spPr>
           <a:xfrm>
-            <a:off x="4398264" y="2011680"/>
-            <a:ext cx="1783080" cy="1463040"/>
+            <a:off x="3685032" y="2011680"/>
+            <a:ext cx="1536192" cy="1463040"/>
           </a:xfrm>
           <a:prstGeom prst="roundRect">
             <a:avLst/>
@@ -4947,7 +4947,7 @@
           <a:p>
             <a:pPr algn="ctr"/>
             <a:r>
-              <a:rPr sz="1400" b="1">
+              <a:rPr sz="1200" b="1">
                 <a:solidFill>
                   <a:srgbClr val="0B0B0B"/>
                 </a:solidFill>
@@ -4958,7 +4958,7 @@
           <a:p>
             <a:pPr algn="ctr"/>
             <a:r>
-              <a:rPr sz="1200" b="0">
+              <a:rPr sz="1000" b="0">
                 <a:solidFill>
                   <a:srgbClr val="0B0B0B"/>
                 </a:solidFill>
@@ -4969,7 +4969,7 @@
           <a:p>
             <a:pPr algn="ctr"/>
             <a:r>
-              <a:rPr sz="1200" b="0">
+              <a:rPr sz="1000" b="0">
                 <a:solidFill>
                   <a:srgbClr val="0B0B0B"/>
                 </a:solidFill>
@@ -4987,8 +4987,8 @@
         </p:nvSpPr>
         <p:spPr>
           <a:xfrm>
-            <a:off x="6345936" y="2011680"/>
-            <a:ext cx="1783080" cy="1463040"/>
+            <a:off x="5321808" y="2011680"/>
+            <a:ext cx="1536192" cy="1463040"/>
           </a:xfrm>
           <a:prstGeom prst="roundRect">
             <a:avLst/>
@@ -5022,7 +5022,7 @@
           <a:p>
             <a:pPr algn="ctr"/>
             <a:r>
-              <a:rPr sz="1400" b="1">
+              <a:rPr sz="1200" b="1">
                 <a:solidFill>
                   <a:srgbClr val="0B0B0B"/>
                 </a:solidFill>
@@ -5033,23 +5033,23 @@
           <a:p>
             <a:pPr algn="ctr"/>
             <a:r>
-              <a:rPr sz="1200" b="0">
-                <a:solidFill>
-                  <a:srgbClr val="0B0B0B"/>
-                </a:solidFill>
-              </a:rPr>
-              <a:t>14 tests + independent</a:t>
+              <a:rPr sz="1000" b="0">
+                <a:solidFill>
+                  <a:srgbClr val="0B0B0B"/>
+                </a:solidFill>
+              </a:rPr>
+              <a:t>18 tests + indep.</a:t>
             </a:r>
           </a:p>
           <a:p>
             <a:pPr algn="ctr"/>
             <a:r>
-              <a:rPr sz="1200" b="0">
-                <a:solidFill>
-                  <a:srgbClr val="0B0B0B"/>
-                </a:solidFill>
-              </a:rPr>
-              <a:t>validation, all green</a:t>
+              <a:rPr sz="1000" b="0">
+                <a:solidFill>
+                  <a:srgbClr val="0B0B0B"/>
+                </a:solidFill>
+              </a:rPr>
+              <a:t>validation, green</a:t>
             </a:r>
           </a:p>
         </p:txBody>
@@ -5062,8 +5062,8 @@
         </p:nvSpPr>
         <p:spPr>
           <a:xfrm>
-            <a:off x="8293608" y="2011680"/>
-            <a:ext cx="1783080" cy="1463040"/>
+            <a:off x="6958584" y="2011680"/>
+            <a:ext cx="1536192" cy="1463040"/>
           </a:xfrm>
           <a:prstGeom prst="roundRect">
             <a:avLst/>
@@ -5097,7 +5097,7 @@
           <a:p>
             <a:pPr algn="ctr"/>
             <a:r>
-              <a:rPr sz="1400" b="1">
+              <a:rPr sz="1200" b="1">
                 <a:solidFill>
                   <a:srgbClr val="0B0B0B"/>
                 </a:solidFill>
@@ -5108,7 +5108,7 @@
           <a:p>
             <a:pPr algn="ctr"/>
             <a:r>
-              <a:rPr sz="1200" b="0">
+              <a:rPr sz="1000" b="0">
                 <a:solidFill>
                   <a:srgbClr val="0B0B0B"/>
                 </a:solidFill>
@@ -5119,7 +5119,7 @@
           <a:p>
             <a:pPr algn="ctr"/>
             <a:r>
-              <a:rPr sz="1200" b="0">
+              <a:rPr sz="1000" b="0">
                 <a:solidFill>
                   <a:srgbClr val="0B0B0B"/>
                 </a:solidFill>
@@ -5137,8 +5137,83 @@
         </p:nvSpPr>
         <p:spPr>
           <a:xfrm>
-            <a:off x="10241280" y="2011680"/>
-            <a:ext cx="1783080" cy="1463040"/>
+            <a:off x="8595359" y="2011680"/>
+            <a:ext cx="1536192" cy="1463040"/>
+          </a:xfrm>
+          <a:prstGeom prst="roundRect">
+            <a:avLst/>
+          </a:prstGeom>
+          <a:solidFill>
+            <a:srgbClr val="F0EFEC"/>
+          </a:solidFill>
+          <a:ln w="12700">
+            <a:solidFill>
+              <a:srgbClr val="2A78D6"/>
+            </a:solidFill>
+          </a:ln>
+        </p:spPr>
+        <p:style>
+          <a:lnRef idx="1">
+            <a:schemeClr val="accent1"/>
+          </a:lnRef>
+          <a:fillRef idx="3">
+            <a:schemeClr val="accent1"/>
+          </a:fillRef>
+          <a:effectRef idx="2">
+            <a:schemeClr val="accent1"/>
+          </a:effectRef>
+          <a:fontRef idx="minor">
+            <a:schemeClr val="lt1"/>
+          </a:fontRef>
+        </p:style>
+        <p:txBody>
+          <a:bodyPr rtlCol="0" anchor="ctr" wrap="square"/>
+          <a:lstStyle/>
+          <a:p>
+            <a:pPr algn="ctr"/>
+            <a:r>
+              <a:rPr sz="1200" b="1">
+                <a:solidFill>
+                  <a:srgbClr val="0B0B0B"/>
+                </a:solidFill>
+              </a:rPr>
+              <a:t>6. Load tests</a:t>
+            </a:r>
+          </a:p>
+          <a:p>
+            <a:pPr algn="ctr"/>
+            <a:r>
+              <a:rPr sz="1000" b="0">
+                <a:solidFill>
+                  <a:srgbClr val="0B0B0B"/>
+                </a:solidFill>
+              </a:rPr>
+              <a:t>Both perf cases</a:t>
+            </a:r>
+          </a:p>
+          <a:p>
+            <a:pPr algn="ctr"/>
+            <a:r>
+              <a:rPr sz="1000" b="0">
+                <a:solidFill>
+                  <a:srgbClr val="0B0B0B"/>
+                </a:solidFill>
+              </a:rPr>
+              <a:t>passed, measured</a:t>
+            </a:r>
+          </a:p>
+        </p:txBody>
+      </p:sp>
+      <p:sp>
+        <p:nvSpPr>
+          <p:cNvPr id="11" name="Rounded Rectangle 10"/>
+          <p:cNvSpPr/>
+          <p:nvPr/>
+        </p:nvSpPr>
+        <p:spPr>
+          <a:xfrm>
+            <a:off x="10232136" y="2011680"/>
+            <a:ext cx="1536192" cy="1463040"/>
           </a:xfrm>
           <a:prstGeom prst="roundRect">
             <a:avLst/>
@@ -5172,41 +5247,41 @@
           <a:p>
             <a:pPr algn="ctr"/>
             <a:r>
-              <a:rPr sz="1400" b="1">
-                <a:solidFill>
-                  <a:srgbClr val="0B0B0B"/>
-                </a:solidFill>
-              </a:rPr>
-              <a:t>6. Load tests</a:t>
+              <a:rPr sz="1200" b="1">
+                <a:solidFill>
+                  <a:srgbClr val="0B0B0B"/>
+                </a:solidFill>
+              </a:rPr>
+              <a:t>7. Review find</a:t>
             </a:r>
           </a:p>
           <a:p>
             <a:pPr algn="ctr"/>
             <a:r>
-              <a:rPr sz="1200" b="0">
-                <a:solidFill>
-                  <a:srgbClr val="0B0B0B"/>
-                </a:solidFill>
-              </a:rPr>
-              <a:t>Both perf cases</a:t>
+              <a:rPr sz="1000" b="0">
+                <a:solidFill>
+                  <a:srgbClr val="0B0B0B"/>
+                </a:solidFill>
+              </a:rPr>
+              <a:t>Price-storm flaw:</a:t>
             </a:r>
           </a:p>
           <a:p>
             <a:pPr algn="ctr"/>
             <a:r>
-              <a:rPr sz="1200" b="0">
-                <a:solidFill>
-                  <a:srgbClr val="0B0B0B"/>
-                </a:solidFill>
-              </a:rPr>
-              <a:t>passed, measured</a:t>
-            </a:r>
-          </a:p>
-        </p:txBody>
-      </p:sp>
-      <p:sp>
-        <p:nvSpPr>
-          <p:cNvPr id="11" name="TextBox 10"/>
+              <a:rPr sz="1000" b="0">
+                <a:solidFill>
+                  <a:srgbClr val="0B0B0B"/>
+                </a:solidFill>
+              </a:rPr>
+              <a:t>proven, fixed, verified</a:t>
+            </a:r>
+          </a:p>
+        </p:txBody>
+      </p:sp>
+      <p:sp>
+        <p:nvSpPr>
+          <p:cNvPr id="12" name="TextBox 11"/>
           <p:cNvSpPr txBox="1"/>
           <p:nvPr/>
         </p:nvSpPr>
@@ -5262,12 +5337,27 @@
               </a:spcAft>
             </a:pPr>
             <a:r>
+              <a:rPr sz="1700" b="1">
+                <a:solidFill>
+                  <a:srgbClr val="0B0B0B"/>
+                </a:solidFill>
+              </a:rPr>
+              <a:t>• Phase 7 was unplanned: a human review comment predicted the price-storm bottleneck — proven, fixed and re-verified the same day</a:t>
+            </a:r>
+          </a:p>
+          <a:p>
+            <a:pPr>
+              <a:spcAft>
+                <a:spcPts val="1000"/>
+              </a:spcAft>
+            </a:pPr>
+            <a:r>
               <a:rPr sz="1700" b="0">
                 <a:solidFill>
                   <a:srgbClr val="0B0B0B"/>
                 </a:solidFill>
               </a:rPr>
-              <a:t>• The six engineering prompts that drove the build are recorded in the repo (prompts/)</a:t>
+              <a:t>• The seven engineering prompts that drove the build are recorded in the repo (prompts/)</a:t>
             </a:r>
           </a:p>
         </p:txBody>
@@ -5432,7 +5522,7 @@
                   <a:srgbClr val="0B0B0B"/>
                 </a:solidFill>
               </a:rPr>
-              <a:t>• 14 unit tests against the real operators — including a golden dataset with hand-computed expected results</a:t>
+              <a:t>• 18 unit tests against the real operators — including a golden dataset with hand-computed expected results</a:t>
             </a:r>
           </a:p>
           <a:p>
@@ -6206,7 +6296,7 @@
         </p:nvSpPr>
         <p:spPr>
           <a:xfrm>
-            <a:off x="640080" y="4892040"/>
+            <a:off x="640080" y="4800600"/>
             <a:ext cx="10881360" cy="4754880"/>
           </a:xfrm>
           <a:prstGeom prst="rect">
@@ -6222,11 +6312,11 @@
           <a:p>
             <a:pPr>
               <a:spcAft>
-                <a:spcPts val="800"/>
+                <a:spcPts val="600"/>
               </a:spcAft>
             </a:pPr>
             <a:r>
-              <a:rPr sz="1600" b="1">
+              <a:rPr sz="1500" b="1">
                 <a:solidFill>
                   <a:srgbClr val="0B0B0B"/>
                 </a:solidFill>
@@ -6237,16 +6327,31 @@
           <a:p>
             <a:pPr>
               <a:spcAft>
-                <a:spcPts val="800"/>
+                <a:spcPts val="600"/>
               </a:spcAft>
             </a:pPr>
             <a:r>
-              <a:rPr sz="1600" b="0">
+              <a:rPr sz="1500" b="0">
                 <a:solidFill>
                   <a:srgbClr val="0B0B0B"/>
                 </a:solidFill>
               </a:rPr>
               <a:t>• Price magnitude is data, not work: the extreme-price case cannot slow the order path by design</a:t>
+            </a:r>
+          </a:p>
+          <a:p>
+            <a:pPr>
+              <a:spcAft>
+                <a:spcPts val="600"/>
+              </a:spcAft>
+            </a:pPr>
+            <a:r>
+              <a:rPr sz="1500" b="1">
+                <a:solidFill>
+                  <a:srgbClr val="008300"/>
+                </a:solidFill>
+              </a:rPr>
+              <a:t>• Review-driven Case 3: 10,000 price ticks/sec saturated the naive design; conflated re-valuation (config: 250 ms) gives 240x less work, zero backpressure, flat order latency</a:t>
             </a:r>
           </a:p>
         </p:txBody>
@@ -6969,7 +7074,7 @@
                   <a:srgbClr val="2A78D6"/>
                 </a:solidFill>
               </a:rPr>
-              <a:t>6 prompts</a:t>
+              <a:t>7 prompts</a:t>
             </a:r>
           </a:p>
           <a:p>
@@ -6980,7 +7085,7 @@
                   <a:srgbClr val="52514E"/>
                 </a:solidFill>
               </a:rPr>
-              <a:t>drove all six</a:t>
+              <a:t>drove all seven</a:t>
             </a:r>
           </a:p>
           <a:p>
@@ -7044,7 +7149,7 @@
                   <a:srgbClr val="2A78D6"/>
                 </a:solidFill>
               </a:rPr>
-              <a:t>≈ $128</a:t>
+              <a:t>≈ $200</a:t>
             </a:r>
           </a:p>
           <a:p>
@@ -7119,7 +7224,7 @@
                   <a:srgbClr val="2A78D6"/>
                 </a:solidFill>
               </a:rPr>
-              <a:t>6 bugs</a:t>
+              <a:t>6 + 1</a:t>
             </a:r>
           </a:p>
           <a:p>
@@ -7130,7 +7235,7 @@
                   <a:srgbClr val="52514E"/>
                 </a:solidFill>
               </a:rPr>
-              <a:t>found &amp; fixed by</a:t>
+              <a:t>bugs + design flaw</a:t>
             </a:r>
           </a:p>
           <a:p>
@@ -7141,7 +7246,7 @@
                   <a:srgbClr val="52514E"/>
                 </a:solidFill>
               </a:rPr>
-              <a:t>verification, pre-prod</a:t>
+              <a:t>found &amp; fixed pre-prod</a:t>
             </a:r>
           </a:p>
         </p:txBody>

</xml_diff>

<commit_message>
Scaling story across README, article, deck, and perf docs
- README: AWS ladder headline row, capacity model, Phase 8 provenance
- Article: section 7 "Then we turned the real dial" (AWS + ladder), 8
  prompts/8 phases framing, results table extended
- PERF_RESULTS: capacity playbook (P=12 recipe, Avro lever, ops kit)
- Deck: AWS ladder chart with capacity model, 8th phase card, deployed
  status, refreshed tiles (8 prompts, ~$430, 15 findings)

Co-Authored-By: Claude Fable 5 <noreply@anthropic.com>
</commit_message>
<xml_diff>
--- a/docs/flink-demo-exec-briefing.pptx
+++ b/docs/flink-demo-exec-briefing.pptx
@@ -134,7 +134,7 @@
               <c:strCache>
                 <c:ptCount val="1"/>
                 <c:pt idx="0">
-                  <c:v>Capacity (records/sec)</c:v>
+                  <c:v>Processed msgs/sec at saturation</c:v>
                 </c:pt>
               </c:strCache>
             </c:strRef>
@@ -150,13 +150,13 @@
               <c:strCache>
                 <c:ptCount val="3"/>
                 <c:pt idx="0">
-                  <c:v>Parallelism 1</c:v>
+                  <c:v>P=2 (2 KPUs)</c:v>
                 </c:pt>
                 <c:pt idx="1">
-                  <c:v>Parallelism 2</c:v>
+                  <c:v>P=4 (4 KPUs)</c:v>
                 </c:pt>
                 <c:pt idx="2">
-                  <c:v>Parallelism 4</c:v>
+                  <c:v>P=8 (8 KPUs)</c:v>
                 </c:pt>
               </c:strCache>
             </c:strRef>
@@ -168,13 +168,13 @@
                 <c:formatCode>General</c:formatCode>
                 <c:ptCount val="3"/>
                 <c:pt idx="0">
-                  <c:v>7000</c:v>
+                  <c:v>16500</c:v>
                 </c:pt>
                 <c:pt idx="1">
-                  <c:v>14300</c:v>
+                  <c:v>52000</c:v>
                 </c:pt>
                 <c:pt idx="2">
-                  <c:v>16800</c:v>
+                  <c:v>97000</c:v>
                 </c:pt>
               </c:numCache>
             </c:numRef>
@@ -4749,7 +4749,7 @@
                   <a:srgbClr val="52514E"/>
                 </a:solidFill>
               </a:rPr>
-              <a:t>Seven phases — each ended in something reviewable and running</a:t>
+              <a:t>Eight phases — each ended in something reviewable and running</a:t>
             </a:r>
           </a:p>
         </p:txBody>
@@ -4762,8 +4762,8 @@
         </p:nvSpPr>
         <p:spPr>
           <a:xfrm>
-            <a:off x="411480" y="2011680"/>
-            <a:ext cx="1536192" cy="1463040"/>
+            <a:off x="365760" y="2011680"/>
+            <a:ext cx="1353312" cy="1463040"/>
           </a:xfrm>
           <a:prstGeom prst="roundRect">
             <a:avLst/>
@@ -4797,7 +4797,7 @@
           <a:p>
             <a:pPr algn="ctr"/>
             <a:r>
-              <a:rPr sz="1200" b="1">
+              <a:rPr sz="1100" b="1">
                 <a:solidFill>
                   <a:srgbClr val="0B0B0B"/>
                 </a:solidFill>
@@ -4808,7 +4808,7 @@
           <a:p>
             <a:pPr algn="ctr"/>
             <a:r>
-              <a:rPr sz="1000" b="0">
+              <a:rPr sz="900" b="0">
                 <a:solidFill>
                   <a:srgbClr val="0B0B0B"/>
                 </a:solidFill>
@@ -4819,7 +4819,7 @@
           <a:p>
             <a:pPr algn="ctr"/>
             <a:r>
-              <a:rPr sz="1000" b="0">
+              <a:rPr sz="900" b="0">
                 <a:solidFill>
                   <a:srgbClr val="0B0B0B"/>
                 </a:solidFill>
@@ -4837,8 +4837,8 @@
         </p:nvSpPr>
         <p:spPr>
           <a:xfrm>
-            <a:off x="2048256" y="2011680"/>
-            <a:ext cx="1536192" cy="1463040"/>
+            <a:off x="1815084" y="2011680"/>
+            <a:ext cx="1353312" cy="1463040"/>
           </a:xfrm>
           <a:prstGeom prst="roundRect">
             <a:avLst/>
@@ -4872,7 +4872,7 @@
           <a:p>
             <a:pPr algn="ctr"/>
             <a:r>
-              <a:rPr sz="1200" b="1">
+              <a:rPr sz="1100" b="1">
                 <a:solidFill>
                   <a:srgbClr val="0B0B0B"/>
                 </a:solidFill>
@@ -4883,7 +4883,7 @@
           <a:p>
             <a:pPr algn="ctr"/>
             <a:r>
-              <a:rPr sz="1000" b="0">
+              <a:rPr sz="900" b="0">
                 <a:solidFill>
                   <a:srgbClr val="0B0B0B"/>
                 </a:solidFill>
@@ -4894,7 +4894,7 @@
           <a:p>
             <a:pPr algn="ctr"/>
             <a:r>
-              <a:rPr sz="1000" b="0">
+              <a:rPr sz="900" b="0">
                 <a:solidFill>
                   <a:srgbClr val="0B0B0B"/>
                 </a:solidFill>
@@ -4912,8 +4912,8 @@
         </p:nvSpPr>
         <p:spPr>
           <a:xfrm>
-            <a:off x="3685032" y="2011680"/>
-            <a:ext cx="1536192" cy="1463040"/>
+            <a:off x="3264408" y="2011680"/>
+            <a:ext cx="1353312" cy="1463040"/>
           </a:xfrm>
           <a:prstGeom prst="roundRect">
             <a:avLst/>
@@ -4947,7 +4947,7 @@
           <a:p>
             <a:pPr algn="ctr"/>
             <a:r>
-              <a:rPr sz="1200" b="1">
+              <a:rPr sz="1100" b="1">
                 <a:solidFill>
                   <a:srgbClr val="0B0B0B"/>
                 </a:solidFill>
@@ -4958,7 +4958,7 @@
           <a:p>
             <a:pPr algn="ctr"/>
             <a:r>
-              <a:rPr sz="1000" b="0">
+              <a:rPr sz="900" b="0">
                 <a:solidFill>
                   <a:srgbClr val="0B0B0B"/>
                 </a:solidFill>
@@ -4969,7 +4969,7 @@
           <a:p>
             <a:pPr algn="ctr"/>
             <a:r>
-              <a:rPr sz="1000" b="0">
+              <a:rPr sz="900" b="0">
                 <a:solidFill>
                   <a:srgbClr val="0B0B0B"/>
                 </a:solidFill>
@@ -4987,8 +4987,8 @@
         </p:nvSpPr>
         <p:spPr>
           <a:xfrm>
-            <a:off x="5321808" y="2011680"/>
-            <a:ext cx="1536192" cy="1463040"/>
+            <a:off x="4713732" y="2011680"/>
+            <a:ext cx="1353312" cy="1463040"/>
           </a:xfrm>
           <a:prstGeom prst="roundRect">
             <a:avLst/>
@@ -5022,7 +5022,7 @@
           <a:p>
             <a:pPr algn="ctr"/>
             <a:r>
-              <a:rPr sz="1200" b="1">
+              <a:rPr sz="1100" b="1">
                 <a:solidFill>
                   <a:srgbClr val="0B0B0B"/>
                 </a:solidFill>
@@ -5033,7 +5033,7 @@
           <a:p>
             <a:pPr algn="ctr"/>
             <a:r>
-              <a:rPr sz="1000" b="0">
+              <a:rPr sz="900" b="0">
                 <a:solidFill>
                   <a:srgbClr val="0B0B0B"/>
                 </a:solidFill>
@@ -5044,7 +5044,7 @@
           <a:p>
             <a:pPr algn="ctr"/>
             <a:r>
-              <a:rPr sz="1000" b="0">
+              <a:rPr sz="900" b="0">
                 <a:solidFill>
                   <a:srgbClr val="0B0B0B"/>
                 </a:solidFill>
@@ -5062,8 +5062,8 @@
         </p:nvSpPr>
         <p:spPr>
           <a:xfrm>
-            <a:off x="6958584" y="2011680"/>
-            <a:ext cx="1536192" cy="1463040"/>
+            <a:off x="6163056" y="2011680"/>
+            <a:ext cx="1353312" cy="1463040"/>
           </a:xfrm>
           <a:prstGeom prst="roundRect">
             <a:avLst/>
@@ -5097,7 +5097,7 @@
           <a:p>
             <a:pPr algn="ctr"/>
             <a:r>
-              <a:rPr sz="1200" b="1">
+              <a:rPr sz="1100" b="1">
                 <a:solidFill>
                   <a:srgbClr val="0B0B0B"/>
                 </a:solidFill>
@@ -5108,7 +5108,7 @@
           <a:p>
             <a:pPr algn="ctr"/>
             <a:r>
-              <a:rPr sz="1000" b="0">
+              <a:rPr sz="900" b="0">
                 <a:solidFill>
                   <a:srgbClr val="0B0B0B"/>
                 </a:solidFill>
@@ -5119,7 +5119,7 @@
           <a:p>
             <a:pPr algn="ctr"/>
             <a:r>
-              <a:rPr sz="1000" b="0">
+              <a:rPr sz="900" b="0">
                 <a:solidFill>
                   <a:srgbClr val="0B0B0B"/>
                 </a:solidFill>
@@ -5137,8 +5137,8 @@
         </p:nvSpPr>
         <p:spPr>
           <a:xfrm>
-            <a:off x="8595359" y="2011680"/>
-            <a:ext cx="1536192" cy="1463040"/>
+            <a:off x="7612379" y="2011680"/>
+            <a:ext cx="1353312" cy="1463040"/>
           </a:xfrm>
           <a:prstGeom prst="roundRect">
             <a:avLst/>
@@ -5172,7 +5172,7 @@
           <a:p>
             <a:pPr algn="ctr"/>
             <a:r>
-              <a:rPr sz="1200" b="1">
+              <a:rPr sz="1100" b="1">
                 <a:solidFill>
                   <a:srgbClr val="0B0B0B"/>
                 </a:solidFill>
@@ -5183,7 +5183,7 @@
           <a:p>
             <a:pPr algn="ctr"/>
             <a:r>
-              <a:rPr sz="1000" b="0">
+              <a:rPr sz="900" b="0">
                 <a:solidFill>
                   <a:srgbClr val="0B0B0B"/>
                 </a:solidFill>
@@ -5194,7 +5194,7 @@
           <a:p>
             <a:pPr algn="ctr"/>
             <a:r>
-              <a:rPr sz="1000" b="0">
+              <a:rPr sz="900" b="0">
                 <a:solidFill>
                   <a:srgbClr val="0B0B0B"/>
                 </a:solidFill>
@@ -5212,8 +5212,8 @@
         </p:nvSpPr>
         <p:spPr>
           <a:xfrm>
-            <a:off x="10232136" y="2011680"/>
-            <a:ext cx="1536192" cy="1463040"/>
+            <a:off x="9061704" y="2011680"/>
+            <a:ext cx="1353312" cy="1463040"/>
           </a:xfrm>
           <a:prstGeom prst="roundRect">
             <a:avLst/>
@@ -5247,7 +5247,7 @@
           <a:p>
             <a:pPr algn="ctr"/>
             <a:r>
-              <a:rPr sz="1200" b="1">
+              <a:rPr sz="1100" b="1">
                 <a:solidFill>
                   <a:srgbClr val="0B0B0B"/>
                 </a:solidFill>
@@ -5258,7 +5258,7 @@
           <a:p>
             <a:pPr algn="ctr"/>
             <a:r>
-              <a:rPr sz="1000" b="0">
+              <a:rPr sz="900" b="0">
                 <a:solidFill>
                   <a:srgbClr val="0B0B0B"/>
                 </a:solidFill>
@@ -5269,7 +5269,7 @@
           <a:p>
             <a:pPr algn="ctr"/>
             <a:r>
-              <a:rPr sz="1000" b="0">
+              <a:rPr sz="900" b="0">
                 <a:solidFill>
                   <a:srgbClr val="0B0B0B"/>
                 </a:solidFill>
@@ -5281,7 +5281,82 @@
       </p:sp>
       <p:sp>
         <p:nvSpPr>
-          <p:cNvPr id="12" name="TextBox 11"/>
+          <p:cNvPr id="12" name="Rounded Rectangle 11"/>
+          <p:cNvSpPr/>
+          <p:nvPr/>
+        </p:nvSpPr>
+        <p:spPr>
+          <a:xfrm>
+            <a:off x="10511028" y="2011680"/>
+            <a:ext cx="1353312" cy="1463040"/>
+          </a:xfrm>
+          <a:prstGeom prst="roundRect">
+            <a:avLst/>
+          </a:prstGeom>
+          <a:solidFill>
+            <a:srgbClr val="FFFFFF"/>
+          </a:solidFill>
+          <a:ln w="12700">
+            <a:solidFill>
+              <a:srgbClr val="2A78D6"/>
+            </a:solidFill>
+          </a:ln>
+        </p:spPr>
+        <p:style>
+          <a:lnRef idx="1">
+            <a:schemeClr val="accent1"/>
+          </a:lnRef>
+          <a:fillRef idx="3">
+            <a:schemeClr val="accent1"/>
+          </a:fillRef>
+          <a:effectRef idx="2">
+            <a:schemeClr val="accent1"/>
+          </a:effectRef>
+          <a:fontRef idx="minor">
+            <a:schemeClr val="lt1"/>
+          </a:fontRef>
+        </p:style>
+        <p:txBody>
+          <a:bodyPr rtlCol="0" anchor="ctr" wrap="square"/>
+          <a:lstStyle/>
+          <a:p>
+            <a:pPr algn="ctr"/>
+            <a:r>
+              <a:rPr sz="1100" b="1">
+                <a:solidFill>
+                  <a:srgbClr val="0B0B0B"/>
+                </a:solidFill>
+              </a:rPr>
+              <a:t>8. AWS proof</a:t>
+            </a:r>
+          </a:p>
+          <a:p>
+            <a:pPr algn="ctr"/>
+            <a:r>
+              <a:rPr sz="900" b="0">
+                <a:solidFill>
+                  <a:srgbClr val="0B0B0B"/>
+                </a:solidFill>
+              </a:rPr>
+              <a:t>Deployed, all tests</a:t>
+            </a:r>
+          </a:p>
+          <a:p>
+            <a:pPr algn="ctr"/>
+            <a:r>
+              <a:rPr sz="900" b="0">
+                <a:solidFill>
+                  <a:srgbClr val="0B0B0B"/>
+                </a:solidFill>
+              </a:rPr>
+              <a:t>green, ladder measured</a:t>
+            </a:r>
+          </a:p>
+        </p:txBody>
+      </p:sp>
+      <p:sp>
+        <p:nvSpPr>
+          <p:cNvPr id="13" name="TextBox 12"/>
           <p:cNvSpPr txBox="1"/>
           <p:nvPr/>
         </p:nvSpPr>
@@ -6478,7 +6553,7 @@
                   <a:srgbClr val="52514E"/>
                 </a:solidFill>
               </a:rPr>
-              <a:t>Measured capacity at saturation (backlog catch-up)</a:t>
+              <a:t>Measured on AWS under sustained overload (Managed Flink KPUs)</a:t>
             </a:r>
           </a:p>
         </p:txBody>
@@ -6509,7 +6584,7 @@
         </p:nvSpPr>
         <p:spPr>
           <a:xfrm>
-            <a:off x="6949440" y="2194560"/>
+            <a:off x="6949440" y="2011680"/>
             <a:ext cx="4846320" cy="4754880"/>
           </a:xfrm>
           <a:prstGeom prst="rect">
@@ -6525,61 +6600,76 @@
           <a:p>
             <a:pPr>
               <a:spcAft>
-                <a:spcPts val="1200"/>
+                <a:spcPts val="1000"/>
               </a:spcAft>
             </a:pPr>
             <a:r>
-              <a:rPr sz="1600" b="1">
+              <a:rPr sz="1500" b="1">
                 <a:solidFill>
                   <a:srgbClr val="008300"/>
                 </a:solidFill>
               </a:rPr>
-              <a:t>• 1 → 2: exactly 2.0× — linear</a:t>
+              <a:t>• Each doubling of parallelism ~doubles throughput — one Terraform variable, zero job restarts</a:t>
             </a:r>
           </a:p>
           <a:p>
             <a:pPr>
               <a:spcAft>
-                <a:spcPts val="1200"/>
+                <a:spcPts val="1000"/>
               </a:spcAft>
             </a:pPr>
             <a:r>
-              <a:rPr sz="1600" b="0">
-                <a:solidFill>
-                  <a:srgbClr val="C98500"/>
-                </a:solidFill>
-              </a:rPr>
-              <a:t>• 2 → 4: limited by the 8-core laptop (28 tasks + Kafka + monitoring on one machine), not the pipeline</a:t>
+              <a:rPr sz="1500" b="0">
+                <a:solidFill>
+                  <a:srgbClr val="0B0B0B"/>
+                </a:solidFill>
+              </a:rPr>
+              <a:t>• Capacity model: ~12k msgs/sec per KPU (~$0.12/hr each)</a:t>
             </a:r>
           </a:p>
           <a:p>
             <a:pPr>
               <a:spcAft>
-                <a:spcPts val="1200"/>
+                <a:spcPts val="1000"/>
               </a:spcAft>
             </a:pPr>
             <a:r>
-              <a:rPr sz="1600" b="0">
-                <a:solidFill>
-                  <a:srgbClr val="0B0B0B"/>
-                </a:solidFill>
-              </a:rPr>
-              <a:t>• Rescaling = one config value; no rebuild, no code change</a:t>
+              <a:rPr sz="1500" b="0">
+                <a:solidFill>
+                  <a:srgbClr val="0B0B0B"/>
+                </a:solidFill>
+              </a:rPr>
+              <a:t>• The 110k msgs/sec stress load = a ~P=10 dial setting</a:t>
             </a:r>
           </a:p>
           <a:p>
             <a:pPr>
               <a:spcAft>
-                <a:spcPts val="1200"/>
+                <a:spcPts val="1000"/>
               </a:spcAft>
             </a:pPr>
             <a:r>
-              <a:rPr sz="1600" b="0">
-                <a:solidFill>
-                  <a:srgbClr val="0B0B0B"/>
-                </a:solidFill>
-              </a:rPr>
-              <a:t>• AWS (dedicated compute per unit) is the venue to demonstrate 4-way+ linearity</a:t>
+              <a:rPr sz="1500" b="0">
+                <a:solidFill>
+                  <a:srgbClr val="0B0B0B"/>
+                </a:solidFill>
+              </a:rPr>
+              <a:t>• Next 3-5x identified: binary serialization (Avro) instead of JSON — before buying more KPUs</a:t>
+            </a:r>
+          </a:p>
+          <a:p>
+            <a:pPr>
+              <a:spcAft>
+                <a:spcPts val="1000"/>
+              </a:spcAft>
+            </a:pPr>
+            <a:r>
+              <a:rPr sz="1500" b="0">
+                <a:solidFill>
+                  <a:srgbClr val="52514E"/>
+                </a:solidFill>
+              </a:rPr>
+              <a:t>• Laptop result matched: P=1-&gt;2 exactly 2.0x</a:t>
             </a:r>
           </a:p>
         </p:txBody>
@@ -6816,10 +6906,10 @@
             <a:r>
               <a:rPr sz="1800" b="1">
                 <a:solidFill>
-                  <a:srgbClr val="C98500"/>
-                </a:solidFill>
-              </a:rPr>
-              <a:t>• Status: validated and ready — awaiting credentials/approval to apply</a:t>
+                  <a:srgbClr val="008300"/>
+                </a:solidFill>
+              </a:rPr>
+              <a:t>• Status: DEPLOYED and load-tested on AWS — all cases green, scaling ladder measured, then torn down cleanly</a:t>
             </a:r>
           </a:p>
         </p:txBody>
@@ -7074,7 +7164,7 @@
                   <a:srgbClr val="2A78D6"/>
                 </a:solidFill>
               </a:rPr>
-              <a:t>7 prompts</a:t>
+              <a:t>8 prompts</a:t>
             </a:r>
           </a:p>
           <a:p>
@@ -7085,7 +7175,7 @@
                   <a:srgbClr val="52514E"/>
                 </a:solidFill>
               </a:rPr>
-              <a:t>drove all seven</a:t>
+              <a:t>drove all eight</a:t>
             </a:r>
           </a:p>
           <a:p>
@@ -7149,7 +7239,7 @@
                   <a:srgbClr val="2A78D6"/>
                 </a:solidFill>
               </a:rPr>
-              <a:t>≈ $200</a:t>
+              <a:t>≈ $430</a:t>
             </a:r>
           </a:p>
           <a:p>
@@ -7224,7 +7314,7 @@
                   <a:srgbClr val="2A78D6"/>
                 </a:solidFill>
               </a:rPr>
-              <a:t>6 + 1</a:t>
+              <a:t>15 finds</a:t>
             </a:r>
           </a:p>
           <a:p>
@@ -7235,7 +7325,7 @@
                   <a:srgbClr val="52514E"/>
                 </a:solidFill>
               </a:rPr>
-              <a:t>bugs + design flaw</a:t>
+              <a:t>6 bugs, 1 design flaw,</a:t>
             </a:r>
           </a:p>
           <a:p>
@@ -7246,7 +7336,7 @@
                   <a:srgbClr val="52514E"/>
                 </a:solidFill>
               </a:rPr>
-              <a:t>found &amp; fixed pre-prod</a:t>
+              <a:t>8 deploy gotchas — pre-prod</a:t>
             </a:r>
           </a:p>
         </p:txBody>

</xml_diff>

<commit_message>
Add live AWS evidence: ladder graphs and Flink UI screenshot
- CloudWatch-rendered throughput ladder (rungs -> drain -> P=12 plateau
  sustaining 110k msgs/s) and saturation-to-headroom graph
- AWS Flink UI: 84 tasks at parallelism 12, RUNNING
- Embedded in README (AWS section), PERF_RESULTS Phase 8b, article note,
  and a new evidence slide in the exec deck

Co-Authored-By: Claude Fable 5 <noreply@anthropic.com>
</commit_message>
<xml_diff>
--- a/docs/flink-demo-exec-briefing.pptx
+++ b/docs/flink-demo-exec-briefing.pptx
@@ -15,6 +15,7 @@
     <p:sldId id="263" r:id="rId14"/>
     <p:sldId id="264" r:id="rId15"/>
     <p:sldId id="265" r:id="rId16"/>
+    <p:sldId id="266" r:id="rId17"/>
   </p:sldIdLst>
   <p:sldSz cx="12191695" cy="6858000" type="screen4x3"/>
   <p:notesSz cx="6858000" cy="9144000"/>
@@ -3392,6 +3393,501 @@
 </file>
 
 <file path=ppt/slides/slide10.xml><?xml version="1.0" encoding="utf-8"?>
+<p:sld xmlns:a="http://schemas.openxmlformats.org/drawingml/2006/main" xmlns:p="http://schemas.openxmlformats.org/presentationml/2006/main" xmlns:r="http://schemas.openxmlformats.org/officeDocument/2006/relationships">
+  <p:cSld>
+    <p:spTree>
+      <p:nvGrpSpPr>
+        <p:cNvPr id="1" name=""/>
+        <p:cNvGrpSpPr/>
+        <p:nvPr/>
+      </p:nvGrpSpPr>
+      <p:grpSpPr/>
+      <p:sp>
+        <p:nvSpPr>
+          <p:cNvPr id="2" name="TextBox 1"/>
+          <p:cNvSpPr txBox="1"/>
+          <p:nvPr/>
+        </p:nvSpPr>
+        <p:spPr>
+          <a:xfrm>
+            <a:off x="548640" y="320040"/>
+            <a:ext cx="11064240" cy="914400"/>
+          </a:xfrm>
+          <a:prstGeom prst="rect">
+            <a:avLst/>
+          </a:prstGeom>
+          <a:noFill/>
+        </p:spPr>
+        <p:txBody>
+          <a:bodyPr wrap="square">
+            <a:spAutoFit/>
+          </a:bodyPr>
+          <a:lstStyle/>
+          <a:p>
+            <a:r>
+              <a:rPr sz="3000" b="1">
+                <a:solidFill>
+                  <a:srgbClr val="0B0B0B"/>
+                </a:solidFill>
+              </a:rPr>
+              <a:t>What it took to build</a:t>
+            </a:r>
+          </a:p>
+        </p:txBody>
+      </p:sp>
+      <p:sp>
+        <p:nvSpPr>
+          <p:cNvPr id="3" name="Rectangle 2"/>
+          <p:cNvSpPr/>
+          <p:nvPr/>
+        </p:nvSpPr>
+        <p:spPr>
+          <a:xfrm>
+            <a:off x="594360" y="1051560"/>
+            <a:ext cx="2011680" cy="50800"/>
+          </a:xfrm>
+          <a:prstGeom prst="rect">
+            <a:avLst/>
+          </a:prstGeom>
+          <a:solidFill>
+            <a:srgbClr val="2A78D6"/>
+          </a:solidFill>
+          <a:ln>
+            <a:noFill/>
+          </a:ln>
+        </p:spPr>
+        <p:style>
+          <a:lnRef idx="1">
+            <a:schemeClr val="accent1"/>
+          </a:lnRef>
+          <a:fillRef idx="3">
+            <a:schemeClr val="accent1"/>
+          </a:fillRef>
+          <a:effectRef idx="2">
+            <a:schemeClr val="accent1"/>
+          </a:effectRef>
+          <a:fontRef idx="minor">
+            <a:schemeClr val="lt1"/>
+          </a:fontRef>
+        </p:style>
+        <p:txBody>
+          <a:bodyPr rtlCol="0" anchor="ctr"/>
+          <a:lstStyle/>
+          <a:p>
+            <a:pPr algn="ctr"/>
+          </a:p>
+        </p:txBody>
+      </p:sp>
+      <p:sp>
+        <p:nvSpPr>
+          <p:cNvPr id="4" name="TextBox 3"/>
+          <p:cNvSpPr txBox="1"/>
+          <p:nvPr/>
+        </p:nvSpPr>
+        <p:spPr>
+          <a:xfrm>
+            <a:off x="548640" y="1143000"/>
+            <a:ext cx="11064240" cy="457200"/>
+          </a:xfrm>
+          <a:prstGeom prst="rect">
+            <a:avLst/>
+          </a:prstGeom>
+          <a:noFill/>
+        </p:spPr>
+        <p:txBody>
+          <a:bodyPr wrap="square">
+            <a:spAutoFit/>
+          </a:bodyPr>
+          <a:lstStyle/>
+          <a:p>
+            <a:r>
+              <a:rPr sz="1500">
+                <a:solidFill>
+                  <a:srgbClr val="52514E"/>
+                </a:solidFill>
+              </a:rPr>
+              <a:t>AI-assisted engineering with review gates</a:t>
+            </a:r>
+          </a:p>
+        </p:txBody>
+      </p:sp>
+      <p:sp>
+        <p:nvSpPr>
+          <p:cNvPr id="5" name="Rounded Rectangle 4"/>
+          <p:cNvSpPr/>
+          <p:nvPr/>
+        </p:nvSpPr>
+        <p:spPr>
+          <a:xfrm>
+            <a:off x="640080" y="1920240"/>
+            <a:ext cx="2560320" cy="1828800"/>
+          </a:xfrm>
+          <a:prstGeom prst="roundRect">
+            <a:avLst/>
+          </a:prstGeom>
+          <a:solidFill>
+            <a:srgbClr val="F0EFEC"/>
+          </a:solidFill>
+          <a:ln w="12700">
+            <a:solidFill>
+              <a:srgbClr val="2A78D6"/>
+            </a:solidFill>
+          </a:ln>
+        </p:spPr>
+        <p:style>
+          <a:lnRef idx="1">
+            <a:schemeClr val="accent1"/>
+          </a:lnRef>
+          <a:fillRef idx="3">
+            <a:schemeClr val="accent1"/>
+          </a:fillRef>
+          <a:effectRef idx="2">
+            <a:schemeClr val="accent1"/>
+          </a:effectRef>
+          <a:fontRef idx="minor">
+            <a:schemeClr val="lt1"/>
+          </a:fontRef>
+        </p:style>
+        <p:txBody>
+          <a:bodyPr rtlCol="0" anchor="ctr"/>
+          <a:lstStyle/>
+          <a:p>
+            <a:pPr algn="ctr"/>
+            <a:r>
+              <a:rPr sz="3400" b="1">
+                <a:solidFill>
+                  <a:srgbClr val="2A78D6"/>
+                </a:solidFill>
+              </a:rPr>
+              <a:t>1 day</a:t>
+            </a:r>
+          </a:p>
+          <a:p>
+            <a:pPr algn="ctr"/>
+            <a:r>
+              <a:rPr sz="1300">
+                <a:solidFill>
+                  <a:srgbClr val="52514E"/>
+                </a:solidFill>
+              </a:rPr>
+              <a:t>requirements to</a:t>
+            </a:r>
+          </a:p>
+          <a:p>
+            <a:pPr algn="ctr"/>
+            <a:r>
+              <a:rPr sz="1300">
+                <a:solidFill>
+                  <a:srgbClr val="52514E"/>
+                </a:solidFill>
+              </a:rPr>
+              <a:t>load-tested system</a:t>
+            </a:r>
+          </a:p>
+        </p:txBody>
+      </p:sp>
+      <p:sp>
+        <p:nvSpPr>
+          <p:cNvPr id="6" name="Rounded Rectangle 5"/>
+          <p:cNvSpPr/>
+          <p:nvPr/>
+        </p:nvSpPr>
+        <p:spPr>
+          <a:xfrm>
+            <a:off x="3474720" y="1920240"/>
+            <a:ext cx="2560320" cy="1828800"/>
+          </a:xfrm>
+          <a:prstGeom prst="roundRect">
+            <a:avLst/>
+          </a:prstGeom>
+          <a:solidFill>
+            <a:srgbClr val="F0EFEC"/>
+          </a:solidFill>
+          <a:ln w="12700">
+            <a:solidFill>
+              <a:srgbClr val="2A78D6"/>
+            </a:solidFill>
+          </a:ln>
+        </p:spPr>
+        <p:style>
+          <a:lnRef idx="1">
+            <a:schemeClr val="accent1"/>
+          </a:lnRef>
+          <a:fillRef idx="3">
+            <a:schemeClr val="accent1"/>
+          </a:fillRef>
+          <a:effectRef idx="2">
+            <a:schemeClr val="accent1"/>
+          </a:effectRef>
+          <a:fontRef idx="minor">
+            <a:schemeClr val="lt1"/>
+          </a:fontRef>
+        </p:style>
+        <p:txBody>
+          <a:bodyPr rtlCol="0" anchor="ctr"/>
+          <a:lstStyle/>
+          <a:p>
+            <a:pPr algn="ctr"/>
+            <a:r>
+              <a:rPr sz="3400" b="1">
+                <a:solidFill>
+                  <a:srgbClr val="2A78D6"/>
+                </a:solidFill>
+              </a:rPr>
+              <a:t>8 prompts</a:t>
+            </a:r>
+          </a:p>
+          <a:p>
+            <a:pPr algn="ctr"/>
+            <a:r>
+              <a:rPr sz="1300">
+                <a:solidFill>
+                  <a:srgbClr val="52514E"/>
+                </a:solidFill>
+              </a:rPr>
+              <a:t>drove all eight</a:t>
+            </a:r>
+          </a:p>
+          <a:p>
+            <a:pPr algn="ctr"/>
+            <a:r>
+              <a:rPr sz="1300">
+                <a:solidFill>
+                  <a:srgbClr val="52514E"/>
+                </a:solidFill>
+              </a:rPr>
+              <a:t>phases of work</a:t>
+            </a:r>
+          </a:p>
+        </p:txBody>
+      </p:sp>
+      <p:sp>
+        <p:nvSpPr>
+          <p:cNvPr id="7" name="Rounded Rectangle 6"/>
+          <p:cNvSpPr/>
+          <p:nvPr/>
+        </p:nvSpPr>
+        <p:spPr>
+          <a:xfrm>
+            <a:off x="6309360" y="1920240"/>
+            <a:ext cx="2560320" cy="1828800"/>
+          </a:xfrm>
+          <a:prstGeom prst="roundRect">
+            <a:avLst/>
+          </a:prstGeom>
+          <a:solidFill>
+            <a:srgbClr val="F0EFEC"/>
+          </a:solidFill>
+          <a:ln w="12700">
+            <a:solidFill>
+              <a:srgbClr val="2A78D6"/>
+            </a:solidFill>
+          </a:ln>
+        </p:spPr>
+        <p:style>
+          <a:lnRef idx="1">
+            <a:schemeClr val="accent1"/>
+          </a:lnRef>
+          <a:fillRef idx="3">
+            <a:schemeClr val="accent1"/>
+          </a:fillRef>
+          <a:effectRef idx="2">
+            <a:schemeClr val="accent1"/>
+          </a:effectRef>
+          <a:fontRef idx="minor">
+            <a:schemeClr val="lt1"/>
+          </a:fontRef>
+        </p:style>
+        <p:txBody>
+          <a:bodyPr rtlCol="0" anchor="ctr"/>
+          <a:lstStyle/>
+          <a:p>
+            <a:pPr algn="ctr"/>
+            <a:r>
+              <a:rPr sz="3400" b="1">
+                <a:solidFill>
+                  <a:srgbClr val="2A78D6"/>
+                </a:solidFill>
+              </a:rPr>
+              <a:t>≈ $430</a:t>
+            </a:r>
+          </a:p>
+          <a:p>
+            <a:pPr algn="ctr"/>
+            <a:r>
+              <a:rPr sz="1300">
+                <a:solidFill>
+                  <a:srgbClr val="52514E"/>
+                </a:solidFill>
+              </a:rPr>
+              <a:t>metered AI compute</a:t>
+            </a:r>
+          </a:p>
+          <a:p>
+            <a:pPr algn="ctr"/>
+            <a:r>
+              <a:rPr sz="1300">
+                <a:solidFill>
+                  <a:srgbClr val="52514E"/>
+                </a:solidFill>
+              </a:rPr>
+              <a:t>(included in subscription)</a:t>
+            </a:r>
+          </a:p>
+        </p:txBody>
+      </p:sp>
+      <p:sp>
+        <p:nvSpPr>
+          <p:cNvPr id="8" name="Rounded Rectangle 7"/>
+          <p:cNvSpPr/>
+          <p:nvPr/>
+        </p:nvSpPr>
+        <p:spPr>
+          <a:xfrm>
+            <a:off x="9144000" y="1920240"/>
+            <a:ext cx="2560320" cy="1828800"/>
+          </a:xfrm>
+          <a:prstGeom prst="roundRect">
+            <a:avLst/>
+          </a:prstGeom>
+          <a:solidFill>
+            <a:srgbClr val="F0EFEC"/>
+          </a:solidFill>
+          <a:ln w="12700">
+            <a:solidFill>
+              <a:srgbClr val="2A78D6"/>
+            </a:solidFill>
+          </a:ln>
+        </p:spPr>
+        <p:style>
+          <a:lnRef idx="1">
+            <a:schemeClr val="accent1"/>
+          </a:lnRef>
+          <a:fillRef idx="3">
+            <a:schemeClr val="accent1"/>
+          </a:fillRef>
+          <a:effectRef idx="2">
+            <a:schemeClr val="accent1"/>
+          </a:effectRef>
+          <a:fontRef idx="minor">
+            <a:schemeClr val="lt1"/>
+          </a:fontRef>
+        </p:style>
+        <p:txBody>
+          <a:bodyPr rtlCol="0" anchor="ctr"/>
+          <a:lstStyle/>
+          <a:p>
+            <a:pPr algn="ctr"/>
+            <a:r>
+              <a:rPr sz="3400" b="1">
+                <a:solidFill>
+                  <a:srgbClr val="2A78D6"/>
+                </a:solidFill>
+              </a:rPr>
+              <a:t>15 finds</a:t>
+            </a:r>
+          </a:p>
+          <a:p>
+            <a:pPr algn="ctr"/>
+            <a:r>
+              <a:rPr sz="1300">
+                <a:solidFill>
+                  <a:srgbClr val="52514E"/>
+                </a:solidFill>
+              </a:rPr>
+              <a:t>6 bugs, 1 design flaw,</a:t>
+            </a:r>
+          </a:p>
+          <a:p>
+            <a:pPr algn="ctr"/>
+            <a:r>
+              <a:rPr sz="1300">
+                <a:solidFill>
+                  <a:srgbClr val="52514E"/>
+                </a:solidFill>
+              </a:rPr>
+              <a:t>8 deploy gotchas — pre-prod</a:t>
+            </a:r>
+          </a:p>
+        </p:txBody>
+      </p:sp>
+      <p:sp>
+        <p:nvSpPr>
+          <p:cNvPr id="9" name="TextBox 8"/>
+          <p:cNvSpPr txBox="1"/>
+          <p:nvPr/>
+        </p:nvSpPr>
+        <p:spPr>
+          <a:xfrm>
+            <a:off x="640080" y="4297680"/>
+            <a:ext cx="10881360" cy="4754880"/>
+          </a:xfrm>
+          <a:prstGeom prst="rect">
+            <a:avLst/>
+          </a:prstGeom>
+          <a:noFill/>
+        </p:spPr>
+        <p:txBody>
+          <a:bodyPr wrap="square">
+            <a:spAutoFit/>
+          </a:bodyPr>
+          <a:lstStyle/>
+          <a:p>
+            <a:pPr>
+              <a:spcAft>
+                <a:spcPts val="1000"/>
+              </a:spcAft>
+            </a:pPr>
+            <a:r>
+              <a:rPr sz="1700" b="1">
+                <a:solidFill>
+                  <a:srgbClr val="0B0B0B"/>
+                </a:solidFill>
+              </a:rPr>
+              <a:t>• Quality came from the process: plan first, review each outcome, make the system prove itself</a:t>
+            </a:r>
+          </a:p>
+          <a:p>
+            <a:pPr>
+              <a:spcAft>
+                <a:spcPts val="1000"/>
+              </a:spcAft>
+            </a:pPr>
+            <a:r>
+              <a:rPr sz="1700" b="0">
+                <a:solidFill>
+                  <a:srgbClr val="0B0B0B"/>
+                </a:solidFill>
+              </a:rPr>
+              <a:t>• Bugs caught included the kind that bite in production: dependency clashes, silent metric mismatches, replay semantics</a:t>
+            </a:r>
+          </a:p>
+          <a:p>
+            <a:pPr>
+              <a:spcAft>
+                <a:spcPts val="1000"/>
+              </a:spcAft>
+            </a:pPr>
+            <a:r>
+              <a:rPr sz="1700" b="0">
+                <a:solidFill>
+                  <a:srgbClr val="0B0B0B"/>
+                </a:solidFill>
+              </a:rPr>
+              <a:t>• Every prompt, decision, and result is recorded in the repository — fully auditable</a:t>
+            </a:r>
+          </a:p>
+        </p:txBody>
+      </p:sp>
+    </p:spTree>
+  </p:cSld>
+  <p:clrMapOvr>
+    <a:masterClrMapping/>
+  </p:clrMapOvr>
+</p:sld>
+</file>
+
+<file path=ppt/slides/slide11.xml><?xml version="1.0" encoding="utf-8"?>
 <p:sld xmlns:a="http://schemas.openxmlformats.org/drawingml/2006/main" xmlns:p="http://schemas.openxmlformats.org/presentationml/2006/main" xmlns:r="http://schemas.openxmlformats.org/officeDocument/2006/relationships">
   <p:cSld>
     <p:spTree>
@@ -6720,7 +7216,7 @@
                   <a:srgbClr val="0B0B0B"/>
                 </a:solidFill>
               </a:rPr>
-              <a:t>Path to production — AWS ready today</a:t>
+              <a:t>The ladder, as measured</a:t>
             </a:r>
           </a:p>
         </p:txBody>
@@ -6796,124 +7292,59 @@
                   <a:srgbClr val="52514E"/>
                 </a:solidFill>
               </a:rPr>
-              <a:t>Full infrastructure-as-code, validated; one command to deploy</a:t>
-            </a:r>
-          </a:p>
-        </p:txBody>
-      </p:sp>
-      <p:sp>
-        <p:nvSpPr>
-          <p:cNvPr id="5" name="TextBox 4"/>
-          <p:cNvSpPr txBox="1"/>
+              <a:t>CloudWatch, per-subtask throughput and saturation — AWS, Managed Flink</a:t>
+            </a:r>
+          </a:p>
+        </p:txBody>
+      </p:sp>
+      <p:pic>
+        <p:nvPicPr>
+          <p:cNvPr id="5" name="Picture 4" descr="aws-ladder-throughput.png"/>
+          <p:cNvPicPr>
+            <a:picLocks noChangeAspect="1"/>
+          </p:cNvPicPr>
           <p:nvPr/>
-        </p:nvSpPr>
-        <p:spPr>
-          <a:xfrm>
-            <a:off x="640080" y="1737360"/>
-            <a:ext cx="10881360" cy="4754880"/>
+        </p:nvPicPr>
+        <p:blipFill>
+          <a:blip r:embed="rId2"/>
+          <a:stretch>
+            <a:fillRect/>
+          </a:stretch>
+        </p:blipFill>
+        <p:spPr>
+          <a:xfrm>
+            <a:off x="457200" y="1554480"/>
+            <a:ext cx="11247120" cy="2468880"/>
           </a:xfrm>
           <a:prstGeom prst="rect">
             <a:avLst/>
           </a:prstGeom>
-          <a:noFill/>
-        </p:spPr>
-        <p:txBody>
-          <a:bodyPr wrap="square">
-            <a:spAutoFit/>
-          </a:bodyPr>
-          <a:lstStyle/>
-          <a:p>
-            <a:pPr>
-              <a:spcAft>
-                <a:spcPts val="1200"/>
-              </a:spcAft>
-            </a:pPr>
-            <a:r>
-              <a:rPr sz="1800" b="0">
-                <a:solidFill>
-                  <a:srgbClr val="0B0B0B"/>
-                </a:solidFill>
-              </a:rPr>
-              <a:t>• Terraform stack complete: MSK Serverless (Kafka) + Amazon Managed Service for Apache Flink + generator on Fargate + CloudWatch dashboard</a:t>
-            </a:r>
-          </a:p>
-          <a:p>
-            <a:pPr>
-              <a:spcAft>
-                <a:spcPts val="1200"/>
-              </a:spcAft>
-            </a:pPr>
-            <a:r>
-              <a:rPr sz="1800" b="1">
-                <a:solidFill>
-                  <a:srgbClr val="0B0B0B"/>
-                </a:solidFill>
-              </a:rPr>
-              <a:t>• The exact same application jar runs on AWS — every environment difference is configuration</a:t>
-            </a:r>
-          </a:p>
-          <a:p>
-            <a:pPr>
-              <a:spcAft>
-                <a:spcPts val="1200"/>
-              </a:spcAft>
-            </a:pPr>
-            <a:r>
-              <a:rPr sz="1800" b="0">
-                <a:solidFill>
-                  <a:srgbClr val="0B0B0B"/>
-                </a:solidFill>
-              </a:rPr>
-              <a:t>• Security by default: private VPC, IAM auth to Kafka, least-privilege roles</a:t>
-            </a:r>
-          </a:p>
-          <a:p>
-            <a:pPr>
-              <a:spcAft>
-                <a:spcPts val="1200"/>
-              </a:spcAft>
-            </a:pPr>
-            <a:r>
-              <a:rPr sz="1800" b="0">
-                <a:solidFill>
-                  <a:srgbClr val="0B0B0B"/>
-                </a:solidFill>
-              </a:rPr>
-              <a:t>• Operations runbook: deploy, in-place code update, config-only rescale, teardown</a:t>
-            </a:r>
-          </a:p>
-          <a:p>
-            <a:pPr>
-              <a:spcAft>
-                <a:spcPts val="1200"/>
-              </a:spcAft>
-            </a:pPr>
-            <a:r>
-              <a:rPr sz="1800" b="0">
-                <a:solidFill>
-                  <a:srgbClr val="0B0B0B"/>
-                </a:solidFill>
-              </a:rPr>
-              <a:t>• Demo cost ≈ $1/hour while running; destroyed when not in use</a:t>
-            </a:r>
-          </a:p>
-          <a:p>
-            <a:pPr>
-              <a:spcAft>
-                <a:spcPts val="1200"/>
-              </a:spcAft>
-            </a:pPr>
-            <a:r>
-              <a:rPr sz="1800" b="1">
-                <a:solidFill>
-                  <a:srgbClr val="008300"/>
-                </a:solidFill>
-              </a:rPr>
-              <a:t>• Status: DEPLOYED and load-tested on AWS — all cases green, scaling ladder measured, then torn down cleanly</a:t>
-            </a:r>
-          </a:p>
-        </p:txBody>
-      </p:sp>
+        </p:spPr>
+      </p:pic>
+      <p:pic>
+        <p:nvPicPr>
+          <p:cNvPr id="6" name="Picture 5" descr="aws-busy-backpressure.png"/>
+          <p:cNvPicPr>
+            <a:picLocks noChangeAspect="1"/>
+          </p:cNvPicPr>
+          <p:nvPr/>
+        </p:nvPicPr>
+        <p:blipFill>
+          <a:blip r:embed="rId3"/>
+          <a:stretch>
+            <a:fillRect/>
+          </a:stretch>
+        </p:blipFill>
+        <p:spPr>
+          <a:xfrm>
+            <a:off x="457200" y="4114800"/>
+            <a:ext cx="11247120" cy="2468880"/>
+          </a:xfrm>
+          <a:prstGeom prst="rect">
+            <a:avLst/>
+          </a:prstGeom>
+        </p:spPr>
+      </p:pic>
     </p:spTree>
   </p:cSld>
   <p:clrMapOvr>
@@ -6960,7 +7391,7 @@
                   <a:srgbClr val="0B0B0B"/>
                 </a:solidFill>
               </a:rPr>
-              <a:t>What it took to build</a:t>
+              <a:t>Path to production — AWS ready today</a:t>
             </a:r>
           </a:p>
         </p:txBody>
@@ -7036,320 +7467,20 @@
                   <a:srgbClr val="52514E"/>
                 </a:solidFill>
               </a:rPr>
-              <a:t>AI-assisted engineering with review gates</a:t>
-            </a:r>
-          </a:p>
-        </p:txBody>
-      </p:sp>
-      <p:sp>
-        <p:nvSpPr>
-          <p:cNvPr id="5" name="Rounded Rectangle 4"/>
-          <p:cNvSpPr/>
-          <p:nvPr/>
-        </p:nvSpPr>
-        <p:spPr>
-          <a:xfrm>
-            <a:off x="640080" y="1920240"/>
-            <a:ext cx="2560320" cy="1828800"/>
-          </a:xfrm>
-          <a:prstGeom prst="roundRect">
-            <a:avLst/>
-          </a:prstGeom>
-          <a:solidFill>
-            <a:srgbClr val="F0EFEC"/>
-          </a:solidFill>
-          <a:ln w="12700">
-            <a:solidFill>
-              <a:srgbClr val="2A78D6"/>
-            </a:solidFill>
-          </a:ln>
-        </p:spPr>
-        <p:style>
-          <a:lnRef idx="1">
-            <a:schemeClr val="accent1"/>
-          </a:lnRef>
-          <a:fillRef idx="3">
-            <a:schemeClr val="accent1"/>
-          </a:fillRef>
-          <a:effectRef idx="2">
-            <a:schemeClr val="accent1"/>
-          </a:effectRef>
-          <a:fontRef idx="minor">
-            <a:schemeClr val="lt1"/>
-          </a:fontRef>
-        </p:style>
-        <p:txBody>
-          <a:bodyPr rtlCol="0" anchor="ctr"/>
-          <a:lstStyle/>
-          <a:p>
-            <a:pPr algn="ctr"/>
-            <a:r>
-              <a:rPr sz="3400" b="1">
-                <a:solidFill>
-                  <a:srgbClr val="2A78D6"/>
-                </a:solidFill>
-              </a:rPr>
-              <a:t>1 day</a:t>
-            </a:r>
-          </a:p>
-          <a:p>
-            <a:pPr algn="ctr"/>
-            <a:r>
-              <a:rPr sz="1300">
-                <a:solidFill>
-                  <a:srgbClr val="52514E"/>
-                </a:solidFill>
-              </a:rPr>
-              <a:t>requirements to</a:t>
-            </a:r>
-          </a:p>
-          <a:p>
-            <a:pPr algn="ctr"/>
-            <a:r>
-              <a:rPr sz="1300">
-                <a:solidFill>
-                  <a:srgbClr val="52514E"/>
-                </a:solidFill>
-              </a:rPr>
-              <a:t>load-tested system</a:t>
-            </a:r>
-          </a:p>
-        </p:txBody>
-      </p:sp>
-      <p:sp>
-        <p:nvSpPr>
-          <p:cNvPr id="6" name="Rounded Rectangle 5"/>
-          <p:cNvSpPr/>
-          <p:nvPr/>
-        </p:nvSpPr>
-        <p:spPr>
-          <a:xfrm>
-            <a:off x="3474720" y="1920240"/>
-            <a:ext cx="2560320" cy="1828800"/>
-          </a:xfrm>
-          <a:prstGeom prst="roundRect">
-            <a:avLst/>
-          </a:prstGeom>
-          <a:solidFill>
-            <a:srgbClr val="F0EFEC"/>
-          </a:solidFill>
-          <a:ln w="12700">
-            <a:solidFill>
-              <a:srgbClr val="2A78D6"/>
-            </a:solidFill>
-          </a:ln>
-        </p:spPr>
-        <p:style>
-          <a:lnRef idx="1">
-            <a:schemeClr val="accent1"/>
-          </a:lnRef>
-          <a:fillRef idx="3">
-            <a:schemeClr val="accent1"/>
-          </a:fillRef>
-          <a:effectRef idx="2">
-            <a:schemeClr val="accent1"/>
-          </a:effectRef>
-          <a:fontRef idx="minor">
-            <a:schemeClr val="lt1"/>
-          </a:fontRef>
-        </p:style>
-        <p:txBody>
-          <a:bodyPr rtlCol="0" anchor="ctr"/>
-          <a:lstStyle/>
-          <a:p>
-            <a:pPr algn="ctr"/>
-            <a:r>
-              <a:rPr sz="3400" b="1">
-                <a:solidFill>
-                  <a:srgbClr val="2A78D6"/>
-                </a:solidFill>
-              </a:rPr>
-              <a:t>8 prompts</a:t>
-            </a:r>
-          </a:p>
-          <a:p>
-            <a:pPr algn="ctr"/>
-            <a:r>
-              <a:rPr sz="1300">
-                <a:solidFill>
-                  <a:srgbClr val="52514E"/>
-                </a:solidFill>
-              </a:rPr>
-              <a:t>drove all eight</a:t>
-            </a:r>
-          </a:p>
-          <a:p>
-            <a:pPr algn="ctr"/>
-            <a:r>
-              <a:rPr sz="1300">
-                <a:solidFill>
-                  <a:srgbClr val="52514E"/>
-                </a:solidFill>
-              </a:rPr>
-              <a:t>phases of work</a:t>
-            </a:r>
-          </a:p>
-        </p:txBody>
-      </p:sp>
-      <p:sp>
-        <p:nvSpPr>
-          <p:cNvPr id="7" name="Rounded Rectangle 6"/>
-          <p:cNvSpPr/>
-          <p:nvPr/>
-        </p:nvSpPr>
-        <p:spPr>
-          <a:xfrm>
-            <a:off x="6309360" y="1920240"/>
-            <a:ext cx="2560320" cy="1828800"/>
-          </a:xfrm>
-          <a:prstGeom prst="roundRect">
-            <a:avLst/>
-          </a:prstGeom>
-          <a:solidFill>
-            <a:srgbClr val="F0EFEC"/>
-          </a:solidFill>
-          <a:ln w="12700">
-            <a:solidFill>
-              <a:srgbClr val="2A78D6"/>
-            </a:solidFill>
-          </a:ln>
-        </p:spPr>
-        <p:style>
-          <a:lnRef idx="1">
-            <a:schemeClr val="accent1"/>
-          </a:lnRef>
-          <a:fillRef idx="3">
-            <a:schemeClr val="accent1"/>
-          </a:fillRef>
-          <a:effectRef idx="2">
-            <a:schemeClr val="accent1"/>
-          </a:effectRef>
-          <a:fontRef idx="minor">
-            <a:schemeClr val="lt1"/>
-          </a:fontRef>
-        </p:style>
-        <p:txBody>
-          <a:bodyPr rtlCol="0" anchor="ctr"/>
-          <a:lstStyle/>
-          <a:p>
-            <a:pPr algn="ctr"/>
-            <a:r>
-              <a:rPr sz="3400" b="1">
-                <a:solidFill>
-                  <a:srgbClr val="2A78D6"/>
-                </a:solidFill>
-              </a:rPr>
-              <a:t>≈ $430</a:t>
-            </a:r>
-          </a:p>
-          <a:p>
-            <a:pPr algn="ctr"/>
-            <a:r>
-              <a:rPr sz="1300">
-                <a:solidFill>
-                  <a:srgbClr val="52514E"/>
-                </a:solidFill>
-              </a:rPr>
-              <a:t>metered AI compute</a:t>
-            </a:r>
-          </a:p>
-          <a:p>
-            <a:pPr algn="ctr"/>
-            <a:r>
-              <a:rPr sz="1300">
-                <a:solidFill>
-                  <a:srgbClr val="52514E"/>
-                </a:solidFill>
-              </a:rPr>
-              <a:t>(included in subscription)</a:t>
-            </a:r>
-          </a:p>
-        </p:txBody>
-      </p:sp>
-      <p:sp>
-        <p:nvSpPr>
-          <p:cNvPr id="8" name="Rounded Rectangle 7"/>
-          <p:cNvSpPr/>
-          <p:nvPr/>
-        </p:nvSpPr>
-        <p:spPr>
-          <a:xfrm>
-            <a:off x="9144000" y="1920240"/>
-            <a:ext cx="2560320" cy="1828800"/>
-          </a:xfrm>
-          <a:prstGeom prst="roundRect">
-            <a:avLst/>
-          </a:prstGeom>
-          <a:solidFill>
-            <a:srgbClr val="F0EFEC"/>
-          </a:solidFill>
-          <a:ln w="12700">
-            <a:solidFill>
-              <a:srgbClr val="2A78D6"/>
-            </a:solidFill>
-          </a:ln>
-        </p:spPr>
-        <p:style>
-          <a:lnRef idx="1">
-            <a:schemeClr val="accent1"/>
-          </a:lnRef>
-          <a:fillRef idx="3">
-            <a:schemeClr val="accent1"/>
-          </a:fillRef>
-          <a:effectRef idx="2">
-            <a:schemeClr val="accent1"/>
-          </a:effectRef>
-          <a:fontRef idx="minor">
-            <a:schemeClr val="lt1"/>
-          </a:fontRef>
-        </p:style>
-        <p:txBody>
-          <a:bodyPr rtlCol="0" anchor="ctr"/>
-          <a:lstStyle/>
-          <a:p>
-            <a:pPr algn="ctr"/>
-            <a:r>
-              <a:rPr sz="3400" b="1">
-                <a:solidFill>
-                  <a:srgbClr val="2A78D6"/>
-                </a:solidFill>
-              </a:rPr>
-              <a:t>15 finds</a:t>
-            </a:r>
-          </a:p>
-          <a:p>
-            <a:pPr algn="ctr"/>
-            <a:r>
-              <a:rPr sz="1300">
-                <a:solidFill>
-                  <a:srgbClr val="52514E"/>
-                </a:solidFill>
-              </a:rPr>
-              <a:t>6 bugs, 1 design flaw,</a:t>
-            </a:r>
-          </a:p>
-          <a:p>
-            <a:pPr algn="ctr"/>
-            <a:r>
-              <a:rPr sz="1300">
-                <a:solidFill>
-                  <a:srgbClr val="52514E"/>
-                </a:solidFill>
-              </a:rPr>
-              <a:t>8 deploy gotchas — pre-prod</a:t>
-            </a:r>
-          </a:p>
-        </p:txBody>
-      </p:sp>
-      <p:sp>
-        <p:nvSpPr>
-          <p:cNvPr id="9" name="TextBox 8"/>
+              <a:t>Full infrastructure-as-code, validated; one command to deploy</a:t>
+            </a:r>
+          </a:p>
+        </p:txBody>
+      </p:sp>
+      <p:sp>
+        <p:nvSpPr>
+          <p:cNvPr id="5" name="TextBox 4"/>
           <p:cNvSpPr txBox="1"/>
           <p:nvPr/>
         </p:nvSpPr>
         <p:spPr>
           <a:xfrm>
-            <a:off x="640080" y="4297680"/>
+            <a:off x="640080" y="1737360"/>
             <a:ext cx="10881360" cy="4754880"/>
           </a:xfrm>
           <a:prstGeom prst="rect">
@@ -7365,46 +7496,91 @@
           <a:p>
             <a:pPr>
               <a:spcAft>
-                <a:spcPts val="1000"/>
+                <a:spcPts val="1200"/>
               </a:spcAft>
             </a:pPr>
             <a:r>
-              <a:rPr sz="1700" b="1">
-                <a:solidFill>
-                  <a:srgbClr val="0B0B0B"/>
-                </a:solidFill>
-              </a:rPr>
-              <a:t>• Quality came from the process: plan first, review each outcome, make the system prove itself</a:t>
+              <a:rPr sz="1800" b="0">
+                <a:solidFill>
+                  <a:srgbClr val="0B0B0B"/>
+                </a:solidFill>
+              </a:rPr>
+              <a:t>• Terraform stack complete: MSK Serverless (Kafka) + Amazon Managed Service for Apache Flink + generator on Fargate + CloudWatch dashboard</a:t>
             </a:r>
           </a:p>
           <a:p>
             <a:pPr>
               <a:spcAft>
-                <a:spcPts val="1000"/>
+                <a:spcPts val="1200"/>
               </a:spcAft>
             </a:pPr>
             <a:r>
-              <a:rPr sz="1700" b="0">
-                <a:solidFill>
-                  <a:srgbClr val="0B0B0B"/>
-                </a:solidFill>
-              </a:rPr>
-              <a:t>• Bugs caught included the kind that bite in production: dependency clashes, silent metric mismatches, replay semantics</a:t>
+              <a:rPr sz="1800" b="1">
+                <a:solidFill>
+                  <a:srgbClr val="0B0B0B"/>
+                </a:solidFill>
+              </a:rPr>
+              <a:t>• The exact same application jar runs on AWS — every environment difference is configuration</a:t>
             </a:r>
           </a:p>
           <a:p>
             <a:pPr>
               <a:spcAft>
-                <a:spcPts val="1000"/>
+                <a:spcPts val="1200"/>
               </a:spcAft>
             </a:pPr>
             <a:r>
-              <a:rPr sz="1700" b="0">
-                <a:solidFill>
-                  <a:srgbClr val="0B0B0B"/>
-                </a:solidFill>
-              </a:rPr>
-              <a:t>• Every prompt, decision, and result is recorded in the repository — fully auditable</a:t>
+              <a:rPr sz="1800" b="0">
+                <a:solidFill>
+                  <a:srgbClr val="0B0B0B"/>
+                </a:solidFill>
+              </a:rPr>
+              <a:t>• Security by default: private VPC, IAM auth to Kafka, least-privilege roles</a:t>
+            </a:r>
+          </a:p>
+          <a:p>
+            <a:pPr>
+              <a:spcAft>
+                <a:spcPts val="1200"/>
+              </a:spcAft>
+            </a:pPr>
+            <a:r>
+              <a:rPr sz="1800" b="0">
+                <a:solidFill>
+                  <a:srgbClr val="0B0B0B"/>
+                </a:solidFill>
+              </a:rPr>
+              <a:t>• Operations runbook: deploy, in-place code update, config-only rescale, teardown</a:t>
+            </a:r>
+          </a:p>
+          <a:p>
+            <a:pPr>
+              <a:spcAft>
+                <a:spcPts val="1200"/>
+              </a:spcAft>
+            </a:pPr>
+            <a:r>
+              <a:rPr sz="1800" b="0">
+                <a:solidFill>
+                  <a:srgbClr val="0B0B0B"/>
+                </a:solidFill>
+              </a:rPr>
+              <a:t>• Demo cost ≈ $1/hour while running; destroyed when not in use</a:t>
+            </a:r>
+          </a:p>
+          <a:p>
+            <a:pPr>
+              <a:spcAft>
+                <a:spcPts val="1200"/>
+              </a:spcAft>
+            </a:pPr>
+            <a:r>
+              <a:rPr sz="1800" b="1">
+                <a:solidFill>
+                  <a:srgbClr val="008300"/>
+                </a:solidFill>
+              </a:rPr>
+              <a:t>• Status: DEPLOYED and load-tested on AWS — all cases green, scaling ladder measured, then torn down cleanly</a:t>
             </a:r>
           </a:p>
         </p:txBody>

</xml_diff>

<commit_message>
Article + deck: add the Confluent second-cloud story
Article: Sunday-epilogue section (same tests, second cloud, 232k msgs/s,
$4) + one closer line. Deck: new comparison slide (code size, correctness,
top speed, scaling model, monthly cost), refreshed stat tiles (9 prompts,
$515, 26 finds), recommendations now frame the two-cloud choice.

Co-Authored-By: Claude Fable 5 <noreply@anthropic.com>
</commit_message>
<xml_diff>
--- a/docs/flink-demo-exec-briefing.pptx
+++ b/docs/flink-demo-exec-briefing.pptx
@@ -16,6 +16,7 @@
     <p:sldId id="264" r:id="rId15"/>
     <p:sldId id="265" r:id="rId16"/>
     <p:sldId id="266" r:id="rId17"/>
+    <p:sldId id="267" r:id="rId18"/>
   </p:sldIdLst>
   <p:sldSz cx="12191695" cy="6858000" type="screen4x3"/>
   <p:notesSz cx="6858000" cy="9144000"/>
@@ -3430,7 +3431,7 @@
                   <a:srgbClr val="0B0B0B"/>
                 </a:solidFill>
               </a:rPr>
-              <a:t>What it took to build</a:t>
+              <a:t>Path to production — AWS ready today</a:t>
             </a:r>
           </a:p>
         </p:txBody>
@@ -3506,320 +3507,20 @@
                   <a:srgbClr val="52514E"/>
                 </a:solidFill>
               </a:rPr>
-              <a:t>AI-assisted engineering with review gates</a:t>
-            </a:r>
-          </a:p>
-        </p:txBody>
-      </p:sp>
-      <p:sp>
-        <p:nvSpPr>
-          <p:cNvPr id="5" name="Rounded Rectangle 4"/>
-          <p:cNvSpPr/>
-          <p:nvPr/>
-        </p:nvSpPr>
-        <p:spPr>
-          <a:xfrm>
-            <a:off x="640080" y="1920240"/>
-            <a:ext cx="2560320" cy="1828800"/>
-          </a:xfrm>
-          <a:prstGeom prst="roundRect">
-            <a:avLst/>
-          </a:prstGeom>
-          <a:solidFill>
-            <a:srgbClr val="F0EFEC"/>
-          </a:solidFill>
-          <a:ln w="12700">
-            <a:solidFill>
-              <a:srgbClr val="2A78D6"/>
-            </a:solidFill>
-          </a:ln>
-        </p:spPr>
-        <p:style>
-          <a:lnRef idx="1">
-            <a:schemeClr val="accent1"/>
-          </a:lnRef>
-          <a:fillRef idx="3">
-            <a:schemeClr val="accent1"/>
-          </a:fillRef>
-          <a:effectRef idx="2">
-            <a:schemeClr val="accent1"/>
-          </a:effectRef>
-          <a:fontRef idx="minor">
-            <a:schemeClr val="lt1"/>
-          </a:fontRef>
-        </p:style>
-        <p:txBody>
-          <a:bodyPr rtlCol="0" anchor="ctr"/>
-          <a:lstStyle/>
-          <a:p>
-            <a:pPr algn="ctr"/>
-            <a:r>
-              <a:rPr sz="3400" b="1">
-                <a:solidFill>
-                  <a:srgbClr val="2A78D6"/>
-                </a:solidFill>
-              </a:rPr>
-              <a:t>1 day</a:t>
-            </a:r>
-          </a:p>
-          <a:p>
-            <a:pPr algn="ctr"/>
-            <a:r>
-              <a:rPr sz="1300">
-                <a:solidFill>
-                  <a:srgbClr val="52514E"/>
-                </a:solidFill>
-              </a:rPr>
-              <a:t>requirements to</a:t>
-            </a:r>
-          </a:p>
-          <a:p>
-            <a:pPr algn="ctr"/>
-            <a:r>
-              <a:rPr sz="1300">
-                <a:solidFill>
-                  <a:srgbClr val="52514E"/>
-                </a:solidFill>
-              </a:rPr>
-              <a:t>load-tested system</a:t>
-            </a:r>
-          </a:p>
-        </p:txBody>
-      </p:sp>
-      <p:sp>
-        <p:nvSpPr>
-          <p:cNvPr id="6" name="Rounded Rectangle 5"/>
-          <p:cNvSpPr/>
-          <p:nvPr/>
-        </p:nvSpPr>
-        <p:spPr>
-          <a:xfrm>
-            <a:off x="3474720" y="1920240"/>
-            <a:ext cx="2560320" cy="1828800"/>
-          </a:xfrm>
-          <a:prstGeom prst="roundRect">
-            <a:avLst/>
-          </a:prstGeom>
-          <a:solidFill>
-            <a:srgbClr val="F0EFEC"/>
-          </a:solidFill>
-          <a:ln w="12700">
-            <a:solidFill>
-              <a:srgbClr val="2A78D6"/>
-            </a:solidFill>
-          </a:ln>
-        </p:spPr>
-        <p:style>
-          <a:lnRef idx="1">
-            <a:schemeClr val="accent1"/>
-          </a:lnRef>
-          <a:fillRef idx="3">
-            <a:schemeClr val="accent1"/>
-          </a:fillRef>
-          <a:effectRef idx="2">
-            <a:schemeClr val="accent1"/>
-          </a:effectRef>
-          <a:fontRef idx="minor">
-            <a:schemeClr val="lt1"/>
-          </a:fontRef>
-        </p:style>
-        <p:txBody>
-          <a:bodyPr rtlCol="0" anchor="ctr"/>
-          <a:lstStyle/>
-          <a:p>
-            <a:pPr algn="ctr"/>
-            <a:r>
-              <a:rPr sz="3400" b="1">
-                <a:solidFill>
-                  <a:srgbClr val="2A78D6"/>
-                </a:solidFill>
-              </a:rPr>
-              <a:t>8 prompts</a:t>
-            </a:r>
-          </a:p>
-          <a:p>
-            <a:pPr algn="ctr"/>
-            <a:r>
-              <a:rPr sz="1300">
-                <a:solidFill>
-                  <a:srgbClr val="52514E"/>
-                </a:solidFill>
-              </a:rPr>
-              <a:t>drove all eight</a:t>
-            </a:r>
-          </a:p>
-          <a:p>
-            <a:pPr algn="ctr"/>
-            <a:r>
-              <a:rPr sz="1300">
-                <a:solidFill>
-                  <a:srgbClr val="52514E"/>
-                </a:solidFill>
-              </a:rPr>
-              <a:t>phases of work</a:t>
-            </a:r>
-          </a:p>
-        </p:txBody>
-      </p:sp>
-      <p:sp>
-        <p:nvSpPr>
-          <p:cNvPr id="7" name="Rounded Rectangle 6"/>
-          <p:cNvSpPr/>
-          <p:nvPr/>
-        </p:nvSpPr>
-        <p:spPr>
-          <a:xfrm>
-            <a:off x="6309360" y="1920240"/>
-            <a:ext cx="2560320" cy="1828800"/>
-          </a:xfrm>
-          <a:prstGeom prst="roundRect">
-            <a:avLst/>
-          </a:prstGeom>
-          <a:solidFill>
-            <a:srgbClr val="F0EFEC"/>
-          </a:solidFill>
-          <a:ln w="12700">
-            <a:solidFill>
-              <a:srgbClr val="2A78D6"/>
-            </a:solidFill>
-          </a:ln>
-        </p:spPr>
-        <p:style>
-          <a:lnRef idx="1">
-            <a:schemeClr val="accent1"/>
-          </a:lnRef>
-          <a:fillRef idx="3">
-            <a:schemeClr val="accent1"/>
-          </a:fillRef>
-          <a:effectRef idx="2">
-            <a:schemeClr val="accent1"/>
-          </a:effectRef>
-          <a:fontRef idx="minor">
-            <a:schemeClr val="lt1"/>
-          </a:fontRef>
-        </p:style>
-        <p:txBody>
-          <a:bodyPr rtlCol="0" anchor="ctr"/>
-          <a:lstStyle/>
-          <a:p>
-            <a:pPr algn="ctr"/>
-            <a:r>
-              <a:rPr sz="3400" b="1">
-                <a:solidFill>
-                  <a:srgbClr val="2A78D6"/>
-                </a:solidFill>
-              </a:rPr>
-              <a:t>≈ $430</a:t>
-            </a:r>
-          </a:p>
-          <a:p>
-            <a:pPr algn="ctr"/>
-            <a:r>
-              <a:rPr sz="1300">
-                <a:solidFill>
-                  <a:srgbClr val="52514E"/>
-                </a:solidFill>
-              </a:rPr>
-              <a:t>metered AI compute</a:t>
-            </a:r>
-          </a:p>
-          <a:p>
-            <a:pPr algn="ctr"/>
-            <a:r>
-              <a:rPr sz="1300">
-                <a:solidFill>
-                  <a:srgbClr val="52514E"/>
-                </a:solidFill>
-              </a:rPr>
-              <a:t>(included in subscription)</a:t>
-            </a:r>
-          </a:p>
-        </p:txBody>
-      </p:sp>
-      <p:sp>
-        <p:nvSpPr>
-          <p:cNvPr id="8" name="Rounded Rectangle 7"/>
-          <p:cNvSpPr/>
-          <p:nvPr/>
-        </p:nvSpPr>
-        <p:spPr>
-          <a:xfrm>
-            <a:off x="9144000" y="1920240"/>
-            <a:ext cx="2560320" cy="1828800"/>
-          </a:xfrm>
-          <a:prstGeom prst="roundRect">
-            <a:avLst/>
-          </a:prstGeom>
-          <a:solidFill>
-            <a:srgbClr val="F0EFEC"/>
-          </a:solidFill>
-          <a:ln w="12700">
-            <a:solidFill>
-              <a:srgbClr val="2A78D6"/>
-            </a:solidFill>
-          </a:ln>
-        </p:spPr>
-        <p:style>
-          <a:lnRef idx="1">
-            <a:schemeClr val="accent1"/>
-          </a:lnRef>
-          <a:fillRef idx="3">
-            <a:schemeClr val="accent1"/>
-          </a:fillRef>
-          <a:effectRef idx="2">
-            <a:schemeClr val="accent1"/>
-          </a:effectRef>
-          <a:fontRef idx="minor">
-            <a:schemeClr val="lt1"/>
-          </a:fontRef>
-        </p:style>
-        <p:txBody>
-          <a:bodyPr rtlCol="0" anchor="ctr"/>
-          <a:lstStyle/>
-          <a:p>
-            <a:pPr algn="ctr"/>
-            <a:r>
-              <a:rPr sz="3400" b="1">
-                <a:solidFill>
-                  <a:srgbClr val="2A78D6"/>
-                </a:solidFill>
-              </a:rPr>
-              <a:t>15 finds</a:t>
-            </a:r>
-          </a:p>
-          <a:p>
-            <a:pPr algn="ctr"/>
-            <a:r>
-              <a:rPr sz="1300">
-                <a:solidFill>
-                  <a:srgbClr val="52514E"/>
-                </a:solidFill>
-              </a:rPr>
-              <a:t>6 bugs, 1 design flaw,</a:t>
-            </a:r>
-          </a:p>
-          <a:p>
-            <a:pPr algn="ctr"/>
-            <a:r>
-              <a:rPr sz="1300">
-                <a:solidFill>
-                  <a:srgbClr val="52514E"/>
-                </a:solidFill>
-              </a:rPr>
-              <a:t>8 deploy gotchas — pre-prod</a:t>
-            </a:r>
-          </a:p>
-        </p:txBody>
-      </p:sp>
-      <p:sp>
-        <p:nvSpPr>
-          <p:cNvPr id="9" name="TextBox 8"/>
+              <a:t>Full infrastructure-as-code, validated; one command to deploy</a:t>
+            </a:r>
+          </a:p>
+        </p:txBody>
+      </p:sp>
+      <p:sp>
+        <p:nvSpPr>
+          <p:cNvPr id="5" name="TextBox 4"/>
           <p:cNvSpPr txBox="1"/>
           <p:nvPr/>
         </p:nvSpPr>
         <p:spPr>
           <a:xfrm>
-            <a:off x="640080" y="4297680"/>
+            <a:off x="640080" y="1737360"/>
             <a:ext cx="10881360" cy="4754880"/>
           </a:xfrm>
           <a:prstGeom prst="rect">
@@ -3835,46 +3536,91 @@
           <a:p>
             <a:pPr>
               <a:spcAft>
-                <a:spcPts val="1000"/>
+                <a:spcPts val="1200"/>
               </a:spcAft>
             </a:pPr>
             <a:r>
-              <a:rPr sz="1700" b="1">
-                <a:solidFill>
-                  <a:srgbClr val="0B0B0B"/>
-                </a:solidFill>
-              </a:rPr>
-              <a:t>• Quality came from the process: plan first, review each outcome, make the system prove itself</a:t>
+              <a:rPr sz="1800" b="0">
+                <a:solidFill>
+                  <a:srgbClr val="0B0B0B"/>
+                </a:solidFill>
+              </a:rPr>
+              <a:t>• Terraform stack complete: MSK Serverless (Kafka) + Amazon Managed Service for Apache Flink + generator on Fargate + CloudWatch dashboard</a:t>
             </a:r>
           </a:p>
           <a:p>
             <a:pPr>
               <a:spcAft>
-                <a:spcPts val="1000"/>
+                <a:spcPts val="1200"/>
               </a:spcAft>
             </a:pPr>
             <a:r>
-              <a:rPr sz="1700" b="0">
-                <a:solidFill>
-                  <a:srgbClr val="0B0B0B"/>
-                </a:solidFill>
-              </a:rPr>
-              <a:t>• Bugs caught included the kind that bite in production: dependency clashes, silent metric mismatches, replay semantics</a:t>
+              <a:rPr sz="1800" b="1">
+                <a:solidFill>
+                  <a:srgbClr val="0B0B0B"/>
+                </a:solidFill>
+              </a:rPr>
+              <a:t>• The exact same application jar runs on AWS — every environment difference is configuration</a:t>
             </a:r>
           </a:p>
           <a:p>
             <a:pPr>
               <a:spcAft>
-                <a:spcPts val="1000"/>
+                <a:spcPts val="1200"/>
               </a:spcAft>
             </a:pPr>
             <a:r>
-              <a:rPr sz="1700" b="0">
-                <a:solidFill>
-                  <a:srgbClr val="0B0B0B"/>
-                </a:solidFill>
-              </a:rPr>
-              <a:t>• Every prompt, decision, and result is recorded in the repository — fully auditable</a:t>
+              <a:rPr sz="1800" b="0">
+                <a:solidFill>
+                  <a:srgbClr val="0B0B0B"/>
+                </a:solidFill>
+              </a:rPr>
+              <a:t>• Security by default: private VPC, IAM auth to Kafka, least-privilege roles</a:t>
+            </a:r>
+          </a:p>
+          <a:p>
+            <a:pPr>
+              <a:spcAft>
+                <a:spcPts val="1200"/>
+              </a:spcAft>
+            </a:pPr>
+            <a:r>
+              <a:rPr sz="1800" b="0">
+                <a:solidFill>
+                  <a:srgbClr val="0B0B0B"/>
+                </a:solidFill>
+              </a:rPr>
+              <a:t>• Operations runbook: deploy, in-place code update, config-only rescale, teardown</a:t>
+            </a:r>
+          </a:p>
+          <a:p>
+            <a:pPr>
+              <a:spcAft>
+                <a:spcPts val="1200"/>
+              </a:spcAft>
+            </a:pPr>
+            <a:r>
+              <a:rPr sz="1800" b="0">
+                <a:solidFill>
+                  <a:srgbClr val="0B0B0B"/>
+                </a:solidFill>
+              </a:rPr>
+              <a:t>• Demo cost ≈ $1/hour while running; destroyed when not in use</a:t>
+            </a:r>
+          </a:p>
+          <a:p>
+            <a:pPr>
+              <a:spcAft>
+                <a:spcPts val="1200"/>
+              </a:spcAft>
+            </a:pPr>
+            <a:r>
+              <a:rPr sz="1800" b="1">
+                <a:solidFill>
+                  <a:srgbClr val="008300"/>
+                </a:solidFill>
+              </a:rPr>
+              <a:t>• Status: DEPLOYED and load-tested on AWS — all cases green, scaling ladder measured, then torn down cleanly</a:t>
             </a:r>
           </a:p>
         </p:txBody>
@@ -3925,7 +3671,7 @@
                   <a:srgbClr val="0B0B0B"/>
                 </a:solidFill>
               </a:rPr>
-              <a:t>Recommendations &amp; next steps</a:t>
+              <a:t>What it took to build</a:t>
             </a:r>
           </a:p>
         </p:txBody>
@@ -3981,6 +3727,501 @@
         </p:nvSpPr>
         <p:spPr>
           <a:xfrm>
+            <a:off x="548640" y="1143000"/>
+            <a:ext cx="11064240" cy="457200"/>
+          </a:xfrm>
+          <a:prstGeom prst="rect">
+            <a:avLst/>
+          </a:prstGeom>
+          <a:noFill/>
+        </p:spPr>
+        <p:txBody>
+          <a:bodyPr wrap="square">
+            <a:spAutoFit/>
+          </a:bodyPr>
+          <a:lstStyle/>
+          <a:p>
+            <a:r>
+              <a:rPr sz="1500">
+                <a:solidFill>
+                  <a:srgbClr val="52514E"/>
+                </a:solidFill>
+              </a:rPr>
+              <a:t>AI-assisted engineering with review gates</a:t>
+            </a:r>
+          </a:p>
+        </p:txBody>
+      </p:sp>
+      <p:sp>
+        <p:nvSpPr>
+          <p:cNvPr id="5" name="Rounded Rectangle 4"/>
+          <p:cNvSpPr/>
+          <p:nvPr/>
+        </p:nvSpPr>
+        <p:spPr>
+          <a:xfrm>
+            <a:off x="640080" y="1920240"/>
+            <a:ext cx="2560320" cy="1828800"/>
+          </a:xfrm>
+          <a:prstGeom prst="roundRect">
+            <a:avLst/>
+          </a:prstGeom>
+          <a:solidFill>
+            <a:srgbClr val="F0EFEC"/>
+          </a:solidFill>
+          <a:ln w="12700">
+            <a:solidFill>
+              <a:srgbClr val="2A78D6"/>
+            </a:solidFill>
+          </a:ln>
+        </p:spPr>
+        <p:style>
+          <a:lnRef idx="1">
+            <a:schemeClr val="accent1"/>
+          </a:lnRef>
+          <a:fillRef idx="3">
+            <a:schemeClr val="accent1"/>
+          </a:fillRef>
+          <a:effectRef idx="2">
+            <a:schemeClr val="accent1"/>
+          </a:effectRef>
+          <a:fontRef idx="minor">
+            <a:schemeClr val="lt1"/>
+          </a:fontRef>
+        </p:style>
+        <p:txBody>
+          <a:bodyPr rtlCol="0" anchor="ctr"/>
+          <a:lstStyle/>
+          <a:p>
+            <a:pPr algn="ctr"/>
+            <a:r>
+              <a:rPr sz="3400" b="1">
+                <a:solidFill>
+                  <a:srgbClr val="2A78D6"/>
+                </a:solidFill>
+              </a:rPr>
+              <a:t>1 day + epilogue</a:t>
+            </a:r>
+          </a:p>
+          <a:p>
+            <a:pPr algn="ctr"/>
+            <a:r>
+              <a:rPr sz="1300">
+                <a:solidFill>
+                  <a:srgbClr val="52514E"/>
+                </a:solidFill>
+              </a:rPr>
+              <a:t>requirements to a</a:t>
+            </a:r>
+          </a:p>
+          <a:p>
+            <a:pPr algn="ctr"/>
+            <a:r>
+              <a:rPr sz="1300">
+                <a:solidFill>
+                  <a:srgbClr val="52514E"/>
+                </a:solidFill>
+              </a:rPr>
+              <a:t>two-cloud proof</a:t>
+            </a:r>
+          </a:p>
+        </p:txBody>
+      </p:sp>
+      <p:sp>
+        <p:nvSpPr>
+          <p:cNvPr id="6" name="Rounded Rectangle 5"/>
+          <p:cNvSpPr/>
+          <p:nvPr/>
+        </p:nvSpPr>
+        <p:spPr>
+          <a:xfrm>
+            <a:off x="3474720" y="1920240"/>
+            <a:ext cx="2560320" cy="1828800"/>
+          </a:xfrm>
+          <a:prstGeom prst="roundRect">
+            <a:avLst/>
+          </a:prstGeom>
+          <a:solidFill>
+            <a:srgbClr val="F0EFEC"/>
+          </a:solidFill>
+          <a:ln w="12700">
+            <a:solidFill>
+              <a:srgbClr val="2A78D6"/>
+            </a:solidFill>
+          </a:ln>
+        </p:spPr>
+        <p:style>
+          <a:lnRef idx="1">
+            <a:schemeClr val="accent1"/>
+          </a:lnRef>
+          <a:fillRef idx="3">
+            <a:schemeClr val="accent1"/>
+          </a:fillRef>
+          <a:effectRef idx="2">
+            <a:schemeClr val="accent1"/>
+          </a:effectRef>
+          <a:fontRef idx="minor">
+            <a:schemeClr val="lt1"/>
+          </a:fontRef>
+        </p:style>
+        <p:txBody>
+          <a:bodyPr rtlCol="0" anchor="ctr"/>
+          <a:lstStyle/>
+          <a:p>
+            <a:pPr algn="ctr"/>
+            <a:r>
+              <a:rPr sz="3400" b="1">
+                <a:solidFill>
+                  <a:srgbClr val="2A78D6"/>
+                </a:solidFill>
+              </a:rPr>
+              <a:t>9 prompts</a:t>
+            </a:r>
+          </a:p>
+          <a:p>
+            <a:pPr algn="ctr"/>
+            <a:r>
+              <a:rPr sz="1300">
+                <a:solidFill>
+                  <a:srgbClr val="52514E"/>
+                </a:solidFill>
+              </a:rPr>
+              <a:t>drove all nine</a:t>
+            </a:r>
+          </a:p>
+          <a:p>
+            <a:pPr algn="ctr"/>
+            <a:r>
+              <a:rPr sz="1300">
+                <a:solidFill>
+                  <a:srgbClr val="52514E"/>
+                </a:solidFill>
+              </a:rPr>
+              <a:t>phases of work</a:t>
+            </a:r>
+          </a:p>
+        </p:txBody>
+      </p:sp>
+      <p:sp>
+        <p:nvSpPr>
+          <p:cNvPr id="7" name="Rounded Rectangle 6"/>
+          <p:cNvSpPr/>
+          <p:nvPr/>
+        </p:nvSpPr>
+        <p:spPr>
+          <a:xfrm>
+            <a:off x="6309360" y="1920240"/>
+            <a:ext cx="2560320" cy="1828800"/>
+          </a:xfrm>
+          <a:prstGeom prst="roundRect">
+            <a:avLst/>
+          </a:prstGeom>
+          <a:solidFill>
+            <a:srgbClr val="F0EFEC"/>
+          </a:solidFill>
+          <a:ln w="12700">
+            <a:solidFill>
+              <a:srgbClr val="2A78D6"/>
+            </a:solidFill>
+          </a:ln>
+        </p:spPr>
+        <p:style>
+          <a:lnRef idx="1">
+            <a:schemeClr val="accent1"/>
+          </a:lnRef>
+          <a:fillRef idx="3">
+            <a:schemeClr val="accent1"/>
+          </a:fillRef>
+          <a:effectRef idx="2">
+            <a:schemeClr val="accent1"/>
+          </a:effectRef>
+          <a:fontRef idx="minor">
+            <a:schemeClr val="lt1"/>
+          </a:fontRef>
+        </p:style>
+        <p:txBody>
+          <a:bodyPr rtlCol="0" anchor="ctr"/>
+          <a:lstStyle/>
+          <a:p>
+            <a:pPr algn="ctr"/>
+            <a:r>
+              <a:rPr sz="3400" b="1">
+                <a:solidFill>
+                  <a:srgbClr val="2A78D6"/>
+                </a:solidFill>
+              </a:rPr>
+              <a:t>≈ $515</a:t>
+            </a:r>
+          </a:p>
+          <a:p>
+            <a:pPr algn="ctr"/>
+            <a:r>
+              <a:rPr sz="1300">
+                <a:solidFill>
+                  <a:srgbClr val="52514E"/>
+                </a:solidFill>
+              </a:rPr>
+              <a:t>metered AI compute</a:t>
+            </a:r>
+          </a:p>
+          <a:p>
+            <a:pPr algn="ctr"/>
+            <a:r>
+              <a:rPr sz="1300">
+                <a:solidFill>
+                  <a:srgbClr val="52514E"/>
+                </a:solidFill>
+              </a:rPr>
+              <a:t>(flat-rate in practice)</a:t>
+            </a:r>
+          </a:p>
+        </p:txBody>
+      </p:sp>
+      <p:sp>
+        <p:nvSpPr>
+          <p:cNvPr id="8" name="Rounded Rectangle 7"/>
+          <p:cNvSpPr/>
+          <p:nvPr/>
+        </p:nvSpPr>
+        <p:spPr>
+          <a:xfrm>
+            <a:off x="9144000" y="1920240"/>
+            <a:ext cx="2560320" cy="1828800"/>
+          </a:xfrm>
+          <a:prstGeom prst="roundRect">
+            <a:avLst/>
+          </a:prstGeom>
+          <a:solidFill>
+            <a:srgbClr val="F0EFEC"/>
+          </a:solidFill>
+          <a:ln w="12700">
+            <a:solidFill>
+              <a:srgbClr val="2A78D6"/>
+            </a:solidFill>
+          </a:ln>
+        </p:spPr>
+        <p:style>
+          <a:lnRef idx="1">
+            <a:schemeClr val="accent1"/>
+          </a:lnRef>
+          <a:fillRef idx="3">
+            <a:schemeClr val="accent1"/>
+          </a:fillRef>
+          <a:effectRef idx="2">
+            <a:schemeClr val="accent1"/>
+          </a:effectRef>
+          <a:fontRef idx="minor">
+            <a:schemeClr val="lt1"/>
+          </a:fontRef>
+        </p:style>
+        <p:txBody>
+          <a:bodyPr rtlCol="0" anchor="ctr"/>
+          <a:lstStyle/>
+          <a:p>
+            <a:pPr algn="ctr"/>
+            <a:r>
+              <a:rPr sz="3400" b="1">
+                <a:solidFill>
+                  <a:srgbClr val="2A78D6"/>
+                </a:solidFill>
+              </a:rPr>
+              <a:t>26 finds</a:t>
+            </a:r>
+          </a:p>
+          <a:p>
+            <a:pPr algn="ctr"/>
+            <a:r>
+              <a:rPr sz="1300">
+                <a:solidFill>
+                  <a:srgbClr val="52514E"/>
+                </a:solidFill>
+              </a:rPr>
+              <a:t>7 bugs, 1 design flaw,</a:t>
+            </a:r>
+          </a:p>
+          <a:p>
+            <a:pPr algn="ctr"/>
+            <a:r>
+              <a:rPr sz="1300">
+                <a:solidFill>
+                  <a:srgbClr val="52514E"/>
+                </a:solidFill>
+              </a:rPr>
+              <a:t>18 deploy/cleanup gotchas</a:t>
+            </a:r>
+          </a:p>
+        </p:txBody>
+      </p:sp>
+      <p:sp>
+        <p:nvSpPr>
+          <p:cNvPr id="9" name="TextBox 8"/>
+          <p:cNvSpPr txBox="1"/>
+          <p:nvPr/>
+        </p:nvSpPr>
+        <p:spPr>
+          <a:xfrm>
+            <a:off x="640080" y="4297680"/>
+            <a:ext cx="10881360" cy="4754880"/>
+          </a:xfrm>
+          <a:prstGeom prst="rect">
+            <a:avLst/>
+          </a:prstGeom>
+          <a:noFill/>
+        </p:spPr>
+        <p:txBody>
+          <a:bodyPr wrap="square">
+            <a:spAutoFit/>
+          </a:bodyPr>
+          <a:lstStyle/>
+          <a:p>
+            <a:pPr>
+              <a:spcAft>
+                <a:spcPts val="1000"/>
+              </a:spcAft>
+            </a:pPr>
+            <a:r>
+              <a:rPr sz="1700" b="1">
+                <a:solidFill>
+                  <a:srgbClr val="0B0B0B"/>
+                </a:solidFill>
+              </a:rPr>
+              <a:t>• Quality came from the process: plan first, review each outcome, make the system prove itself</a:t>
+            </a:r>
+          </a:p>
+          <a:p>
+            <a:pPr>
+              <a:spcAft>
+                <a:spcPts val="1000"/>
+              </a:spcAft>
+            </a:pPr>
+            <a:r>
+              <a:rPr sz="1700" b="0">
+                <a:solidFill>
+                  <a:srgbClr val="0B0B0B"/>
+                </a:solidFill>
+              </a:rPr>
+              <a:t>• Bugs caught included the kind that bite in production: dependency clashes, silent metric mismatches, replay semantics</a:t>
+            </a:r>
+          </a:p>
+          <a:p>
+            <a:pPr>
+              <a:spcAft>
+                <a:spcPts val="1000"/>
+              </a:spcAft>
+            </a:pPr>
+            <a:r>
+              <a:rPr sz="1700" b="0">
+                <a:solidFill>
+                  <a:srgbClr val="0B0B0B"/>
+                </a:solidFill>
+              </a:rPr>
+              <a:t>• Every prompt, decision, and result is recorded in the repository — fully auditable</a:t>
+            </a:r>
+          </a:p>
+        </p:txBody>
+      </p:sp>
+    </p:spTree>
+  </p:cSld>
+  <p:clrMapOvr>
+    <a:masterClrMapping/>
+  </p:clrMapOvr>
+</p:sld>
+</file>
+
+<file path=ppt/slides/slide12.xml><?xml version="1.0" encoding="utf-8"?>
+<p:sld xmlns:a="http://schemas.openxmlformats.org/drawingml/2006/main" xmlns:p="http://schemas.openxmlformats.org/presentationml/2006/main" xmlns:r="http://schemas.openxmlformats.org/officeDocument/2006/relationships">
+  <p:cSld>
+    <p:spTree>
+      <p:nvGrpSpPr>
+        <p:cNvPr id="1" name=""/>
+        <p:cNvGrpSpPr/>
+        <p:nvPr/>
+      </p:nvGrpSpPr>
+      <p:grpSpPr/>
+      <p:sp>
+        <p:nvSpPr>
+          <p:cNvPr id="2" name="TextBox 1"/>
+          <p:cNvSpPr txBox="1"/>
+          <p:nvPr/>
+        </p:nvSpPr>
+        <p:spPr>
+          <a:xfrm>
+            <a:off x="548640" y="320040"/>
+            <a:ext cx="11064240" cy="914400"/>
+          </a:xfrm>
+          <a:prstGeom prst="rect">
+            <a:avLst/>
+          </a:prstGeom>
+          <a:noFill/>
+        </p:spPr>
+        <p:txBody>
+          <a:bodyPr wrap="square">
+            <a:spAutoFit/>
+          </a:bodyPr>
+          <a:lstStyle/>
+          <a:p>
+            <a:r>
+              <a:rPr sz="3000" b="1">
+                <a:solidFill>
+                  <a:srgbClr val="0B0B0B"/>
+                </a:solidFill>
+              </a:rPr>
+              <a:t>Recommendations &amp; next steps</a:t>
+            </a:r>
+          </a:p>
+        </p:txBody>
+      </p:sp>
+      <p:sp>
+        <p:nvSpPr>
+          <p:cNvPr id="3" name="Rectangle 2"/>
+          <p:cNvSpPr/>
+          <p:nvPr/>
+        </p:nvSpPr>
+        <p:spPr>
+          <a:xfrm>
+            <a:off x="594360" y="1051560"/>
+            <a:ext cx="2011680" cy="50800"/>
+          </a:xfrm>
+          <a:prstGeom prst="rect">
+            <a:avLst/>
+          </a:prstGeom>
+          <a:solidFill>
+            <a:srgbClr val="2A78D6"/>
+          </a:solidFill>
+          <a:ln>
+            <a:noFill/>
+          </a:ln>
+        </p:spPr>
+        <p:style>
+          <a:lnRef idx="1">
+            <a:schemeClr val="accent1"/>
+          </a:lnRef>
+          <a:fillRef idx="3">
+            <a:schemeClr val="accent1"/>
+          </a:fillRef>
+          <a:effectRef idx="2">
+            <a:schemeClr val="accent1"/>
+          </a:effectRef>
+          <a:fontRef idx="minor">
+            <a:schemeClr val="lt1"/>
+          </a:fontRef>
+        </p:style>
+        <p:txBody>
+          <a:bodyPr rtlCol="0" anchor="ctr"/>
+          <a:lstStyle/>
+          <a:p>
+            <a:pPr algn="ctr"/>
+          </a:p>
+        </p:txBody>
+      </p:sp>
+      <p:sp>
+        <p:nvSpPr>
+          <p:cNvPr id="4" name="TextBox 3"/>
+          <p:cNvSpPr txBox="1"/>
+          <p:nvPr/>
+        </p:nvSpPr>
+        <p:spPr>
+          <a:xfrm>
             <a:off x="640080" y="1737360"/>
             <a:ext cx="10881360" cy="4754880"/>
           </a:xfrm>
@@ -4006,7 +4247,7 @@
                   <a:srgbClr val="0B0B0B"/>
                 </a:solidFill>
               </a:rPr>
-              <a:t>• Approve the AWS demo deployment (≈ $1/hour, teardown scripted) — final requirement: Grafana-backed demo on AWS</a:t>
+              <a:t>• Two validated deployment targets — choose by ops model: AWS Managed Flink (explicit control, custom metrics) vs Confluent Cloud (serverless SQL, ~25% cheaper at sustained high volume)</a:t>
             </a:r>
           </a:p>
           <a:p>
@@ -4021,7 +4262,7 @@
                   <a:srgbClr val="0B0B0B"/>
                 </a:solidFill>
               </a:rPr>
-              <a:t>• Re-run the scaling test on AWS with dedicated compute to demonstrate 4-way+ linearity</a:t>
+              <a:t>• Volume proven on both clouds: 110k msgs/sec live on AWS; 232k msgs/sec processing on Confluent</a:t>
             </a:r>
           </a:p>
           <a:p>
@@ -7391,7 +7632,7 @@
                   <a:srgbClr val="0B0B0B"/>
                 </a:solidFill>
               </a:rPr>
-              <a:t>Path to production — AWS ready today</a:t>
+              <a:t>Day two: same pipeline, second cloud</a:t>
             </a:r>
           </a:p>
         </p:txBody>
@@ -7467,20 +7708,502 @@
                   <a:srgbClr val="52514E"/>
                 </a:solidFill>
               </a:rPr>
-              <a:t>Full infrastructure-as-code, validated; one command to deploy</a:t>
-            </a:r>
-          </a:p>
-        </p:txBody>
-      </p:sp>
-      <p:sp>
-        <p:nvSpPr>
-          <p:cNvPr id="5" name="TextBox 4"/>
+              <a:t>Rewritten in Flink SQL on Confluent Cloud — judged by the same validation suite</a:t>
+            </a:r>
+          </a:p>
+        </p:txBody>
+      </p:sp>
+      <p:graphicFrame>
+        <p:nvGraphicFramePr>
+          <p:cNvPr id="5" name="Table 4"/>
+          <p:cNvGraphicFramePr>
+            <a:graphicFrameLocks noGrp="1"/>
+          </p:cNvGraphicFramePr>
+          <p:nvPr/>
+        </p:nvGraphicFramePr>
+        <p:xfrm>
+          <a:off x="640080" y="1645920"/>
+          <a:ext cx="10972800" cy="2560320"/>
+        </p:xfrm>
+        <a:graphic>
+          <a:graphicData uri="http://schemas.openxmlformats.org/drawingml/2006/table">
+            <a:tbl>
+              <a:tblPr firstRow="1" bandRow="1">
+                <a:tableStyleId>{5C22544A-7EE6-4342-B048-85BDC9FD1C3A}</a:tableStyleId>
+              </a:tblPr>
+              <a:tblGrid>
+                <a:gridCol w="4023360"/>
+                <a:gridCol w="3474720"/>
+                <a:gridCol w="3474720"/>
+              </a:tblGrid>
+              <a:tr h="365760">
+                <a:tc>
+                  <a:txBody>
+                    <a:bodyPr wrap="square"/>
+                    <a:lstStyle/>
+                    <a:p>
+                      <a:r>
+                        <a:rPr sz="1400" b="1">
+                          <a:solidFill>
+                            <a:srgbClr val="FFFFFF"/>
+                          </a:solidFill>
+                        </a:rPr>
+                        <a:t/>
+                      </a:r>
+                    </a:p>
+                  </a:txBody>
+                  <a:tcPr marT="45720" marB="45720">
+                    <a:solidFill>
+                      <a:srgbClr val="2A78D6"/>
+                    </a:solidFill>
+                  </a:tcPr>
+                </a:tc>
+                <a:tc>
+                  <a:txBody>
+                    <a:bodyPr wrap="square"/>
+                    <a:lstStyle/>
+                    <a:p>
+                      <a:r>
+                        <a:rPr sz="1400" b="1">
+                          <a:solidFill>
+                            <a:srgbClr val="FFFFFF"/>
+                          </a:solidFill>
+                        </a:rPr>
+                        <a:t>AWS (day 1)</a:t>
+                      </a:r>
+                    </a:p>
+                  </a:txBody>
+                  <a:tcPr marT="45720" marB="45720">
+                    <a:solidFill>
+                      <a:srgbClr val="2A78D6"/>
+                    </a:solidFill>
+                  </a:tcPr>
+                </a:tc>
+                <a:tc>
+                  <a:txBody>
+                    <a:bodyPr wrap="square"/>
+                    <a:lstStyle/>
+                    <a:p>
+                      <a:r>
+                        <a:rPr sz="1400" b="1">
+                          <a:solidFill>
+                            <a:srgbClr val="FFFFFF"/>
+                          </a:solidFill>
+                        </a:rPr>
+                        <a:t>Confluent Cloud (day 2)</a:t>
+                      </a:r>
+                    </a:p>
+                  </a:txBody>
+                  <a:tcPr marT="45720" marB="45720">
+                    <a:solidFill>
+                      <a:srgbClr val="2A78D6"/>
+                    </a:solidFill>
+                  </a:tcPr>
+                </a:tc>
+              </a:tr>
+              <a:tr h="365760">
+                <a:tc>
+                  <a:txBody>
+                    <a:bodyPr wrap="square"/>
+                    <a:lstStyle/>
+                    <a:p>
+                      <a:r>
+                        <a:rPr sz="1400">
+                          <a:solidFill>
+                            <a:srgbClr val="0B0B0B"/>
+                          </a:solidFill>
+                        </a:rPr>
+                        <a:t>Code</a:t>
+                      </a:r>
+                    </a:p>
+                  </a:txBody>
+                  <a:tcPr marT="45720" marB="45720">
+                    <a:solidFill>
+                      <a:srgbClr val="FFFFFF"/>
+                    </a:solidFill>
+                  </a:tcPr>
+                </a:tc>
+                <a:tc>
+                  <a:txBody>
+                    <a:bodyPr wrap="square"/>
+                    <a:lstStyle/>
+                    <a:p>
+                      <a:r>
+                        <a:rPr sz="1400">
+                          <a:solidFill>
+                            <a:srgbClr val="0B0B0B"/>
+                          </a:solidFill>
+                        </a:rPr>
+                        <a:t>~2,000 lines of Java</a:t>
+                      </a:r>
+                    </a:p>
+                  </a:txBody>
+                  <a:tcPr marT="45720" marB="45720">
+                    <a:solidFill>
+                      <a:srgbClr val="FFFFFF"/>
+                    </a:solidFill>
+                  </a:tcPr>
+                </a:tc>
+                <a:tc>
+                  <a:txBody>
+                    <a:bodyPr wrap="square"/>
+                    <a:lstStyle/>
+                    <a:p>
+                      <a:r>
+                        <a:rPr sz="1400">
+                          <a:solidFill>
+                            <a:srgbClr val="0B0B0B"/>
+                          </a:solidFill>
+                        </a:rPr>
+                        <a:t>~200 lines of SQL (6 statements)</a:t>
+                      </a:r>
+                    </a:p>
+                  </a:txBody>
+                  <a:tcPr marT="45720" marB="45720">
+                    <a:solidFill>
+                      <a:srgbClr val="FFFFFF"/>
+                    </a:solidFill>
+                  </a:tcPr>
+                </a:tc>
+              </a:tr>
+              <a:tr h="365760">
+                <a:tc>
+                  <a:txBody>
+                    <a:bodyPr wrap="square"/>
+                    <a:lstStyle/>
+                    <a:p>
+                      <a:r>
+                        <a:rPr sz="1400">
+                          <a:solidFill>
+                            <a:srgbClr val="0B0B0B"/>
+                          </a:solidFill>
+                        </a:rPr>
+                        <a:t>Correctness — 5 independent checks</a:t>
+                      </a:r>
+                    </a:p>
+                  </a:txBody>
+                  <a:tcPr marT="45720" marB="45720">
+                    <a:solidFill>
+                      <a:srgbClr val="F0EFEC"/>
+                    </a:solidFill>
+                  </a:tcPr>
+                </a:tc>
+                <a:tc>
+                  <a:txBody>
+                    <a:bodyPr wrap="square"/>
+                    <a:lstStyle/>
+                    <a:p>
+                      <a:r>
+                        <a:rPr sz="1400">
+                          <a:solidFill>
+                            <a:srgbClr val="0B0B0B"/>
+                          </a:solidFill>
+                        </a:rPr>
+                        <a:t>All pass</a:t>
+                      </a:r>
+                    </a:p>
+                  </a:txBody>
+                  <a:tcPr marT="45720" marB="45720">
+                    <a:solidFill>
+                      <a:srgbClr val="F0EFEC"/>
+                    </a:solidFill>
+                  </a:tcPr>
+                </a:tc>
+                <a:tc>
+                  <a:txBody>
+                    <a:bodyPr wrap="square"/>
+                    <a:lstStyle/>
+                    <a:p>
+                      <a:r>
+                        <a:rPr sz="1400">
+                          <a:solidFill>
+                            <a:srgbClr val="0B0B0B"/>
+                          </a:solidFill>
+                        </a:rPr>
+                        <a:t>All pass — exact to the cent</a:t>
+                      </a:r>
+                    </a:p>
+                  </a:txBody>
+                  <a:tcPr marT="45720" marB="45720">
+                    <a:solidFill>
+                      <a:srgbClr val="F0EFEC"/>
+                    </a:solidFill>
+                  </a:tcPr>
+                </a:tc>
+              </a:tr>
+              <a:tr h="365760">
+                <a:tc>
+                  <a:txBody>
+                    <a:bodyPr wrap="square"/>
+                    <a:lstStyle/>
+                    <a:p>
+                      <a:r>
+                        <a:rPr sz="1400">
+                          <a:solidFill>
+                            <a:srgbClr val="0B0B0B"/>
+                          </a:solidFill>
+                        </a:rPr>
+                        <a:t>Top speed measured</a:t>
+                      </a:r>
+                    </a:p>
+                  </a:txBody>
+                  <a:tcPr marT="45720" marB="45720">
+                    <a:solidFill>
+                      <a:srgbClr val="FFFFFF"/>
+                    </a:solidFill>
+                  </a:tcPr>
+                </a:tc>
+                <a:tc>
+                  <a:txBody>
+                    <a:bodyPr wrap="square"/>
+                    <a:lstStyle/>
+                    <a:p>
+                      <a:r>
+                        <a:rPr sz="1400">
+                          <a:solidFill>
+                            <a:srgbClr val="0B0B0B"/>
+                          </a:solidFill>
+                        </a:rPr>
+                        <a:t>110,000 msgs/sec (12 units)</a:t>
+                      </a:r>
+                    </a:p>
+                  </a:txBody>
+                  <a:tcPr marT="45720" marB="45720">
+                    <a:solidFill>
+                      <a:srgbClr val="FFFFFF"/>
+                    </a:solidFill>
+                  </a:tcPr>
+                </a:tc>
+                <a:tc>
+                  <a:txBody>
+                    <a:bodyPr wrap="square"/>
+                    <a:lstStyle/>
+                    <a:p>
+                      <a:r>
+                        <a:rPr sz="1400">
+                          <a:solidFill>
+                            <a:srgbClr val="0B0B0B"/>
+                          </a:solidFill>
+                        </a:rPr>
+                        <a:t>232,000 msgs/sec (16 units)</a:t>
+                      </a:r>
+                    </a:p>
+                  </a:txBody>
+                  <a:tcPr marT="45720" marB="45720">
+                    <a:solidFill>
+                      <a:srgbClr val="FFFFFF"/>
+                    </a:solidFill>
+                  </a:tcPr>
+                </a:tc>
+              </a:tr>
+              <a:tr h="365760">
+                <a:tc>
+                  <a:txBody>
+                    <a:bodyPr wrap="square"/>
+                    <a:lstStyle/>
+                    <a:p>
+                      <a:r>
+                        <a:rPr sz="1400">
+                          <a:solidFill>
+                            <a:srgbClr val="0B0B0B"/>
+                          </a:solidFill>
+                        </a:rPr>
+                        <a:t>How you scale</a:t>
+                      </a:r>
+                    </a:p>
+                  </a:txBody>
+                  <a:tcPr marT="45720" marB="45720">
+                    <a:solidFill>
+                      <a:srgbClr val="F0EFEC"/>
+                    </a:solidFill>
+                  </a:tcPr>
+                </a:tc>
+                <a:tc>
+                  <a:txBody>
+                    <a:bodyPr wrap="square"/>
+                    <a:lstStyle/>
+                    <a:p>
+                      <a:r>
+                        <a:rPr sz="1400">
+                          <a:solidFill>
+                            <a:srgbClr val="0B0B0B"/>
+                          </a:solidFill>
+                        </a:rPr>
+                        <a:t>Pick unit count by hand</a:t>
+                      </a:r>
+                    </a:p>
+                  </a:txBody>
+                  <a:tcPr marT="45720" marB="45720">
+                    <a:solidFill>
+                      <a:srgbClr val="F0EFEC"/>
+                    </a:solidFill>
+                  </a:tcPr>
+                </a:tc>
+                <a:tc>
+                  <a:txBody>
+                    <a:bodyPr wrap="square"/>
+                    <a:lstStyle/>
+                    <a:p>
+                      <a:r>
+                        <a:rPr sz="1400">
+                          <a:solidFill>
+                            <a:srgbClr val="0B0B0B"/>
+                          </a:solidFill>
+                        </a:rPr>
+                        <a:t>Autoscales up to a cap you set</a:t>
+                      </a:r>
+                    </a:p>
+                  </a:txBody>
+                  <a:tcPr marT="45720" marB="45720">
+                    <a:solidFill>
+                      <a:srgbClr val="F0EFEC"/>
+                    </a:solidFill>
+                  </a:tcPr>
+                </a:tc>
+              </a:tr>
+              <a:tr h="365760">
+                <a:tc>
+                  <a:txBody>
+                    <a:bodyPr wrap="square"/>
+                    <a:lstStyle/>
+                    <a:p>
+                      <a:r>
+                        <a:rPr sz="1400">
+                          <a:solidFill>
+                            <a:srgbClr val="0B0B0B"/>
+                          </a:solidFill>
+                        </a:rPr>
+                        <a:t>Est. monthly cost, normal load</a:t>
+                      </a:r>
+                    </a:p>
+                  </a:txBody>
+                  <a:tcPr marT="45720" marB="45720">
+                    <a:solidFill>
+                      <a:srgbClr val="FFFFFF"/>
+                    </a:solidFill>
+                  </a:tcPr>
+                </a:tc>
+                <a:tc>
+                  <a:txBody>
+                    <a:bodyPr wrap="square"/>
+                    <a:lstStyle/>
+                    <a:p>
+                      <a:r>
+                        <a:rPr sz="1400">
+                          <a:solidFill>
+                            <a:srgbClr val="0B0B0B"/>
+                          </a:solidFill>
+                        </a:rPr>
+                        <a:t>~ $1,070</a:t>
+                      </a:r>
+                    </a:p>
+                  </a:txBody>
+                  <a:tcPr marT="45720" marB="45720">
+                    <a:solidFill>
+                      <a:srgbClr val="FFFFFF"/>
+                    </a:solidFill>
+                  </a:tcPr>
+                </a:tc>
+                <a:tc>
+                  <a:txBody>
+                    <a:bodyPr wrap="square"/>
+                    <a:lstStyle/>
+                    <a:p>
+                      <a:r>
+                        <a:rPr sz="1400">
+                          <a:solidFill>
+                            <a:srgbClr val="0B0B0B"/>
+                          </a:solidFill>
+                        </a:rPr>
+                        <a:t>~ $1,010</a:t>
+                      </a:r>
+                    </a:p>
+                  </a:txBody>
+                  <a:tcPr marT="45720" marB="45720">
+                    <a:solidFill>
+                      <a:srgbClr val="FFFFFF"/>
+                    </a:solidFill>
+                  </a:tcPr>
+                </a:tc>
+              </a:tr>
+              <a:tr h="365760">
+                <a:tc>
+                  <a:txBody>
+                    <a:bodyPr wrap="square"/>
+                    <a:lstStyle/>
+                    <a:p>
+                      <a:r>
+                        <a:rPr sz="1400">
+                          <a:solidFill>
+                            <a:srgbClr val="0B0B0B"/>
+                          </a:solidFill>
+                        </a:rPr>
+                        <a:t>Est. monthly cost, peak volume</a:t>
+                      </a:r>
+                    </a:p>
+                  </a:txBody>
+                  <a:tcPr marT="45720" marB="45720">
+                    <a:solidFill>
+                      <a:srgbClr val="F0EFEC"/>
+                    </a:solidFill>
+                  </a:tcPr>
+                </a:tc>
+                <a:tc>
+                  <a:txBody>
+                    <a:bodyPr wrap="square"/>
+                    <a:lstStyle/>
+                    <a:p>
+                      <a:r>
+                        <a:rPr sz="1400">
+                          <a:solidFill>
+                            <a:srgbClr val="0B0B0B"/>
+                          </a:solidFill>
+                        </a:rPr>
+                        <a:t>~ $6,100</a:t>
+                      </a:r>
+                    </a:p>
+                  </a:txBody>
+                  <a:tcPr marT="45720" marB="45720">
+                    <a:solidFill>
+                      <a:srgbClr val="F0EFEC"/>
+                    </a:solidFill>
+                  </a:tcPr>
+                </a:tc>
+                <a:tc>
+                  <a:txBody>
+                    <a:bodyPr wrap="square"/>
+                    <a:lstStyle/>
+                    <a:p>
+                      <a:r>
+                        <a:rPr sz="1400">
+                          <a:solidFill>
+                            <a:srgbClr val="0B0B0B"/>
+                          </a:solidFill>
+                        </a:rPr>
+                        <a:t>~ $4,500</a:t>
+                      </a:r>
+                    </a:p>
+                  </a:txBody>
+                  <a:tcPr marT="45720" marB="45720">
+                    <a:solidFill>
+                      <a:srgbClr val="F0EFEC"/>
+                    </a:solidFill>
+                  </a:tcPr>
+                </a:tc>
+              </a:tr>
+            </a:tbl>
+          </a:graphicData>
+        </a:graphic>
+      </p:graphicFrame>
+      <p:sp>
+        <p:nvSpPr>
+          <p:cNvPr id="6" name="TextBox 5"/>
           <p:cNvSpPr txBox="1"/>
           <p:nvPr/>
         </p:nvSpPr>
         <p:spPr>
           <a:xfrm>
-            <a:off x="640080" y="1737360"/>
+            <a:off x="640080" y="5120640"/>
             <a:ext cx="10881360" cy="4754880"/>
           </a:xfrm>
           <a:prstGeom prst="rect">
@@ -7496,91 +8219,46 @@
           <a:p>
             <a:pPr>
               <a:spcAft>
-                <a:spcPts val="1200"/>
+                <a:spcPts val="1000"/>
               </a:spcAft>
             </a:pPr>
             <a:r>
-              <a:rPr sz="1800" b="0">
-                <a:solidFill>
-                  <a:srgbClr val="0B0B0B"/>
-                </a:solidFill>
-              </a:rPr>
-              <a:t>• Terraform stack complete: MSK Serverless (Kafka) + Amazon Managed Service for Apache Flink + generator on Fargate + CloudWatch dashboard</a:t>
+              <a:rPr sz="1600" b="1">
+                <a:solidFill>
+                  <a:srgbClr val="0B0B0B"/>
+                </a:solidFill>
+              </a:rPr>
+              <a:t>• Same topics, same JSON, same generator, same tests - only the engine changed</a:t>
             </a:r>
           </a:p>
           <a:p>
             <a:pPr>
               <a:spcAft>
-                <a:spcPts val="1200"/>
+                <a:spcPts val="1000"/>
               </a:spcAft>
             </a:pPr>
             <a:r>
-              <a:rPr sz="1800" b="1">
-                <a:solidFill>
-                  <a:srgbClr val="0B0B0B"/>
-                </a:solidFill>
-              </a:rPr>
-              <a:t>• The exact same application jar runs on AWS — every environment difference is configuration</a:t>
+              <a:rPr sz="1600" b="0">
+                <a:solidFill>
+                  <a:srgbClr val="0B0B0B"/>
+                </a:solidFill>
+              </a:rPr>
+              <a:t>• The validation suite re-derives every number from raw data, so proving a cross-cloud rewrite took an afternoon and ~ $4</a:t>
             </a:r>
           </a:p>
           <a:p>
             <a:pPr>
               <a:spcAft>
-                <a:spcPts val="1200"/>
+                <a:spcPts val="1000"/>
               </a:spcAft>
             </a:pPr>
             <a:r>
-              <a:rPr sz="1800" b="0">
-                <a:solidFill>
-                  <a:srgbClr val="0B0B0B"/>
-                </a:solidFill>
-              </a:rPr>
-              <a:t>• Security by default: private VPC, IAM auth to Kafka, least-privilege roles</a:t>
-            </a:r>
-          </a:p>
-          <a:p>
-            <a:pPr>
-              <a:spcAft>
-                <a:spcPts val="1200"/>
-              </a:spcAft>
-            </a:pPr>
-            <a:r>
-              <a:rPr sz="1800" b="0">
-                <a:solidFill>
-                  <a:srgbClr val="0B0B0B"/>
-                </a:solidFill>
-              </a:rPr>
-              <a:t>• Operations runbook: deploy, in-place code update, config-only rescale, teardown</a:t>
-            </a:r>
-          </a:p>
-          <a:p>
-            <a:pPr>
-              <a:spcAft>
-                <a:spcPts val="1200"/>
-              </a:spcAft>
-            </a:pPr>
-            <a:r>
-              <a:rPr sz="1800" b="0">
-                <a:solidFill>
-                  <a:srgbClr val="0B0B0B"/>
-                </a:solidFill>
-              </a:rPr>
-              <a:t>• Demo cost ≈ $1/hour while running; destroyed when not in use</a:t>
-            </a:r>
-          </a:p>
-          <a:p>
-            <a:pPr>
-              <a:spcAft>
-                <a:spcPts val="1200"/>
-              </a:spcAft>
-            </a:pPr>
-            <a:r>
-              <a:rPr sz="1800" b="1">
+              <a:rPr sz="1600" b="0">
                 <a:solidFill>
                   <a:srgbClr val="008300"/>
                 </a:solidFill>
               </a:rPr>
-              <a:t>• Status: DEPLOYED and load-tested on AWS — all cases green, scaling ladder measured, then torn down cleanly</a:t>
+              <a:t>• Price storm result reproduced: 10,000 price updates/sec in, ~10 conflated updates/sec out, trades unaffected</a:t>
             </a:r>
           </a:p>
         </p:txBody>

</xml_diff>

<commit_message>
Cost model: size Confluent to the same 110k job — ~$3,500/mo, ~40% under AWS
Review catch: the peak-volume comparison priced Confluent at its 232k/s
demo point (16 CFUs); the like-for-like 110k operating point is 10 CFUs
(measured 132.6k/s there). Article, PERF_RESULTS, deck, prompt file updated.

Co-Authored-By: Claude Fable 5 <noreply@anthropic.com>
</commit_message>
<xml_diff>
--- a/docs/flink-demo-exec-briefing.pptx
+++ b/docs/flink-demo-exec-briefing.pptx
@@ -4247,7 +4247,7 @@
                   <a:srgbClr val="0B0B0B"/>
                 </a:solidFill>
               </a:rPr>
-              <a:t>• Two validated deployment targets — choose by ops model: AWS Managed Flink (explicit control, custom metrics) vs Confluent Cloud (serverless SQL, ~25% cheaper at sustained high volume)</a:t>
+              <a:t>• Two validated deployment targets — choose by ops model: AWS Managed Flink (explicit control, custom metrics) vs Confluent Cloud (serverless SQL, ~40% cheaper at sustained high volume)</a:t>
             </a:r>
           </a:p>
           <a:p>
@@ -8138,7 +8138,7 @@
                             <a:srgbClr val="0B0B0B"/>
                           </a:solidFill>
                         </a:rPr>
-                        <a:t>Est. monthly cost, peak volume</a:t>
+                        <a:t>Est. monthly cost, same 110k msgs/sec job</a:t>
                       </a:r>
                     </a:p>
                   </a:txBody>
@@ -8180,7 +8180,7 @@
                             <a:srgbClr val="0B0B0B"/>
                           </a:solidFill>
                         </a:rPr>
-                        <a:t>~ $4,500</a:t>
+                        <a:t>~ $3,500</a:t>
                       </a:r>
                     </a:p>
                   </a:txBody>

</xml_diff>

<commit_message>
Confluent story in article, deck, and README — reviewed
LinkedIn article gains the Sunday-epilogue section (same tests, second
cloud, 232k msgs/s, cost thresholds) and a closer line. Exec deck gains
the two-cloud comparison slide, refreshed stat tiles (9 prompts, $515,
26 finds), and updated recommendations. README headline table and
Confluent section synced to the same claims. Cost framing per review:
parity under ~10k msgs/s; ~40% less sized to the same 110k job.

Co-Authored-By: Claude Fable 5 <noreply@anthropic.com>
</commit_message>
<xml_diff>
--- a/docs/flink-demo-exec-briefing.pptx
+++ b/docs/flink-demo-exec-briefing.pptx
@@ -16,6 +16,7 @@
     <p:sldId id="264" r:id="rId15"/>
     <p:sldId id="265" r:id="rId16"/>
     <p:sldId id="266" r:id="rId17"/>
+    <p:sldId id="267" r:id="rId18"/>
   </p:sldIdLst>
   <p:sldSz cx="12191695" cy="6858000" type="screen4x3"/>
   <p:notesSz cx="6858000" cy="9144000"/>
@@ -3430,7 +3431,7 @@
                   <a:srgbClr val="0B0B0B"/>
                 </a:solidFill>
               </a:rPr>
-              <a:t>What it took to build</a:t>
+              <a:t>Path to production — AWS ready today</a:t>
             </a:r>
           </a:p>
         </p:txBody>
@@ -3506,320 +3507,20 @@
                   <a:srgbClr val="52514E"/>
                 </a:solidFill>
               </a:rPr>
-              <a:t>AI-assisted engineering with review gates</a:t>
-            </a:r>
-          </a:p>
-        </p:txBody>
-      </p:sp>
-      <p:sp>
-        <p:nvSpPr>
-          <p:cNvPr id="5" name="Rounded Rectangle 4"/>
-          <p:cNvSpPr/>
-          <p:nvPr/>
-        </p:nvSpPr>
-        <p:spPr>
-          <a:xfrm>
-            <a:off x="640080" y="1920240"/>
-            <a:ext cx="2560320" cy="1828800"/>
-          </a:xfrm>
-          <a:prstGeom prst="roundRect">
-            <a:avLst/>
-          </a:prstGeom>
-          <a:solidFill>
-            <a:srgbClr val="F0EFEC"/>
-          </a:solidFill>
-          <a:ln w="12700">
-            <a:solidFill>
-              <a:srgbClr val="2A78D6"/>
-            </a:solidFill>
-          </a:ln>
-        </p:spPr>
-        <p:style>
-          <a:lnRef idx="1">
-            <a:schemeClr val="accent1"/>
-          </a:lnRef>
-          <a:fillRef idx="3">
-            <a:schemeClr val="accent1"/>
-          </a:fillRef>
-          <a:effectRef idx="2">
-            <a:schemeClr val="accent1"/>
-          </a:effectRef>
-          <a:fontRef idx="minor">
-            <a:schemeClr val="lt1"/>
-          </a:fontRef>
-        </p:style>
-        <p:txBody>
-          <a:bodyPr rtlCol="0" anchor="ctr"/>
-          <a:lstStyle/>
-          <a:p>
-            <a:pPr algn="ctr"/>
-            <a:r>
-              <a:rPr sz="3400" b="1">
-                <a:solidFill>
-                  <a:srgbClr val="2A78D6"/>
-                </a:solidFill>
-              </a:rPr>
-              <a:t>1 day</a:t>
-            </a:r>
-          </a:p>
-          <a:p>
-            <a:pPr algn="ctr"/>
-            <a:r>
-              <a:rPr sz="1300">
-                <a:solidFill>
-                  <a:srgbClr val="52514E"/>
-                </a:solidFill>
-              </a:rPr>
-              <a:t>requirements to</a:t>
-            </a:r>
-          </a:p>
-          <a:p>
-            <a:pPr algn="ctr"/>
-            <a:r>
-              <a:rPr sz="1300">
-                <a:solidFill>
-                  <a:srgbClr val="52514E"/>
-                </a:solidFill>
-              </a:rPr>
-              <a:t>load-tested system</a:t>
-            </a:r>
-          </a:p>
-        </p:txBody>
-      </p:sp>
-      <p:sp>
-        <p:nvSpPr>
-          <p:cNvPr id="6" name="Rounded Rectangle 5"/>
-          <p:cNvSpPr/>
-          <p:nvPr/>
-        </p:nvSpPr>
-        <p:spPr>
-          <a:xfrm>
-            <a:off x="3474720" y="1920240"/>
-            <a:ext cx="2560320" cy="1828800"/>
-          </a:xfrm>
-          <a:prstGeom prst="roundRect">
-            <a:avLst/>
-          </a:prstGeom>
-          <a:solidFill>
-            <a:srgbClr val="F0EFEC"/>
-          </a:solidFill>
-          <a:ln w="12700">
-            <a:solidFill>
-              <a:srgbClr val="2A78D6"/>
-            </a:solidFill>
-          </a:ln>
-        </p:spPr>
-        <p:style>
-          <a:lnRef idx="1">
-            <a:schemeClr val="accent1"/>
-          </a:lnRef>
-          <a:fillRef idx="3">
-            <a:schemeClr val="accent1"/>
-          </a:fillRef>
-          <a:effectRef idx="2">
-            <a:schemeClr val="accent1"/>
-          </a:effectRef>
-          <a:fontRef idx="minor">
-            <a:schemeClr val="lt1"/>
-          </a:fontRef>
-        </p:style>
-        <p:txBody>
-          <a:bodyPr rtlCol="0" anchor="ctr"/>
-          <a:lstStyle/>
-          <a:p>
-            <a:pPr algn="ctr"/>
-            <a:r>
-              <a:rPr sz="3400" b="1">
-                <a:solidFill>
-                  <a:srgbClr val="2A78D6"/>
-                </a:solidFill>
-              </a:rPr>
-              <a:t>8 prompts</a:t>
-            </a:r>
-          </a:p>
-          <a:p>
-            <a:pPr algn="ctr"/>
-            <a:r>
-              <a:rPr sz="1300">
-                <a:solidFill>
-                  <a:srgbClr val="52514E"/>
-                </a:solidFill>
-              </a:rPr>
-              <a:t>drove all eight</a:t>
-            </a:r>
-          </a:p>
-          <a:p>
-            <a:pPr algn="ctr"/>
-            <a:r>
-              <a:rPr sz="1300">
-                <a:solidFill>
-                  <a:srgbClr val="52514E"/>
-                </a:solidFill>
-              </a:rPr>
-              <a:t>phases of work</a:t>
-            </a:r>
-          </a:p>
-        </p:txBody>
-      </p:sp>
-      <p:sp>
-        <p:nvSpPr>
-          <p:cNvPr id="7" name="Rounded Rectangle 6"/>
-          <p:cNvSpPr/>
-          <p:nvPr/>
-        </p:nvSpPr>
-        <p:spPr>
-          <a:xfrm>
-            <a:off x="6309360" y="1920240"/>
-            <a:ext cx="2560320" cy="1828800"/>
-          </a:xfrm>
-          <a:prstGeom prst="roundRect">
-            <a:avLst/>
-          </a:prstGeom>
-          <a:solidFill>
-            <a:srgbClr val="F0EFEC"/>
-          </a:solidFill>
-          <a:ln w="12700">
-            <a:solidFill>
-              <a:srgbClr val="2A78D6"/>
-            </a:solidFill>
-          </a:ln>
-        </p:spPr>
-        <p:style>
-          <a:lnRef idx="1">
-            <a:schemeClr val="accent1"/>
-          </a:lnRef>
-          <a:fillRef idx="3">
-            <a:schemeClr val="accent1"/>
-          </a:fillRef>
-          <a:effectRef idx="2">
-            <a:schemeClr val="accent1"/>
-          </a:effectRef>
-          <a:fontRef idx="minor">
-            <a:schemeClr val="lt1"/>
-          </a:fontRef>
-        </p:style>
-        <p:txBody>
-          <a:bodyPr rtlCol="0" anchor="ctr"/>
-          <a:lstStyle/>
-          <a:p>
-            <a:pPr algn="ctr"/>
-            <a:r>
-              <a:rPr sz="3400" b="1">
-                <a:solidFill>
-                  <a:srgbClr val="2A78D6"/>
-                </a:solidFill>
-              </a:rPr>
-              <a:t>≈ $430</a:t>
-            </a:r>
-          </a:p>
-          <a:p>
-            <a:pPr algn="ctr"/>
-            <a:r>
-              <a:rPr sz="1300">
-                <a:solidFill>
-                  <a:srgbClr val="52514E"/>
-                </a:solidFill>
-              </a:rPr>
-              <a:t>metered AI compute</a:t>
-            </a:r>
-          </a:p>
-          <a:p>
-            <a:pPr algn="ctr"/>
-            <a:r>
-              <a:rPr sz="1300">
-                <a:solidFill>
-                  <a:srgbClr val="52514E"/>
-                </a:solidFill>
-              </a:rPr>
-              <a:t>(included in subscription)</a:t>
-            </a:r>
-          </a:p>
-        </p:txBody>
-      </p:sp>
-      <p:sp>
-        <p:nvSpPr>
-          <p:cNvPr id="8" name="Rounded Rectangle 7"/>
-          <p:cNvSpPr/>
-          <p:nvPr/>
-        </p:nvSpPr>
-        <p:spPr>
-          <a:xfrm>
-            <a:off x="9144000" y="1920240"/>
-            <a:ext cx="2560320" cy="1828800"/>
-          </a:xfrm>
-          <a:prstGeom prst="roundRect">
-            <a:avLst/>
-          </a:prstGeom>
-          <a:solidFill>
-            <a:srgbClr val="F0EFEC"/>
-          </a:solidFill>
-          <a:ln w="12700">
-            <a:solidFill>
-              <a:srgbClr val="2A78D6"/>
-            </a:solidFill>
-          </a:ln>
-        </p:spPr>
-        <p:style>
-          <a:lnRef idx="1">
-            <a:schemeClr val="accent1"/>
-          </a:lnRef>
-          <a:fillRef idx="3">
-            <a:schemeClr val="accent1"/>
-          </a:fillRef>
-          <a:effectRef idx="2">
-            <a:schemeClr val="accent1"/>
-          </a:effectRef>
-          <a:fontRef idx="minor">
-            <a:schemeClr val="lt1"/>
-          </a:fontRef>
-        </p:style>
-        <p:txBody>
-          <a:bodyPr rtlCol="0" anchor="ctr"/>
-          <a:lstStyle/>
-          <a:p>
-            <a:pPr algn="ctr"/>
-            <a:r>
-              <a:rPr sz="3400" b="1">
-                <a:solidFill>
-                  <a:srgbClr val="2A78D6"/>
-                </a:solidFill>
-              </a:rPr>
-              <a:t>15 finds</a:t>
-            </a:r>
-          </a:p>
-          <a:p>
-            <a:pPr algn="ctr"/>
-            <a:r>
-              <a:rPr sz="1300">
-                <a:solidFill>
-                  <a:srgbClr val="52514E"/>
-                </a:solidFill>
-              </a:rPr>
-              <a:t>6 bugs, 1 design flaw,</a:t>
-            </a:r>
-          </a:p>
-          <a:p>
-            <a:pPr algn="ctr"/>
-            <a:r>
-              <a:rPr sz="1300">
-                <a:solidFill>
-                  <a:srgbClr val="52514E"/>
-                </a:solidFill>
-              </a:rPr>
-              <a:t>8 deploy gotchas — pre-prod</a:t>
-            </a:r>
-          </a:p>
-        </p:txBody>
-      </p:sp>
-      <p:sp>
-        <p:nvSpPr>
-          <p:cNvPr id="9" name="TextBox 8"/>
+              <a:t>Full infrastructure-as-code, validated; one command to deploy</a:t>
+            </a:r>
+          </a:p>
+        </p:txBody>
+      </p:sp>
+      <p:sp>
+        <p:nvSpPr>
+          <p:cNvPr id="5" name="TextBox 4"/>
           <p:cNvSpPr txBox="1"/>
           <p:nvPr/>
         </p:nvSpPr>
         <p:spPr>
           <a:xfrm>
-            <a:off x="640080" y="4297680"/>
+            <a:off x="640080" y="1737360"/>
             <a:ext cx="10881360" cy="4754880"/>
           </a:xfrm>
           <a:prstGeom prst="rect">
@@ -3835,46 +3536,91 @@
           <a:p>
             <a:pPr>
               <a:spcAft>
-                <a:spcPts val="1000"/>
+                <a:spcPts val="1200"/>
               </a:spcAft>
             </a:pPr>
             <a:r>
-              <a:rPr sz="1700" b="1">
-                <a:solidFill>
-                  <a:srgbClr val="0B0B0B"/>
-                </a:solidFill>
-              </a:rPr>
-              <a:t>• Quality came from the process: plan first, review each outcome, make the system prove itself</a:t>
+              <a:rPr sz="1800" b="0">
+                <a:solidFill>
+                  <a:srgbClr val="0B0B0B"/>
+                </a:solidFill>
+              </a:rPr>
+              <a:t>• Terraform stack complete: MSK Serverless (Kafka) + Amazon Managed Service for Apache Flink + generator on Fargate + CloudWatch dashboard</a:t>
             </a:r>
           </a:p>
           <a:p>
             <a:pPr>
               <a:spcAft>
-                <a:spcPts val="1000"/>
+                <a:spcPts val="1200"/>
               </a:spcAft>
             </a:pPr>
             <a:r>
-              <a:rPr sz="1700" b="0">
-                <a:solidFill>
-                  <a:srgbClr val="0B0B0B"/>
-                </a:solidFill>
-              </a:rPr>
-              <a:t>• Bugs caught included the kind that bite in production: dependency clashes, silent metric mismatches, replay semantics</a:t>
+              <a:rPr sz="1800" b="1">
+                <a:solidFill>
+                  <a:srgbClr val="0B0B0B"/>
+                </a:solidFill>
+              </a:rPr>
+              <a:t>• The exact same application jar runs on AWS — every environment difference is configuration</a:t>
             </a:r>
           </a:p>
           <a:p>
             <a:pPr>
               <a:spcAft>
-                <a:spcPts val="1000"/>
+                <a:spcPts val="1200"/>
               </a:spcAft>
             </a:pPr>
             <a:r>
-              <a:rPr sz="1700" b="0">
-                <a:solidFill>
-                  <a:srgbClr val="0B0B0B"/>
-                </a:solidFill>
-              </a:rPr>
-              <a:t>• Every prompt, decision, and result is recorded in the repository — fully auditable</a:t>
+              <a:rPr sz="1800" b="0">
+                <a:solidFill>
+                  <a:srgbClr val="0B0B0B"/>
+                </a:solidFill>
+              </a:rPr>
+              <a:t>• Security by default: private VPC, IAM auth to Kafka, least-privilege roles</a:t>
+            </a:r>
+          </a:p>
+          <a:p>
+            <a:pPr>
+              <a:spcAft>
+                <a:spcPts val="1200"/>
+              </a:spcAft>
+            </a:pPr>
+            <a:r>
+              <a:rPr sz="1800" b="0">
+                <a:solidFill>
+                  <a:srgbClr val="0B0B0B"/>
+                </a:solidFill>
+              </a:rPr>
+              <a:t>• Operations runbook: deploy, in-place code update, config-only rescale, teardown</a:t>
+            </a:r>
+          </a:p>
+          <a:p>
+            <a:pPr>
+              <a:spcAft>
+                <a:spcPts val="1200"/>
+              </a:spcAft>
+            </a:pPr>
+            <a:r>
+              <a:rPr sz="1800" b="0">
+                <a:solidFill>
+                  <a:srgbClr val="0B0B0B"/>
+                </a:solidFill>
+              </a:rPr>
+              <a:t>• Demo cost ≈ $1/hour while running; destroyed when not in use</a:t>
+            </a:r>
+          </a:p>
+          <a:p>
+            <a:pPr>
+              <a:spcAft>
+                <a:spcPts val="1200"/>
+              </a:spcAft>
+            </a:pPr>
+            <a:r>
+              <a:rPr sz="1800" b="1">
+                <a:solidFill>
+                  <a:srgbClr val="008300"/>
+                </a:solidFill>
+              </a:rPr>
+              <a:t>• Status: DEPLOYED and load-tested on AWS — all cases green, scaling ladder measured, then torn down cleanly</a:t>
             </a:r>
           </a:p>
         </p:txBody>
@@ -3925,7 +3671,7 @@
                   <a:srgbClr val="0B0B0B"/>
                 </a:solidFill>
               </a:rPr>
-              <a:t>Recommendations &amp; next steps</a:t>
+              <a:t>What it took to build</a:t>
             </a:r>
           </a:p>
         </p:txBody>
@@ -3981,6 +3727,501 @@
         </p:nvSpPr>
         <p:spPr>
           <a:xfrm>
+            <a:off x="548640" y="1143000"/>
+            <a:ext cx="11064240" cy="457200"/>
+          </a:xfrm>
+          <a:prstGeom prst="rect">
+            <a:avLst/>
+          </a:prstGeom>
+          <a:noFill/>
+        </p:spPr>
+        <p:txBody>
+          <a:bodyPr wrap="square">
+            <a:spAutoFit/>
+          </a:bodyPr>
+          <a:lstStyle/>
+          <a:p>
+            <a:r>
+              <a:rPr sz="1500">
+                <a:solidFill>
+                  <a:srgbClr val="52514E"/>
+                </a:solidFill>
+              </a:rPr>
+              <a:t>AI-assisted engineering with review gates</a:t>
+            </a:r>
+          </a:p>
+        </p:txBody>
+      </p:sp>
+      <p:sp>
+        <p:nvSpPr>
+          <p:cNvPr id="5" name="Rounded Rectangle 4"/>
+          <p:cNvSpPr/>
+          <p:nvPr/>
+        </p:nvSpPr>
+        <p:spPr>
+          <a:xfrm>
+            <a:off x="640080" y="1920240"/>
+            <a:ext cx="2560320" cy="1828800"/>
+          </a:xfrm>
+          <a:prstGeom prst="roundRect">
+            <a:avLst/>
+          </a:prstGeom>
+          <a:solidFill>
+            <a:srgbClr val="F0EFEC"/>
+          </a:solidFill>
+          <a:ln w="12700">
+            <a:solidFill>
+              <a:srgbClr val="2A78D6"/>
+            </a:solidFill>
+          </a:ln>
+        </p:spPr>
+        <p:style>
+          <a:lnRef idx="1">
+            <a:schemeClr val="accent1"/>
+          </a:lnRef>
+          <a:fillRef idx="3">
+            <a:schemeClr val="accent1"/>
+          </a:fillRef>
+          <a:effectRef idx="2">
+            <a:schemeClr val="accent1"/>
+          </a:effectRef>
+          <a:fontRef idx="minor">
+            <a:schemeClr val="lt1"/>
+          </a:fontRef>
+        </p:style>
+        <p:txBody>
+          <a:bodyPr rtlCol="0" anchor="ctr"/>
+          <a:lstStyle/>
+          <a:p>
+            <a:pPr algn="ctr"/>
+            <a:r>
+              <a:rPr sz="3400" b="1">
+                <a:solidFill>
+                  <a:srgbClr val="2A78D6"/>
+                </a:solidFill>
+              </a:rPr>
+              <a:t>1 day + epilogue</a:t>
+            </a:r>
+          </a:p>
+          <a:p>
+            <a:pPr algn="ctr"/>
+            <a:r>
+              <a:rPr sz="1300">
+                <a:solidFill>
+                  <a:srgbClr val="52514E"/>
+                </a:solidFill>
+              </a:rPr>
+              <a:t>requirements to a</a:t>
+            </a:r>
+          </a:p>
+          <a:p>
+            <a:pPr algn="ctr"/>
+            <a:r>
+              <a:rPr sz="1300">
+                <a:solidFill>
+                  <a:srgbClr val="52514E"/>
+                </a:solidFill>
+              </a:rPr>
+              <a:t>two-cloud proof</a:t>
+            </a:r>
+          </a:p>
+        </p:txBody>
+      </p:sp>
+      <p:sp>
+        <p:nvSpPr>
+          <p:cNvPr id="6" name="Rounded Rectangle 5"/>
+          <p:cNvSpPr/>
+          <p:nvPr/>
+        </p:nvSpPr>
+        <p:spPr>
+          <a:xfrm>
+            <a:off x="3474720" y="1920240"/>
+            <a:ext cx="2560320" cy="1828800"/>
+          </a:xfrm>
+          <a:prstGeom prst="roundRect">
+            <a:avLst/>
+          </a:prstGeom>
+          <a:solidFill>
+            <a:srgbClr val="F0EFEC"/>
+          </a:solidFill>
+          <a:ln w="12700">
+            <a:solidFill>
+              <a:srgbClr val="2A78D6"/>
+            </a:solidFill>
+          </a:ln>
+        </p:spPr>
+        <p:style>
+          <a:lnRef idx="1">
+            <a:schemeClr val="accent1"/>
+          </a:lnRef>
+          <a:fillRef idx="3">
+            <a:schemeClr val="accent1"/>
+          </a:fillRef>
+          <a:effectRef idx="2">
+            <a:schemeClr val="accent1"/>
+          </a:effectRef>
+          <a:fontRef idx="minor">
+            <a:schemeClr val="lt1"/>
+          </a:fontRef>
+        </p:style>
+        <p:txBody>
+          <a:bodyPr rtlCol="0" anchor="ctr"/>
+          <a:lstStyle/>
+          <a:p>
+            <a:pPr algn="ctr"/>
+            <a:r>
+              <a:rPr sz="3400" b="1">
+                <a:solidFill>
+                  <a:srgbClr val="2A78D6"/>
+                </a:solidFill>
+              </a:rPr>
+              <a:t>9 prompts</a:t>
+            </a:r>
+          </a:p>
+          <a:p>
+            <a:pPr algn="ctr"/>
+            <a:r>
+              <a:rPr sz="1300">
+                <a:solidFill>
+                  <a:srgbClr val="52514E"/>
+                </a:solidFill>
+              </a:rPr>
+              <a:t>drove all nine</a:t>
+            </a:r>
+          </a:p>
+          <a:p>
+            <a:pPr algn="ctr"/>
+            <a:r>
+              <a:rPr sz="1300">
+                <a:solidFill>
+                  <a:srgbClr val="52514E"/>
+                </a:solidFill>
+              </a:rPr>
+              <a:t>phases of work</a:t>
+            </a:r>
+          </a:p>
+        </p:txBody>
+      </p:sp>
+      <p:sp>
+        <p:nvSpPr>
+          <p:cNvPr id="7" name="Rounded Rectangle 6"/>
+          <p:cNvSpPr/>
+          <p:nvPr/>
+        </p:nvSpPr>
+        <p:spPr>
+          <a:xfrm>
+            <a:off x="6309360" y="1920240"/>
+            <a:ext cx="2560320" cy="1828800"/>
+          </a:xfrm>
+          <a:prstGeom prst="roundRect">
+            <a:avLst/>
+          </a:prstGeom>
+          <a:solidFill>
+            <a:srgbClr val="F0EFEC"/>
+          </a:solidFill>
+          <a:ln w="12700">
+            <a:solidFill>
+              <a:srgbClr val="2A78D6"/>
+            </a:solidFill>
+          </a:ln>
+        </p:spPr>
+        <p:style>
+          <a:lnRef idx="1">
+            <a:schemeClr val="accent1"/>
+          </a:lnRef>
+          <a:fillRef idx="3">
+            <a:schemeClr val="accent1"/>
+          </a:fillRef>
+          <a:effectRef idx="2">
+            <a:schemeClr val="accent1"/>
+          </a:effectRef>
+          <a:fontRef idx="minor">
+            <a:schemeClr val="lt1"/>
+          </a:fontRef>
+        </p:style>
+        <p:txBody>
+          <a:bodyPr rtlCol="0" anchor="ctr"/>
+          <a:lstStyle/>
+          <a:p>
+            <a:pPr algn="ctr"/>
+            <a:r>
+              <a:rPr sz="3400" b="1">
+                <a:solidFill>
+                  <a:srgbClr val="2A78D6"/>
+                </a:solidFill>
+              </a:rPr>
+              <a:t>≈ $515</a:t>
+            </a:r>
+          </a:p>
+          <a:p>
+            <a:pPr algn="ctr"/>
+            <a:r>
+              <a:rPr sz="1300">
+                <a:solidFill>
+                  <a:srgbClr val="52514E"/>
+                </a:solidFill>
+              </a:rPr>
+              <a:t>metered AI compute</a:t>
+            </a:r>
+          </a:p>
+          <a:p>
+            <a:pPr algn="ctr"/>
+            <a:r>
+              <a:rPr sz="1300">
+                <a:solidFill>
+                  <a:srgbClr val="52514E"/>
+                </a:solidFill>
+              </a:rPr>
+              <a:t>(flat-rate in practice)</a:t>
+            </a:r>
+          </a:p>
+        </p:txBody>
+      </p:sp>
+      <p:sp>
+        <p:nvSpPr>
+          <p:cNvPr id="8" name="Rounded Rectangle 7"/>
+          <p:cNvSpPr/>
+          <p:nvPr/>
+        </p:nvSpPr>
+        <p:spPr>
+          <a:xfrm>
+            <a:off x="9144000" y="1920240"/>
+            <a:ext cx="2560320" cy="1828800"/>
+          </a:xfrm>
+          <a:prstGeom prst="roundRect">
+            <a:avLst/>
+          </a:prstGeom>
+          <a:solidFill>
+            <a:srgbClr val="F0EFEC"/>
+          </a:solidFill>
+          <a:ln w="12700">
+            <a:solidFill>
+              <a:srgbClr val="2A78D6"/>
+            </a:solidFill>
+          </a:ln>
+        </p:spPr>
+        <p:style>
+          <a:lnRef idx="1">
+            <a:schemeClr val="accent1"/>
+          </a:lnRef>
+          <a:fillRef idx="3">
+            <a:schemeClr val="accent1"/>
+          </a:fillRef>
+          <a:effectRef idx="2">
+            <a:schemeClr val="accent1"/>
+          </a:effectRef>
+          <a:fontRef idx="minor">
+            <a:schemeClr val="lt1"/>
+          </a:fontRef>
+        </p:style>
+        <p:txBody>
+          <a:bodyPr rtlCol="0" anchor="ctr"/>
+          <a:lstStyle/>
+          <a:p>
+            <a:pPr algn="ctr"/>
+            <a:r>
+              <a:rPr sz="3400" b="1">
+                <a:solidFill>
+                  <a:srgbClr val="2A78D6"/>
+                </a:solidFill>
+              </a:rPr>
+              <a:t>26 finds</a:t>
+            </a:r>
+          </a:p>
+          <a:p>
+            <a:pPr algn="ctr"/>
+            <a:r>
+              <a:rPr sz="1300">
+                <a:solidFill>
+                  <a:srgbClr val="52514E"/>
+                </a:solidFill>
+              </a:rPr>
+              <a:t>7 bugs, 1 design flaw,</a:t>
+            </a:r>
+          </a:p>
+          <a:p>
+            <a:pPr algn="ctr"/>
+            <a:r>
+              <a:rPr sz="1300">
+                <a:solidFill>
+                  <a:srgbClr val="52514E"/>
+                </a:solidFill>
+              </a:rPr>
+              <a:t>18 deploy/cleanup gotchas</a:t>
+            </a:r>
+          </a:p>
+        </p:txBody>
+      </p:sp>
+      <p:sp>
+        <p:nvSpPr>
+          <p:cNvPr id="9" name="TextBox 8"/>
+          <p:cNvSpPr txBox="1"/>
+          <p:nvPr/>
+        </p:nvSpPr>
+        <p:spPr>
+          <a:xfrm>
+            <a:off x="640080" y="4297680"/>
+            <a:ext cx="10881360" cy="4754880"/>
+          </a:xfrm>
+          <a:prstGeom prst="rect">
+            <a:avLst/>
+          </a:prstGeom>
+          <a:noFill/>
+        </p:spPr>
+        <p:txBody>
+          <a:bodyPr wrap="square">
+            <a:spAutoFit/>
+          </a:bodyPr>
+          <a:lstStyle/>
+          <a:p>
+            <a:pPr>
+              <a:spcAft>
+                <a:spcPts val="1000"/>
+              </a:spcAft>
+            </a:pPr>
+            <a:r>
+              <a:rPr sz="1700" b="1">
+                <a:solidFill>
+                  <a:srgbClr val="0B0B0B"/>
+                </a:solidFill>
+              </a:rPr>
+              <a:t>• Quality came from the process: plan first, review each outcome, make the system prove itself</a:t>
+            </a:r>
+          </a:p>
+          <a:p>
+            <a:pPr>
+              <a:spcAft>
+                <a:spcPts val="1000"/>
+              </a:spcAft>
+            </a:pPr>
+            <a:r>
+              <a:rPr sz="1700" b="0">
+                <a:solidFill>
+                  <a:srgbClr val="0B0B0B"/>
+                </a:solidFill>
+              </a:rPr>
+              <a:t>• Bugs caught included the kind that bite in production: dependency clashes, silent metric mismatches, replay semantics</a:t>
+            </a:r>
+          </a:p>
+          <a:p>
+            <a:pPr>
+              <a:spcAft>
+                <a:spcPts val="1000"/>
+              </a:spcAft>
+            </a:pPr>
+            <a:r>
+              <a:rPr sz="1700" b="0">
+                <a:solidFill>
+                  <a:srgbClr val="0B0B0B"/>
+                </a:solidFill>
+              </a:rPr>
+              <a:t>• Every prompt, decision, and result is recorded in the repository — fully auditable</a:t>
+            </a:r>
+          </a:p>
+        </p:txBody>
+      </p:sp>
+    </p:spTree>
+  </p:cSld>
+  <p:clrMapOvr>
+    <a:masterClrMapping/>
+  </p:clrMapOvr>
+</p:sld>
+</file>
+
+<file path=ppt/slides/slide12.xml><?xml version="1.0" encoding="utf-8"?>
+<p:sld xmlns:a="http://schemas.openxmlformats.org/drawingml/2006/main" xmlns:p="http://schemas.openxmlformats.org/presentationml/2006/main" xmlns:r="http://schemas.openxmlformats.org/officeDocument/2006/relationships">
+  <p:cSld>
+    <p:spTree>
+      <p:nvGrpSpPr>
+        <p:cNvPr id="1" name=""/>
+        <p:cNvGrpSpPr/>
+        <p:nvPr/>
+      </p:nvGrpSpPr>
+      <p:grpSpPr/>
+      <p:sp>
+        <p:nvSpPr>
+          <p:cNvPr id="2" name="TextBox 1"/>
+          <p:cNvSpPr txBox="1"/>
+          <p:nvPr/>
+        </p:nvSpPr>
+        <p:spPr>
+          <a:xfrm>
+            <a:off x="548640" y="320040"/>
+            <a:ext cx="11064240" cy="914400"/>
+          </a:xfrm>
+          <a:prstGeom prst="rect">
+            <a:avLst/>
+          </a:prstGeom>
+          <a:noFill/>
+        </p:spPr>
+        <p:txBody>
+          <a:bodyPr wrap="square">
+            <a:spAutoFit/>
+          </a:bodyPr>
+          <a:lstStyle/>
+          <a:p>
+            <a:r>
+              <a:rPr sz="3000" b="1">
+                <a:solidFill>
+                  <a:srgbClr val="0B0B0B"/>
+                </a:solidFill>
+              </a:rPr>
+              <a:t>Recommendations &amp; next steps</a:t>
+            </a:r>
+          </a:p>
+        </p:txBody>
+      </p:sp>
+      <p:sp>
+        <p:nvSpPr>
+          <p:cNvPr id="3" name="Rectangle 2"/>
+          <p:cNvSpPr/>
+          <p:nvPr/>
+        </p:nvSpPr>
+        <p:spPr>
+          <a:xfrm>
+            <a:off x="594360" y="1051560"/>
+            <a:ext cx="2011680" cy="50800"/>
+          </a:xfrm>
+          <a:prstGeom prst="rect">
+            <a:avLst/>
+          </a:prstGeom>
+          <a:solidFill>
+            <a:srgbClr val="2A78D6"/>
+          </a:solidFill>
+          <a:ln>
+            <a:noFill/>
+          </a:ln>
+        </p:spPr>
+        <p:style>
+          <a:lnRef idx="1">
+            <a:schemeClr val="accent1"/>
+          </a:lnRef>
+          <a:fillRef idx="3">
+            <a:schemeClr val="accent1"/>
+          </a:fillRef>
+          <a:effectRef idx="2">
+            <a:schemeClr val="accent1"/>
+          </a:effectRef>
+          <a:fontRef idx="minor">
+            <a:schemeClr val="lt1"/>
+          </a:fontRef>
+        </p:style>
+        <p:txBody>
+          <a:bodyPr rtlCol="0" anchor="ctr"/>
+          <a:lstStyle/>
+          <a:p>
+            <a:pPr algn="ctr"/>
+          </a:p>
+        </p:txBody>
+      </p:sp>
+      <p:sp>
+        <p:nvSpPr>
+          <p:cNvPr id="4" name="TextBox 3"/>
+          <p:cNvSpPr txBox="1"/>
+          <p:nvPr/>
+        </p:nvSpPr>
+        <p:spPr>
+          <a:xfrm>
             <a:off x="640080" y="1737360"/>
             <a:ext cx="10881360" cy="4754880"/>
           </a:xfrm>
@@ -4006,7 +4247,7 @@
                   <a:srgbClr val="0B0B0B"/>
                 </a:solidFill>
               </a:rPr>
-              <a:t>• Approve the AWS demo deployment (≈ $1/hour, teardown scripted) — final requirement: Grafana-backed demo on AWS</a:t>
+              <a:t>• Two validated deployment targets — choose by ops model: AWS Managed Flink (explicit control, custom metrics) vs Confluent Cloud (serverless SQL, ~40% cheaper at sustained high volume)</a:t>
             </a:r>
           </a:p>
           <a:p>
@@ -4021,7 +4262,7 @@
                   <a:srgbClr val="0B0B0B"/>
                 </a:solidFill>
               </a:rPr>
-              <a:t>• Re-run the scaling test on AWS with dedicated compute to demonstrate 4-way+ linearity</a:t>
+              <a:t>• Volume proven on both clouds: 110k msgs/sec live on AWS; 232k msgs/sec processing on Confluent</a:t>
             </a:r>
           </a:p>
           <a:p>
@@ -7391,7 +7632,7 @@
                   <a:srgbClr val="0B0B0B"/>
                 </a:solidFill>
               </a:rPr>
-              <a:t>Path to production — AWS ready today</a:t>
+              <a:t>Day two: same pipeline, second cloud</a:t>
             </a:r>
           </a:p>
         </p:txBody>
@@ -7467,20 +7708,502 @@
                   <a:srgbClr val="52514E"/>
                 </a:solidFill>
               </a:rPr>
-              <a:t>Full infrastructure-as-code, validated; one command to deploy</a:t>
-            </a:r>
-          </a:p>
-        </p:txBody>
-      </p:sp>
-      <p:sp>
-        <p:nvSpPr>
-          <p:cNvPr id="5" name="TextBox 4"/>
+              <a:t>Rewritten in Flink SQL on Confluent Cloud — judged by the same validation suite</a:t>
+            </a:r>
+          </a:p>
+        </p:txBody>
+      </p:sp>
+      <p:graphicFrame>
+        <p:nvGraphicFramePr>
+          <p:cNvPr id="5" name="Table 4"/>
+          <p:cNvGraphicFramePr>
+            <a:graphicFrameLocks noGrp="1"/>
+          </p:cNvGraphicFramePr>
+          <p:nvPr/>
+        </p:nvGraphicFramePr>
+        <p:xfrm>
+          <a:off x="640080" y="1645920"/>
+          <a:ext cx="10972800" cy="2560320"/>
+        </p:xfrm>
+        <a:graphic>
+          <a:graphicData uri="http://schemas.openxmlformats.org/drawingml/2006/table">
+            <a:tbl>
+              <a:tblPr firstRow="1" bandRow="1">
+                <a:tableStyleId>{5C22544A-7EE6-4342-B048-85BDC9FD1C3A}</a:tableStyleId>
+              </a:tblPr>
+              <a:tblGrid>
+                <a:gridCol w="4023360"/>
+                <a:gridCol w="3474720"/>
+                <a:gridCol w="3474720"/>
+              </a:tblGrid>
+              <a:tr h="365760">
+                <a:tc>
+                  <a:txBody>
+                    <a:bodyPr wrap="square"/>
+                    <a:lstStyle/>
+                    <a:p>
+                      <a:r>
+                        <a:rPr sz="1400" b="1">
+                          <a:solidFill>
+                            <a:srgbClr val="FFFFFF"/>
+                          </a:solidFill>
+                        </a:rPr>
+                        <a:t/>
+                      </a:r>
+                    </a:p>
+                  </a:txBody>
+                  <a:tcPr marT="45720" marB="45720">
+                    <a:solidFill>
+                      <a:srgbClr val="2A78D6"/>
+                    </a:solidFill>
+                  </a:tcPr>
+                </a:tc>
+                <a:tc>
+                  <a:txBody>
+                    <a:bodyPr wrap="square"/>
+                    <a:lstStyle/>
+                    <a:p>
+                      <a:r>
+                        <a:rPr sz="1400" b="1">
+                          <a:solidFill>
+                            <a:srgbClr val="FFFFFF"/>
+                          </a:solidFill>
+                        </a:rPr>
+                        <a:t>AWS (day 1)</a:t>
+                      </a:r>
+                    </a:p>
+                  </a:txBody>
+                  <a:tcPr marT="45720" marB="45720">
+                    <a:solidFill>
+                      <a:srgbClr val="2A78D6"/>
+                    </a:solidFill>
+                  </a:tcPr>
+                </a:tc>
+                <a:tc>
+                  <a:txBody>
+                    <a:bodyPr wrap="square"/>
+                    <a:lstStyle/>
+                    <a:p>
+                      <a:r>
+                        <a:rPr sz="1400" b="1">
+                          <a:solidFill>
+                            <a:srgbClr val="FFFFFF"/>
+                          </a:solidFill>
+                        </a:rPr>
+                        <a:t>Confluent Cloud (day 2)</a:t>
+                      </a:r>
+                    </a:p>
+                  </a:txBody>
+                  <a:tcPr marT="45720" marB="45720">
+                    <a:solidFill>
+                      <a:srgbClr val="2A78D6"/>
+                    </a:solidFill>
+                  </a:tcPr>
+                </a:tc>
+              </a:tr>
+              <a:tr h="365760">
+                <a:tc>
+                  <a:txBody>
+                    <a:bodyPr wrap="square"/>
+                    <a:lstStyle/>
+                    <a:p>
+                      <a:r>
+                        <a:rPr sz="1400">
+                          <a:solidFill>
+                            <a:srgbClr val="0B0B0B"/>
+                          </a:solidFill>
+                        </a:rPr>
+                        <a:t>Code</a:t>
+                      </a:r>
+                    </a:p>
+                  </a:txBody>
+                  <a:tcPr marT="45720" marB="45720">
+                    <a:solidFill>
+                      <a:srgbClr val="FFFFFF"/>
+                    </a:solidFill>
+                  </a:tcPr>
+                </a:tc>
+                <a:tc>
+                  <a:txBody>
+                    <a:bodyPr wrap="square"/>
+                    <a:lstStyle/>
+                    <a:p>
+                      <a:r>
+                        <a:rPr sz="1400">
+                          <a:solidFill>
+                            <a:srgbClr val="0B0B0B"/>
+                          </a:solidFill>
+                        </a:rPr>
+                        <a:t>~2,000 lines of Java</a:t>
+                      </a:r>
+                    </a:p>
+                  </a:txBody>
+                  <a:tcPr marT="45720" marB="45720">
+                    <a:solidFill>
+                      <a:srgbClr val="FFFFFF"/>
+                    </a:solidFill>
+                  </a:tcPr>
+                </a:tc>
+                <a:tc>
+                  <a:txBody>
+                    <a:bodyPr wrap="square"/>
+                    <a:lstStyle/>
+                    <a:p>
+                      <a:r>
+                        <a:rPr sz="1400">
+                          <a:solidFill>
+                            <a:srgbClr val="0B0B0B"/>
+                          </a:solidFill>
+                        </a:rPr>
+                        <a:t>~200 lines of SQL (6 statements)</a:t>
+                      </a:r>
+                    </a:p>
+                  </a:txBody>
+                  <a:tcPr marT="45720" marB="45720">
+                    <a:solidFill>
+                      <a:srgbClr val="FFFFFF"/>
+                    </a:solidFill>
+                  </a:tcPr>
+                </a:tc>
+              </a:tr>
+              <a:tr h="365760">
+                <a:tc>
+                  <a:txBody>
+                    <a:bodyPr wrap="square"/>
+                    <a:lstStyle/>
+                    <a:p>
+                      <a:r>
+                        <a:rPr sz="1400">
+                          <a:solidFill>
+                            <a:srgbClr val="0B0B0B"/>
+                          </a:solidFill>
+                        </a:rPr>
+                        <a:t>Correctness — 5 independent checks</a:t>
+                      </a:r>
+                    </a:p>
+                  </a:txBody>
+                  <a:tcPr marT="45720" marB="45720">
+                    <a:solidFill>
+                      <a:srgbClr val="F0EFEC"/>
+                    </a:solidFill>
+                  </a:tcPr>
+                </a:tc>
+                <a:tc>
+                  <a:txBody>
+                    <a:bodyPr wrap="square"/>
+                    <a:lstStyle/>
+                    <a:p>
+                      <a:r>
+                        <a:rPr sz="1400">
+                          <a:solidFill>
+                            <a:srgbClr val="0B0B0B"/>
+                          </a:solidFill>
+                        </a:rPr>
+                        <a:t>All pass</a:t>
+                      </a:r>
+                    </a:p>
+                  </a:txBody>
+                  <a:tcPr marT="45720" marB="45720">
+                    <a:solidFill>
+                      <a:srgbClr val="F0EFEC"/>
+                    </a:solidFill>
+                  </a:tcPr>
+                </a:tc>
+                <a:tc>
+                  <a:txBody>
+                    <a:bodyPr wrap="square"/>
+                    <a:lstStyle/>
+                    <a:p>
+                      <a:r>
+                        <a:rPr sz="1400">
+                          <a:solidFill>
+                            <a:srgbClr val="0B0B0B"/>
+                          </a:solidFill>
+                        </a:rPr>
+                        <a:t>All pass — exact to the cent</a:t>
+                      </a:r>
+                    </a:p>
+                  </a:txBody>
+                  <a:tcPr marT="45720" marB="45720">
+                    <a:solidFill>
+                      <a:srgbClr val="F0EFEC"/>
+                    </a:solidFill>
+                  </a:tcPr>
+                </a:tc>
+              </a:tr>
+              <a:tr h="365760">
+                <a:tc>
+                  <a:txBody>
+                    <a:bodyPr wrap="square"/>
+                    <a:lstStyle/>
+                    <a:p>
+                      <a:r>
+                        <a:rPr sz="1400">
+                          <a:solidFill>
+                            <a:srgbClr val="0B0B0B"/>
+                          </a:solidFill>
+                        </a:rPr>
+                        <a:t>Top speed measured</a:t>
+                      </a:r>
+                    </a:p>
+                  </a:txBody>
+                  <a:tcPr marT="45720" marB="45720">
+                    <a:solidFill>
+                      <a:srgbClr val="FFFFFF"/>
+                    </a:solidFill>
+                  </a:tcPr>
+                </a:tc>
+                <a:tc>
+                  <a:txBody>
+                    <a:bodyPr wrap="square"/>
+                    <a:lstStyle/>
+                    <a:p>
+                      <a:r>
+                        <a:rPr sz="1400">
+                          <a:solidFill>
+                            <a:srgbClr val="0B0B0B"/>
+                          </a:solidFill>
+                        </a:rPr>
+                        <a:t>110,000 msgs/sec (12 units)</a:t>
+                      </a:r>
+                    </a:p>
+                  </a:txBody>
+                  <a:tcPr marT="45720" marB="45720">
+                    <a:solidFill>
+                      <a:srgbClr val="FFFFFF"/>
+                    </a:solidFill>
+                  </a:tcPr>
+                </a:tc>
+                <a:tc>
+                  <a:txBody>
+                    <a:bodyPr wrap="square"/>
+                    <a:lstStyle/>
+                    <a:p>
+                      <a:r>
+                        <a:rPr sz="1400">
+                          <a:solidFill>
+                            <a:srgbClr val="0B0B0B"/>
+                          </a:solidFill>
+                        </a:rPr>
+                        <a:t>232,000 msgs/sec (16 units)</a:t>
+                      </a:r>
+                    </a:p>
+                  </a:txBody>
+                  <a:tcPr marT="45720" marB="45720">
+                    <a:solidFill>
+                      <a:srgbClr val="FFFFFF"/>
+                    </a:solidFill>
+                  </a:tcPr>
+                </a:tc>
+              </a:tr>
+              <a:tr h="365760">
+                <a:tc>
+                  <a:txBody>
+                    <a:bodyPr wrap="square"/>
+                    <a:lstStyle/>
+                    <a:p>
+                      <a:r>
+                        <a:rPr sz="1400">
+                          <a:solidFill>
+                            <a:srgbClr val="0B0B0B"/>
+                          </a:solidFill>
+                        </a:rPr>
+                        <a:t>How you scale</a:t>
+                      </a:r>
+                    </a:p>
+                  </a:txBody>
+                  <a:tcPr marT="45720" marB="45720">
+                    <a:solidFill>
+                      <a:srgbClr val="F0EFEC"/>
+                    </a:solidFill>
+                  </a:tcPr>
+                </a:tc>
+                <a:tc>
+                  <a:txBody>
+                    <a:bodyPr wrap="square"/>
+                    <a:lstStyle/>
+                    <a:p>
+                      <a:r>
+                        <a:rPr sz="1400">
+                          <a:solidFill>
+                            <a:srgbClr val="0B0B0B"/>
+                          </a:solidFill>
+                        </a:rPr>
+                        <a:t>Pick unit count by hand</a:t>
+                      </a:r>
+                    </a:p>
+                  </a:txBody>
+                  <a:tcPr marT="45720" marB="45720">
+                    <a:solidFill>
+                      <a:srgbClr val="F0EFEC"/>
+                    </a:solidFill>
+                  </a:tcPr>
+                </a:tc>
+                <a:tc>
+                  <a:txBody>
+                    <a:bodyPr wrap="square"/>
+                    <a:lstStyle/>
+                    <a:p>
+                      <a:r>
+                        <a:rPr sz="1400">
+                          <a:solidFill>
+                            <a:srgbClr val="0B0B0B"/>
+                          </a:solidFill>
+                        </a:rPr>
+                        <a:t>Autoscales up to a cap you set</a:t>
+                      </a:r>
+                    </a:p>
+                  </a:txBody>
+                  <a:tcPr marT="45720" marB="45720">
+                    <a:solidFill>
+                      <a:srgbClr val="F0EFEC"/>
+                    </a:solidFill>
+                  </a:tcPr>
+                </a:tc>
+              </a:tr>
+              <a:tr h="365760">
+                <a:tc>
+                  <a:txBody>
+                    <a:bodyPr wrap="square"/>
+                    <a:lstStyle/>
+                    <a:p>
+                      <a:r>
+                        <a:rPr sz="1400">
+                          <a:solidFill>
+                            <a:srgbClr val="0B0B0B"/>
+                          </a:solidFill>
+                        </a:rPr>
+                        <a:t>Est. monthly cost, under ~10k msgs/sec</a:t>
+                      </a:r>
+                    </a:p>
+                  </a:txBody>
+                  <a:tcPr marT="45720" marB="45720">
+                    <a:solidFill>
+                      <a:srgbClr val="FFFFFF"/>
+                    </a:solidFill>
+                  </a:tcPr>
+                </a:tc>
+                <a:tc>
+                  <a:txBody>
+                    <a:bodyPr wrap="square"/>
+                    <a:lstStyle/>
+                    <a:p>
+                      <a:r>
+                        <a:rPr sz="1400">
+                          <a:solidFill>
+                            <a:srgbClr val="0B0B0B"/>
+                          </a:solidFill>
+                        </a:rPr>
+                        <a:t>~ $1,070</a:t>
+                      </a:r>
+                    </a:p>
+                  </a:txBody>
+                  <a:tcPr marT="45720" marB="45720">
+                    <a:solidFill>
+                      <a:srgbClr val="FFFFFF"/>
+                    </a:solidFill>
+                  </a:tcPr>
+                </a:tc>
+                <a:tc>
+                  <a:txBody>
+                    <a:bodyPr wrap="square"/>
+                    <a:lstStyle/>
+                    <a:p>
+                      <a:r>
+                        <a:rPr sz="1400">
+                          <a:solidFill>
+                            <a:srgbClr val="0B0B0B"/>
+                          </a:solidFill>
+                        </a:rPr>
+                        <a:t>~ $1,010</a:t>
+                      </a:r>
+                    </a:p>
+                  </a:txBody>
+                  <a:tcPr marT="45720" marB="45720">
+                    <a:solidFill>
+                      <a:srgbClr val="FFFFFF"/>
+                    </a:solidFill>
+                  </a:tcPr>
+                </a:tc>
+              </a:tr>
+              <a:tr h="365760">
+                <a:tc>
+                  <a:txBody>
+                    <a:bodyPr wrap="square"/>
+                    <a:lstStyle/>
+                    <a:p>
+                      <a:r>
+                        <a:rPr sz="1400">
+                          <a:solidFill>
+                            <a:srgbClr val="0B0B0B"/>
+                          </a:solidFill>
+                        </a:rPr>
+                        <a:t>Est. monthly cost, same 110k msgs/sec job</a:t>
+                      </a:r>
+                    </a:p>
+                  </a:txBody>
+                  <a:tcPr marT="45720" marB="45720">
+                    <a:solidFill>
+                      <a:srgbClr val="F0EFEC"/>
+                    </a:solidFill>
+                  </a:tcPr>
+                </a:tc>
+                <a:tc>
+                  <a:txBody>
+                    <a:bodyPr wrap="square"/>
+                    <a:lstStyle/>
+                    <a:p>
+                      <a:r>
+                        <a:rPr sz="1400">
+                          <a:solidFill>
+                            <a:srgbClr val="0B0B0B"/>
+                          </a:solidFill>
+                        </a:rPr>
+                        <a:t>~ $6,100</a:t>
+                      </a:r>
+                    </a:p>
+                  </a:txBody>
+                  <a:tcPr marT="45720" marB="45720">
+                    <a:solidFill>
+                      <a:srgbClr val="F0EFEC"/>
+                    </a:solidFill>
+                  </a:tcPr>
+                </a:tc>
+                <a:tc>
+                  <a:txBody>
+                    <a:bodyPr wrap="square"/>
+                    <a:lstStyle/>
+                    <a:p>
+                      <a:r>
+                        <a:rPr sz="1400">
+                          <a:solidFill>
+                            <a:srgbClr val="0B0B0B"/>
+                          </a:solidFill>
+                        </a:rPr>
+                        <a:t>~ $3,500</a:t>
+                      </a:r>
+                    </a:p>
+                  </a:txBody>
+                  <a:tcPr marT="45720" marB="45720">
+                    <a:solidFill>
+                      <a:srgbClr val="F0EFEC"/>
+                    </a:solidFill>
+                  </a:tcPr>
+                </a:tc>
+              </a:tr>
+            </a:tbl>
+          </a:graphicData>
+        </a:graphic>
+      </p:graphicFrame>
+      <p:sp>
+        <p:nvSpPr>
+          <p:cNvPr id="6" name="TextBox 5"/>
           <p:cNvSpPr txBox="1"/>
           <p:nvPr/>
         </p:nvSpPr>
         <p:spPr>
           <a:xfrm>
-            <a:off x="640080" y="1737360"/>
+            <a:off x="640080" y="5120640"/>
             <a:ext cx="10881360" cy="4754880"/>
           </a:xfrm>
           <a:prstGeom prst="rect">
@@ -7496,91 +8219,46 @@
           <a:p>
             <a:pPr>
               <a:spcAft>
-                <a:spcPts val="1200"/>
+                <a:spcPts val="1000"/>
               </a:spcAft>
             </a:pPr>
             <a:r>
-              <a:rPr sz="1800" b="0">
-                <a:solidFill>
-                  <a:srgbClr val="0B0B0B"/>
-                </a:solidFill>
-              </a:rPr>
-              <a:t>• Terraform stack complete: MSK Serverless (Kafka) + Amazon Managed Service for Apache Flink + generator on Fargate + CloudWatch dashboard</a:t>
+              <a:rPr sz="1600" b="1">
+                <a:solidFill>
+                  <a:srgbClr val="0B0B0B"/>
+                </a:solidFill>
+              </a:rPr>
+              <a:t>• Same topics, same JSON, same generator, same tests - only the engine changed</a:t>
             </a:r>
           </a:p>
           <a:p>
             <a:pPr>
               <a:spcAft>
-                <a:spcPts val="1200"/>
+                <a:spcPts val="1000"/>
               </a:spcAft>
             </a:pPr>
             <a:r>
-              <a:rPr sz="1800" b="1">
-                <a:solidFill>
-                  <a:srgbClr val="0B0B0B"/>
-                </a:solidFill>
-              </a:rPr>
-              <a:t>• The exact same application jar runs on AWS — every environment difference is configuration</a:t>
+              <a:rPr sz="1600" b="0">
+                <a:solidFill>
+                  <a:srgbClr val="0B0B0B"/>
+                </a:solidFill>
+              </a:rPr>
+              <a:t>• The validation suite re-derives every number from raw data, so proving a cross-cloud rewrite took an afternoon and ~ $4</a:t>
             </a:r>
           </a:p>
           <a:p>
             <a:pPr>
               <a:spcAft>
-                <a:spcPts val="1200"/>
+                <a:spcPts val="1000"/>
               </a:spcAft>
             </a:pPr>
             <a:r>
-              <a:rPr sz="1800" b="0">
-                <a:solidFill>
-                  <a:srgbClr val="0B0B0B"/>
-                </a:solidFill>
-              </a:rPr>
-              <a:t>• Security by default: private VPC, IAM auth to Kafka, least-privilege roles</a:t>
-            </a:r>
-          </a:p>
-          <a:p>
-            <a:pPr>
-              <a:spcAft>
-                <a:spcPts val="1200"/>
-              </a:spcAft>
-            </a:pPr>
-            <a:r>
-              <a:rPr sz="1800" b="0">
-                <a:solidFill>
-                  <a:srgbClr val="0B0B0B"/>
-                </a:solidFill>
-              </a:rPr>
-              <a:t>• Operations runbook: deploy, in-place code update, config-only rescale, teardown</a:t>
-            </a:r>
-          </a:p>
-          <a:p>
-            <a:pPr>
-              <a:spcAft>
-                <a:spcPts val="1200"/>
-              </a:spcAft>
-            </a:pPr>
-            <a:r>
-              <a:rPr sz="1800" b="0">
-                <a:solidFill>
-                  <a:srgbClr val="0B0B0B"/>
-                </a:solidFill>
-              </a:rPr>
-              <a:t>• Demo cost ≈ $1/hour while running; destroyed when not in use</a:t>
-            </a:r>
-          </a:p>
-          <a:p>
-            <a:pPr>
-              <a:spcAft>
-                <a:spcPts val="1200"/>
-              </a:spcAft>
-            </a:pPr>
-            <a:r>
-              <a:rPr sz="1800" b="1">
+              <a:rPr sz="1600" b="0">
                 <a:solidFill>
                   <a:srgbClr val="008300"/>
                 </a:solidFill>
               </a:rPr>
-              <a:t>• Status: DEPLOYED and load-tested on AWS — all cases green, scaling ladder measured, then torn down cleanly</a:t>
+              <a:t>• Price storm result reproduced: 10,000 price updates/sec in, ~10 conflated updates/sec out, trades unaffected</a:t>
             </a:r>
           </a:p>
         </p:txBody>

</xml_diff>

<commit_message>
Sync README/article/deck with Phase 10 — correct the top-speed story
The "Confluent 2x AWS" claim was a methodology artifact; corrected in
place with the tuned results and the $1.21 vs $3.36 floor comparison.
Article gains the Monday-postscript rematch section.

Co-Authored-By: Claude Fable 5 <noreply@anthropic.com>
</commit_message>
<xml_diff>
--- a/docs/flink-demo-exec-briefing.pptx
+++ b/docs/flink-demo-exec-briefing.pptx
@@ -4262,7 +4262,7 @@
                   <a:srgbClr val="0B0B0B"/>
                 </a:solidFill>
               </a:rPr>
-              <a:t>• Volume proven on both clouds: 110k msgs/sec live on AWS; 232k msgs/sec processing on Confluent</a:t>
+              <a:t>• Volume proven on both clouds, same method: AWS 757k msgs/sec tuned (linear 2x from a 10-unit floor); Confluent 232.7k</a:t>
             </a:r>
           </a:p>
           <a:p>
@@ -7723,7 +7723,7 @@
         </p:nvGraphicFramePr>
         <p:xfrm>
           <a:off x="640080" y="1645920"/>
-          <a:ext cx="10972800" cy="2560320"/>
+          <a:ext cx="10972800" cy="2926080"/>
         </p:xfrm>
         <a:graphic>
           <a:graphicData uri="http://schemas.openxmlformats.org/drawingml/2006/table">
@@ -7943,7 +7943,7 @@
                             <a:srgbClr val="0B0B0B"/>
                           </a:solidFill>
                         </a:rPr>
-                        <a:t>Top speed measured</a:t>
+                        <a:t>Top speed, same method (day 3 tuned)</a:t>
                       </a:r>
                     </a:p>
                   </a:txBody>
@@ -7964,7 +7964,7 @@
                             <a:srgbClr val="0B0B0B"/>
                           </a:solidFill>
                         </a:rPr>
-                        <a:t>110,000 msgs/sec (12 units)</a:t>
+                        <a:t>757,600 msgs/sec (20 units)</a:t>
                       </a:r>
                     </a:p>
                   </a:txBody>
@@ -7985,7 +7985,7 @@
                             <a:srgbClr val="0B0B0B"/>
                           </a:solidFill>
                         </a:rPr>
-                        <a:t>232,000 msgs/sec (16 units)</a:t>
+                        <a:t>232,700 msgs/sec (16 units)</a:t>
                       </a:r>
                     </a:p>
                   </a:txBody>
@@ -8187,6 +8187,71 @@
                   <a:tcPr marT="45720" marB="45720">
                     <a:solidFill>
                       <a:srgbClr val="F0EFEC"/>
+                    </a:solidFill>
+                  </a:tcPr>
+                </a:tc>
+              </a:tr>
+              <a:tr h="365760">
+                <a:tc>
+                  <a:txBody>
+                    <a:bodyPr wrap="square"/>
+                    <a:lstStyle/>
+                    <a:p>
+                      <a:r>
+                        <a:rPr sz="1400">
+                          <a:solidFill>
+                            <a:srgbClr val="0B0B0B"/>
+                          </a:solidFill>
+                        </a:rPr>
+                        <a:t>Compute $/hr to match the 232.7k peak (day 3)</a:t>
+                      </a:r>
+                    </a:p>
+                  </a:txBody>
+                  <a:tcPr marT="45720" marB="45720">
+                    <a:solidFill>
+                      <a:srgbClr val="FFFFFF"/>
+                    </a:solidFill>
+                  </a:tcPr>
+                </a:tc>
+                <a:tc>
+                  <a:txBody>
+                    <a:bodyPr wrap="square"/>
+                    <a:lstStyle/>
+                    <a:p>
+                      <a:r>
+                        <a:rPr sz="1400">
+                          <a:solidFill>
+                            <a:srgbClr val="0B0B0B"/>
+                          </a:solidFill>
+                        </a:rPr>
+                        <a:t>$1.21 (10 units)</a:t>
+                      </a:r>
+                    </a:p>
+                  </a:txBody>
+                  <a:tcPr marT="45720" marB="45720">
+                    <a:solidFill>
+                      <a:srgbClr val="FFFFFF"/>
+                    </a:solidFill>
+                  </a:tcPr>
+                </a:tc>
+                <a:tc>
+                  <a:txBody>
+                    <a:bodyPr wrap="square"/>
+                    <a:lstStyle/>
+                    <a:p>
+                      <a:r>
+                        <a:rPr sz="1400">
+                          <a:solidFill>
+                            <a:srgbClr val="0B0B0B"/>
+                          </a:solidFill>
+                        </a:rPr>
+                        <a:t>$3.36 (16 units)</a:t>
+                      </a:r>
+                    </a:p>
+                  </a:txBody>
+                  <a:tcPr marT="45720" marB="45720">
+                    <a:solidFill>
+                      <a:srgbClr val="FFFFFF"/>
                     </a:solidFill>
                   </a:tcPr>
                 </a:tc>

</xml_diff>

<commit_message>
Phase 10: AWS efficiency parity — tuned +89%, 10-KPU floor, linear 2x
Backlog-drain methodology (same as Phase 9's Confluent test): untuned P=12
already averaged 236k msgs/s (peak 483k) vs the 110k "finale" that was
never a ceiling. Tuning at fixed cost: config (packed subtasks, 48
partitions, batched lz4 sinks) +39%; emission conflation
(emit.interval.ms, default 0 preserves latency) +89% total to ~435k.
Descending ladder: 10 KPUs ($1.21/hr) matches Confluent's 232.7k peak at
36% of its compute cost; 8 KPUs fails (sub-linear edge). Linearity from
the floor: 10->20 KPUs = 2.0x sustained, peak 757.6k. README/article/deck
corrected (the "Confluent 2x AWS" claim was a methodology artifact).
Stack destroyed, zeros verified. 21 tests green.

Co-Authored-By: Claude Fable 5 <noreply@anthropic.com>
</commit_message>
<xml_diff>
--- a/docs/flink-demo-exec-briefing.pptx
+++ b/docs/flink-demo-exec-briefing.pptx
@@ -4262,7 +4262,7 @@
                   <a:srgbClr val="0B0B0B"/>
                 </a:solidFill>
               </a:rPr>
-              <a:t>• Volume proven on both clouds: 110k msgs/sec live on AWS; 232k msgs/sec processing on Confluent</a:t>
+              <a:t>• Volume proven on both clouds, same method: AWS 757k msgs/sec tuned (linear 2x from a 10-unit floor); Confluent 232.7k</a:t>
             </a:r>
           </a:p>
           <a:p>
@@ -7723,7 +7723,7 @@
         </p:nvGraphicFramePr>
         <p:xfrm>
           <a:off x="640080" y="1645920"/>
-          <a:ext cx="10972800" cy="2560320"/>
+          <a:ext cx="10972800" cy="2926080"/>
         </p:xfrm>
         <a:graphic>
           <a:graphicData uri="http://schemas.openxmlformats.org/drawingml/2006/table">
@@ -7943,7 +7943,7 @@
                             <a:srgbClr val="0B0B0B"/>
                           </a:solidFill>
                         </a:rPr>
-                        <a:t>Top speed measured</a:t>
+                        <a:t>Top speed, same method (day 3 tuned)</a:t>
                       </a:r>
                     </a:p>
                   </a:txBody>
@@ -7964,7 +7964,7 @@
                             <a:srgbClr val="0B0B0B"/>
                           </a:solidFill>
                         </a:rPr>
-                        <a:t>110,000 msgs/sec (12 units)</a:t>
+                        <a:t>757,600 msgs/sec (20 units)</a:t>
                       </a:r>
                     </a:p>
                   </a:txBody>
@@ -7985,7 +7985,7 @@
                             <a:srgbClr val="0B0B0B"/>
                           </a:solidFill>
                         </a:rPr>
-                        <a:t>232,000 msgs/sec (16 units)</a:t>
+                        <a:t>232,700 msgs/sec (16 units)</a:t>
                       </a:r>
                     </a:p>
                   </a:txBody>
@@ -8187,6 +8187,71 @@
                   <a:tcPr marT="45720" marB="45720">
                     <a:solidFill>
                       <a:srgbClr val="F0EFEC"/>
+                    </a:solidFill>
+                  </a:tcPr>
+                </a:tc>
+              </a:tr>
+              <a:tr h="365760">
+                <a:tc>
+                  <a:txBody>
+                    <a:bodyPr wrap="square"/>
+                    <a:lstStyle/>
+                    <a:p>
+                      <a:r>
+                        <a:rPr sz="1400">
+                          <a:solidFill>
+                            <a:srgbClr val="0B0B0B"/>
+                          </a:solidFill>
+                        </a:rPr>
+                        <a:t>Compute $/hr to match the 232.7k peak (day 3)</a:t>
+                      </a:r>
+                    </a:p>
+                  </a:txBody>
+                  <a:tcPr marT="45720" marB="45720">
+                    <a:solidFill>
+                      <a:srgbClr val="FFFFFF"/>
+                    </a:solidFill>
+                  </a:tcPr>
+                </a:tc>
+                <a:tc>
+                  <a:txBody>
+                    <a:bodyPr wrap="square"/>
+                    <a:lstStyle/>
+                    <a:p>
+                      <a:r>
+                        <a:rPr sz="1400">
+                          <a:solidFill>
+                            <a:srgbClr val="0B0B0B"/>
+                          </a:solidFill>
+                        </a:rPr>
+                        <a:t>$1.21 (10 units)</a:t>
+                      </a:r>
+                    </a:p>
+                  </a:txBody>
+                  <a:tcPr marT="45720" marB="45720">
+                    <a:solidFill>
+                      <a:srgbClr val="FFFFFF"/>
+                    </a:solidFill>
+                  </a:tcPr>
+                </a:tc>
+                <a:tc>
+                  <a:txBody>
+                    <a:bodyPr wrap="square"/>
+                    <a:lstStyle/>
+                    <a:p>
+                      <a:r>
+                        <a:rPr sz="1400">
+                          <a:solidFill>
+                            <a:srgbClr val="0B0B0B"/>
+                          </a:solidFill>
+                        </a:rPr>
+                        <a:t>$3.36 (16 units)</a:t>
+                      </a:r>
+                    </a:p>
+                  </a:txBody>
+                  <a:tcPr marT="45720" marB="45720">
+                    <a:solidFill>
+                      <a:srgbClr val="FFFFFF"/>
                     </a:solidFill>
                   </a:tcPr>
                 </a:tc>

</xml_diff>

<commit_message>
TCO correction: Phase 10 cost claims include Kafka base + partition fees
User review catch: $1.21 vs $3.36 was compute-only. Full infra TCO at the
floor: AWS ~$2.39/hr (KPUs + MSK cluster base + 288 partition-hours) vs
Confluent ~$3.7-4.2/hr (Flink + eCKU; no partition/cluster-base fees) —
"~40% cheaper TCO", not "64% cheaper compute". PERF_RESULTS, README,
article, deck all corrected; Phase 11 verdict will use TCO.

Co-Authored-By: Claude Fable 5 <noreply@anthropic.com>
</commit_message>
<xml_diff>
--- a/docs/flink-demo-exec-briefing.pptx
+++ b/docs/flink-demo-exec-briefing.pptx
@@ -8203,7 +8203,7 @@
                             <a:srgbClr val="0B0B0B"/>
                           </a:solidFill>
                         </a:rPr>
-                        <a:t>Compute $/hr to match the 232.7k peak (day 3)</a:t>
+                        <a:t>Infra $/hr to match the 232.7k peak (day 3)</a:t>
                       </a:r>
                     </a:p>
                   </a:txBody>
@@ -8224,7 +8224,7 @@
                             <a:srgbClr val="0B0B0B"/>
                           </a:solidFill>
                         </a:rPr>
-                        <a:t>$1.21 (10 units)</a:t>
+                        <a:t>~$2.39 (10 units + Kafka base/partitions)</a:t>
                       </a:r>
                     </a:p>
                   </a:txBody>
@@ -8245,7 +8245,7 @@
                             <a:srgbClr val="0B0B0B"/>
                           </a:solidFill>
                         </a:rPr>
-                        <a:t>$3.36 (16 units)</a:t>
+                        <a:t>~$3.9 (16 units + usage; no partition fees)</a:t>
                       </a:r>
                     </a:p>
                   </a:txBody>

</xml_diff>

<commit_message>
Phase 12: SQL gets within ~7x of DataStream — the 124x was my topology
Rewrote the same logic three ways and measured each live. Diagnostic killed
the watermark hypothesis immediately: the no-window path was also slow, so
the cost was the statement chain (~7s per Kafka hop), not the window.
Inlining intermediate topics as CTEs: p50 26.7s -> 1.9s. Fusing all four
sinks into one EXECUTE STATEMENT SET: p50 1.8s and p99 55s -> 2.1s (11.7x
tail improvement). Residual ~1.8s is not the window (no-window and windowed
paths measured identical) but likely delivery semantics: our DataStream job
is AT_LEAST_ONCE and publishes immediately, Confluent commits
transactionally at checkpoints.

Corrected the published 124x claim everywhere (scoreboard, README, article,
deck) and recorded the open gaps: AWS positions-path latency never measured,
guarantees never matched, fused-set throughput not measured.

Both stacks destroyed, zeros verified.

Co-Authored-By: Claude Fable 5 <noreply@anthropic.com>
</commit_message>
<xml_diff>
--- a/docs/flink-demo-exec-briefing.pptx
+++ b/docs/flink-demo-exec-briefing.pptx
@@ -7920,7 +7920,7 @@
                             <a:srgbClr val="0B0B0B"/>
                           </a:solidFill>
                         </a:rPr>
-                        <a:t>p50 33 s  /  p99 44 s</a:t>
+                        <a:t>p50 1.8 s  /  p99 2.1 s (SQL tuned for latency)</a:t>
                       </a:r>
                     </a:p>
                   </a:txBody>
@@ -8308,7 +8308,7 @@
                   <a:srgbClr val="0B0B0B"/>
                 </a:solidFill>
               </a:rPr>
-              <a:t>• Confluent is ~10x less code and nothing to deploy: independent SQL statements - which is why data crosses Kafka between every step</a:t>
+              <a:t>• Confluent is ~10x less code and nothing to deploy - but the SQL must be ONE fused statement set; writing it as chained statements costs 15x latency (26.7s -&gt; 1.8s when fixed)</a:t>
             </a:r>
           </a:p>
           <a:p>

</xml_diff>

<commit_message>
Article, README and deck: add the CR-1 capability finding
The article now ends on the requirement rather than the benchmark — three
days of arguing about speed, settled by whether either platform could do
what the product asked. README gains a headline row; the scoreboard and
deck comparison gain a "rate-limit an output" line; the deck's
recommendation is now a recommendation rather than a both-are-fine.

Co-Authored-By: Claude Fable 5 <noreply@anthropic.com>
</commit_message>
<xml_diff>
--- a/docs/flink-demo-exec-briefing.pptx
+++ b/docs/flink-demo-exec-briefing.pptx
@@ -4247,7 +4247,7 @@
                   <a:srgbClr val="0B0B0B"/>
                 </a:solidFill>
               </a:rPr>
-              <a:t>• Two validated deployment targets: AWS Managed Flink for latency-critical and high-volume work; Confluent Cloud SQL where multi-second freshness is fine and speed-to-build wins</a:t>
+              <a:t>• Recommend AWS Managed Flink for this product: it is faster, cheaper at equal work, and the only one of the two that can satisfy the output-cadence requirement (CR-1)</a:t>
             </a:r>
           </a:p>
           <a:p>
@@ -7723,7 +7723,7 @@
         </p:nvGraphicFramePr>
         <p:xfrm>
           <a:off x="640080" y="1645920"/>
-          <a:ext cx="10972800" cy="2926080"/>
+          <a:ext cx="10972800" cy="3291840"/>
         </p:xfrm>
         <a:graphic>
           <a:graphicData uri="http://schemas.openxmlformats.org/drawingml/2006/table">
@@ -8256,6 +8256,71 @@
                   </a:tcPr>
                 </a:tc>
               </a:tr>
+              <a:tr h="365760">
+                <a:tc>
+                  <a:txBody>
+                    <a:bodyPr wrap="square"/>
+                    <a:lstStyle/>
+                    <a:p>
+                      <a:r>
+                        <a:rPr sz="1300">
+                          <a:solidFill>
+                            <a:srgbClr val="0B0B0B"/>
+                          </a:solidFill>
+                        </a:rPr>
+                        <a:t>Rate-limit an output (CR-1)</a:t>
+                      </a:r>
+                    </a:p>
+                  </a:txBody>
+                  <a:tcPr marT="45720" marB="45720">
+                    <a:solidFill>
+                      <a:srgbClr val="F0EFEC"/>
+                    </a:solidFill>
+                  </a:tcPr>
+                </a:tc>
+                <a:tc>
+                  <a:txBody>
+                    <a:bodyPr wrap="square"/>
+                    <a:lstStyle/>
+                    <a:p>
+                      <a:r>
+                        <a:rPr sz="1300">
+                          <a:solidFill>
+                            <a:srgbClr val="0B0B0B"/>
+                          </a:solidFill>
+                        </a:rPr>
+                        <a:t>config change - 0.96/key/sec vs 1.0 cap</a:t>
+                      </a:r>
+                    </a:p>
+                  </a:txBody>
+                  <a:tcPr marT="45720" marB="45720">
+                    <a:solidFill>
+                      <a:srgbClr val="F0EFEC"/>
+                    </a:solidFill>
+                  </a:tcPr>
+                </a:tc>
+                <a:tc>
+                  <a:txBody>
+                    <a:bodyPr wrap="square"/>
+                    <a:lstStyle/>
+                    <a:p>
+                      <a:r>
+                        <a:rPr sz="1300">
+                          <a:solidFill>
+                            <a:srgbClr val="0B0B0B"/>
+                          </a:solidFill>
+                        </a:rPr>
+                        <a:t>NOT EXPRESSIBLE for updating aggregations</a:t>
+                      </a:r>
+                    </a:p>
+                  </a:txBody>
+                  <a:tcPr marT="45720" marB="45720">
+                    <a:solidFill>
+                      <a:srgbClr val="F0EFEC"/>
+                    </a:solidFill>
+                  </a:tcPr>
+                </a:tc>
+              </a:tr>
             </a:tbl>
           </a:graphicData>
         </a:graphic>
@@ -8320,10 +8385,10 @@
             <a:r>
               <a:rPr sz="1500" b="1">
                 <a:solidFill>
-                  <a:srgbClr val="0B0B0B"/>
-                </a:solidFill>
-              </a:rPr>
-              <a:t>• Decide by latency budget, not by benchmark: sub-second -&gt; DataStream; multi-second-tolerant analytics -&gt; SQL</a:t>
+                  <a:srgbClr val="2A78D6"/>
+                </a:solidFill>
+              </a:rPr>
+              <a:t>• The deciding factor was not speed: a plain requirement - do not update the screen faster than a human can read - is one config line on DataStream and has no supported construct in Confluent SQL</a:t>
             </a:r>
           </a:p>
         </p:txBody>

</xml_diff>

<commit_message>
Rewrite docs, article and deck around the measured results
One clean story rather than a trail of corrections:

* docs/PHASE16_RESULTS.md rewritten as the single source of truth. Leads with
  the workload (ten tickers) because that one fact explains nearly every
  result, states only what the data supports, and confines the corrections to
  a single "What changed" table.
* docs/PERF_RESULTS.md carries a SUPERSEDED banner naming exactly which figures
  are retired and why; kept for method and reasoning, which still hold.
* README headline table replaced with the verified claims.
* LinkedIn article epilogue rewritten in plain language around the real
  finding: I checked that records went in on every test and never checked that
  any came out.
* Deck: scoreboard slide rebuilt on measured numbers, plus a new slide on the
  three published conclusions that did not survive re-measurement.

Co-Authored-By: Claude Fable 5 <noreply@anthropic.com>
</commit_message>
<xml_diff>
--- a/docs/flink-demo-exec-briefing.pptx
+++ b/docs/flink-demo-exec-briefing.pptx
@@ -17,6 +17,7 @@
     <p:sldId id="265" r:id="rId16"/>
     <p:sldId id="266" r:id="rId17"/>
     <p:sldId id="267" r:id="rId18"/>
+    <p:sldId id="268" r:id="rId19"/>
   </p:sldIdLst>
   <p:sldSz cx="12191695" cy="6858000" type="screen4x3"/>
   <p:notesSz cx="6858000" cy="9144000"/>
@@ -3431,7 +3432,7 @@
                   <a:srgbClr val="0B0B0B"/>
                 </a:solidFill>
               </a:rPr>
-              <a:t>Path to production — AWS ready today</a:t>
+              <a:t>Most of the first numbers were wrong</a:t>
             </a:r>
           </a:p>
         </p:txBody>
@@ -3507,20 +3508,437 @@
                   <a:srgbClr val="52514E"/>
                 </a:solidFill>
               </a:rPr>
-              <a:t>Full infrastructure-as-code, validated; one command to deploy</a:t>
-            </a:r>
-          </a:p>
-        </p:txBody>
-      </p:sp>
-      <p:sp>
-        <p:nvSpPr>
-          <p:cNvPr id="5" name="TextBox 4"/>
+              <a:t>Three published conclusions did not survive re-measurement</a:t>
+            </a:r>
+          </a:p>
+        </p:txBody>
+      </p:sp>
+      <p:graphicFrame>
+        <p:nvGraphicFramePr>
+          <p:cNvPr id="5" name="Table 4"/>
+          <p:cNvGraphicFramePr>
+            <a:graphicFrameLocks noGrp="1"/>
+          </p:cNvGraphicFramePr>
+          <p:nvPr/>
+        </p:nvGraphicFramePr>
+        <p:xfrm>
+          <a:off x="640080" y="1645920"/>
+          <a:ext cx="10972800" cy="2194560"/>
+        </p:xfrm>
+        <a:graphic>
+          <a:graphicData uri="http://schemas.openxmlformats.org/drawingml/2006/table">
+            <a:tbl>
+              <a:tblPr firstRow="1" bandRow="1">
+                <a:tableStyleId>{5C22544A-7EE6-4342-B048-85BDC9FD1C3A}</a:tableStyleId>
+              </a:tblPr>
+              <a:tblGrid>
+                <a:gridCol w="3108960"/>
+                <a:gridCol w="4937760"/>
+                <a:gridCol w="2926080"/>
+              </a:tblGrid>
+              <a:tr h="365760">
+                <a:tc>
+                  <a:txBody>
+                    <a:bodyPr wrap="square"/>
+                    <a:lstStyle/>
+                    <a:p>
+                      <a:r>
+                        <a:rPr sz="1200" b="1">
+                          <a:solidFill>
+                            <a:srgbClr val="FFFFFF"/>
+                          </a:solidFill>
+                        </a:rPr>
+                        <a:t>What I published</a:t>
+                      </a:r>
+                    </a:p>
+                  </a:txBody>
+                  <a:tcPr marT="45720" marB="45720">
+                    <a:solidFill>
+                      <a:srgbClr val="2A78D6"/>
+                    </a:solidFill>
+                  </a:tcPr>
+                </a:tc>
+                <a:tc>
+                  <a:txBody>
+                    <a:bodyPr wrap="square"/>
+                    <a:lstStyle/>
+                    <a:p>
+                      <a:r>
+                        <a:rPr sz="1200" b="1">
+                          <a:solidFill>
+                            <a:srgbClr val="FFFFFF"/>
+                          </a:solidFill>
+                        </a:rPr>
+                        <a:t>What was actually happening</a:t>
+                      </a:r>
+                    </a:p>
+                  </a:txBody>
+                  <a:tcPr marT="45720" marB="45720">
+                    <a:solidFill>
+                      <a:srgbClr val="2A78D6"/>
+                    </a:solidFill>
+                  </a:tcPr>
+                </a:tc>
+                <a:tc>
+                  <a:txBody>
+                    <a:bodyPr wrap="square"/>
+                    <a:lstStyle/>
+                    <a:p>
+                      <a:r>
+                        <a:rPr sz="1200" b="1">
+                          <a:solidFill>
+                            <a:srgbClr val="FFFFFF"/>
+                          </a:solidFill>
+                        </a:rPr>
+                        <a:t>Corrected</a:t>
+                      </a:r>
+                    </a:p>
+                  </a:txBody>
+                  <a:tcPr marT="45720" marB="45720">
+                    <a:solidFill>
+                      <a:srgbClr val="2A78D6"/>
+                    </a:solidFill>
+                  </a:tcPr>
+                </a:tc>
+              </a:tr>
+              <a:tr h="365760">
+                <a:tc>
+                  <a:txBody>
+                    <a:bodyPr wrap="square"/>
+                    <a:lstStyle/>
+                    <a:p>
+                      <a:r>
+                        <a:rPr sz="1200">
+                          <a:solidFill>
+                            <a:srgbClr val="0B0B0B"/>
+                          </a:solidFill>
+                        </a:rPr>
+                        <a:t>SQL is 124x slower</a:t>
+                      </a:r>
+                    </a:p>
+                  </a:txBody>
+                  <a:tcPr marT="45720" marB="45720">
+                    <a:solidFill>
+                      <a:srgbClr val="FFFFFF"/>
+                    </a:solidFill>
+                  </a:tcPr>
+                </a:tc>
+                <a:tc>
+                  <a:txBody>
+                    <a:bodyPr wrap="square"/>
+                    <a:lstStyle/>
+                    <a:p>
+                      <a:r>
+                        <a:rPr sz="1200">
+                          <a:solidFill>
+                            <a:srgbClr val="0B0B0B"/>
+                          </a:solidFill>
+                        </a:rPr>
+                        <a:t>I wrote one SQL statement per Java operator, so every stage hopped through Kafka</a:t>
+                      </a:r>
+                    </a:p>
+                  </a:txBody>
+                  <a:tcPr marT="45720" marB="45720">
+                    <a:solidFill>
+                      <a:srgbClr val="FFFFFF"/>
+                    </a:solidFill>
+                  </a:tcPr>
+                </a:tc>
+                <a:tc>
+                  <a:txBody>
+                    <a:bodyPr wrap="square"/>
+                    <a:lstStyle/>
+                    <a:p>
+                      <a:r>
+                        <a:rPr sz="1200">
+                          <a:solidFill>
+                            <a:srgbClr val="0B0B0B"/>
+                          </a:solidFill>
+                        </a:rPr>
+                        <a:t>1.8s, not 26.7s</a:t>
+                      </a:r>
+                    </a:p>
+                  </a:txBody>
+                  <a:tcPr marT="45720" marB="45720">
+                    <a:solidFill>
+                      <a:srgbClr val="FFFFFF"/>
+                    </a:solidFill>
+                  </a:tcPr>
+                </a:tc>
+              </a:tr>
+              <a:tr h="365760">
+                <a:tc>
+                  <a:txBody>
+                    <a:bodyPr wrap="square"/>
+                    <a:lstStyle/>
+                    <a:p>
+                      <a:r>
+                        <a:rPr sz="1200">
+                          <a:solidFill>
+                            <a:srgbClr val="0B0B0B"/>
+                          </a:solidFill>
+                        </a:rPr>
+                        <a:t>SQL is 2.69x slower</a:t>
+                      </a:r>
+                    </a:p>
+                  </a:txBody>
+                  <a:tcPr marT="45720" marB="45720">
+                    <a:solidFill>
+                      <a:srgbClr val="F0EFEC"/>
+                    </a:solidFill>
+                  </a:tcPr>
+                </a:tc>
+                <a:tc>
+                  <a:txBody>
+                    <a:bodyPr wrap="square"/>
+                    <a:lstStyle/>
+                    <a:p>
+                      <a:r>
+                        <a:rPr sz="1200">
+                          <a:solidFill>
+                            <a:srgbClr val="0B0B0B"/>
+                          </a:solidFill>
+                        </a:rPr>
+                        <a:t>That run consumed 119k rec/sec and wrote NOTHING for an hour - status green throughout</a:t>
+                      </a:r>
+                    </a:p>
+                  </a:txBody>
+                  <a:tcPr marT="45720" marB="45720">
+                    <a:solidFill>
+                      <a:srgbClr val="F0EFEC"/>
+                    </a:solidFill>
+                  </a:tcPr>
+                </a:tc>
+                <a:tc>
+                  <a:txBody>
+                    <a:bodyPr wrap="square"/>
+                    <a:lstStyle/>
+                    <a:p>
+                      <a:r>
+                        <a:rPr sz="1200">
+                          <a:solidFill>
+                            <a:srgbClr val="0B0B0B"/>
+                          </a:solidFill>
+                        </a:rPr>
+                        <a:t>~2x, output verified</a:t>
+                      </a:r>
+                    </a:p>
+                  </a:txBody>
+                  <a:tcPr marT="45720" marB="45720">
+                    <a:solidFill>
+                      <a:srgbClr val="F0EFEC"/>
+                    </a:solidFill>
+                  </a:tcPr>
+                </a:tc>
+              </a:tr>
+              <a:tr h="365760">
+                <a:tc>
+                  <a:txBody>
+                    <a:bodyPr wrap="square"/>
+                    <a:lstStyle/>
+                    <a:p>
+                      <a:r>
+                        <a:rPr sz="1200">
+                          <a:solidFill>
+                            <a:srgbClr val="0B0B0B"/>
+                          </a:solidFill>
+                        </a:rPr>
+                        <a:t>Confluent does not scale</a:t>
+                      </a:r>
+                    </a:p>
+                  </a:txBody>
+                  <a:tcPr marT="45720" marB="45720">
+                    <a:solidFill>
+                      <a:srgbClr val="FFFFFF"/>
+                    </a:solidFill>
+                  </a:tcPr>
+                </a:tc>
+                <a:tc>
+                  <a:txBody>
+                    <a:bodyPr wrap="square"/>
+                    <a:lstStyle/>
+                    <a:p>
+                      <a:r>
+                        <a:rPr sz="1200">
+                          <a:solidFill>
+                            <a:srgbClr val="0B0B0B"/>
+                          </a:solidFill>
+                        </a:rPr>
+                        <a:t>6-bucket tables capped the source at 6 readers - my test rig, not the platform</a:t>
+                      </a:r>
+                    </a:p>
+                  </a:txBody>
+                  <a:tcPr marT="45720" marB="45720">
+                    <a:solidFill>
+                      <a:srgbClr val="FFFFFF"/>
+                    </a:solidFill>
+                  </a:tcPr>
+                </a:tc>
+                <a:tc>
+                  <a:txBody>
+                    <a:bodyPr wrap="square"/>
+                    <a:lstStyle/>
+                    <a:p>
+                      <a:r>
+                        <a:rPr sz="1200">
+                          <a:solidFill>
+                            <a:srgbClr val="0B0B0B"/>
+                          </a:solidFill>
+                        </a:rPr>
+                        <a:t>ceiling was mine</a:t>
+                      </a:r>
+                    </a:p>
+                  </a:txBody>
+                  <a:tcPr marT="45720" marB="45720">
+                    <a:solidFill>
+                      <a:srgbClr val="FFFFFF"/>
+                    </a:solidFill>
+                  </a:tcPr>
+                </a:tc>
+              </a:tr>
+              <a:tr h="365760">
+                <a:tc>
+                  <a:txBody>
+                    <a:bodyPr wrap="square"/>
+                    <a:lstStyle/>
+                    <a:p>
+                      <a:r>
+                        <a:rPr sz="1200">
+                          <a:solidFill>
+                            <a:srgbClr val="0B0B0B"/>
+                          </a:solidFill>
+                        </a:rPr>
+                        <a:t>Confluent scales 1.5x</a:t>
+                      </a:r>
+                    </a:p>
+                  </a:txBody>
+                  <a:tcPr marT="45720" marB="45720">
+                    <a:solidFill>
+                      <a:srgbClr val="F0EFEC"/>
+                    </a:solidFill>
+                  </a:tcPr>
+                </a:tc>
+                <a:tc>
+                  <a:txBody>
+                    <a:bodyPr wrap="square"/>
+                    <a:lstStyle/>
+                    <a:p>
+                      <a:r>
+                        <a:rPr sz="1200">
+                          <a:solidFill>
+                            <a:srgbClr val="0B0B0B"/>
+                          </a:solidFill>
+                        </a:rPr>
+                        <a:t>Compared runs with different backlog sizes; ramp-up penalises the smaller one</a:t>
+                      </a:r>
+                    </a:p>
+                  </a:txBody>
+                  <a:tcPr marT="45720" marB="45720">
+                    <a:solidFill>
+                      <a:srgbClr val="F0EFEC"/>
+                    </a:solidFill>
+                  </a:tcPr>
+                </a:tc>
+                <a:tc>
+                  <a:txBody>
+                    <a:bodyPr wrap="square"/>
+                    <a:lstStyle/>
+                    <a:p>
+                      <a:r>
+                        <a:rPr sz="1200">
+                          <a:solidFill>
+                            <a:srgbClr val="0B0B0B"/>
+                          </a:solidFill>
+                        </a:rPr>
+                        <a:t>no scaling at all</a:t>
+                      </a:r>
+                    </a:p>
+                  </a:txBody>
+                  <a:tcPr marT="45720" marB="45720">
+                    <a:solidFill>
+                      <a:srgbClr val="F0EFEC"/>
+                    </a:solidFill>
+                  </a:tcPr>
+                </a:tc>
+              </a:tr>
+              <a:tr h="365760">
+                <a:tc>
+                  <a:txBody>
+                    <a:bodyPr wrap="square"/>
+                    <a:lstStyle/>
+                    <a:p>
+                      <a:r>
+                        <a:rPr sz="1200">
+                          <a:solidFill>
+                            <a:srgbClr val="0B0B0B"/>
+                          </a:solidFill>
+                        </a:rPr>
+                        <a:t>~$1.09/hr on AWS</a:t>
+                      </a:r>
+                    </a:p>
+                  </a:txBody>
+                  <a:tcPr marT="45720" marB="45720">
+                    <a:solidFill>
+                      <a:srgbClr val="FFFFFF"/>
+                    </a:solidFill>
+                  </a:tcPr>
+                </a:tc>
+                <a:tc>
+                  <a:txBody>
+                    <a:bodyPr wrap="square"/>
+                    <a:lstStyle/>
+                    <a:p>
+                      <a:r>
+                        <a:rPr sz="1200">
+                          <a:solidFill>
+                            <a:srgbClr val="0B0B0B"/>
+                          </a:solidFill>
+                        </a:rPr>
+                        <a:t>Omitted the Kafka base charge entirely</a:t>
+                      </a:r>
+                    </a:p>
+                  </a:txBody>
+                  <a:tcPr marT="45720" marB="45720">
+                    <a:solidFill>
+                      <a:srgbClr val="FFFFFF"/>
+                    </a:solidFill>
+                  </a:tcPr>
+                </a:tc>
+                <a:tc>
+                  <a:txBody>
+                    <a:bodyPr wrap="square"/>
+                    <a:lstStyle/>
+                    <a:p>
+                      <a:r>
+                        <a:rPr sz="1200">
+                          <a:solidFill>
+                            <a:srgbClr val="0B0B0B"/>
+                          </a:solidFill>
+                        </a:rPr>
+                        <a:t>$1.84/hr</a:t>
+                      </a:r>
+                    </a:p>
+                  </a:txBody>
+                  <a:tcPr marT="45720" marB="45720">
+                    <a:solidFill>
+                      <a:srgbClr val="FFFFFF"/>
+                    </a:solidFill>
+                  </a:tcPr>
+                </a:tc>
+              </a:tr>
+            </a:tbl>
+          </a:graphicData>
+        </a:graphic>
+      </p:graphicFrame>
+      <p:sp>
+        <p:nvSpPr>
+          <p:cNvPr id="6" name="TextBox 5"/>
           <p:cNvSpPr txBox="1"/>
           <p:nvPr/>
         </p:nvSpPr>
         <p:spPr>
           <a:xfrm>
-            <a:off x="640080" y="1737360"/>
+            <a:off x="640080" y="5120640"/>
             <a:ext cx="10881360" cy="4754880"/>
           </a:xfrm>
           <a:prstGeom prst="rect">
@@ -3536,91 +3954,61 @@
           <a:p>
             <a:pPr>
               <a:spcAft>
-                <a:spcPts val="1200"/>
+                <a:spcPts val="900"/>
               </a:spcAft>
             </a:pPr>
             <a:r>
-              <a:rPr sz="1800" b="0">
-                <a:solidFill>
-                  <a:srgbClr val="0B0B0B"/>
-                </a:solidFill>
-              </a:rPr>
-              <a:t>• Terraform stack complete: MSK Serverless (Kafka) + Amazon Managed Service for Apache Flink + generator on Fargate + CloudWatch dashboard</a:t>
+              <a:rPr sz="1500" b="1">
+                <a:solidFill>
+                  <a:srgbClr val="2A78D6"/>
+                </a:solidFill>
+              </a:rPr>
+              <a:t>• The root cause of the worst one: I checked on every test that records went IN. I never checked that records came OUT</a:t>
             </a:r>
           </a:p>
           <a:p>
             <a:pPr>
               <a:spcAft>
-                <a:spcPts val="1200"/>
+                <a:spcPts val="900"/>
               </a:spcAft>
             </a:pPr>
             <a:r>
-              <a:rPr sz="1800" b="1">
+              <a:rPr sz="1500" b="0">
                 <a:solidFill>
                   <a:srgbClr val="0B0B0B"/>
                 </a:solidFill>
               </a:rPr>
-              <a:t>• The exact same application jar runs on AWS — every environment difference is configuration</a:t>
+              <a:t>• A pipeline that reads fast and writes nothing scores beautifully on a throughput metric</a:t>
             </a:r>
           </a:p>
           <a:p>
             <a:pPr>
               <a:spcAft>
-                <a:spcPts val="1200"/>
+                <a:spcPts val="900"/>
               </a:spcAft>
             </a:pPr>
             <a:r>
-              <a:rPr sz="1800" b="0">
-                <a:solidFill>
-                  <a:srgbClr val="0B0B0B"/>
-                </a:solidFill>
-              </a:rPr>
-              <a:t>• Security by default: private VPC, IAM auth to Kafka, least-privilege roles</a:t>
+              <a:rPr sz="1500" b="1">
+                <a:solidFill>
+                  <a:srgbClr val="008300"/>
+                </a:solidFill>
+              </a:rPr>
+              <a:t>• The optimisation I argued would slow things down made them 2.66x faster - the test took 20 minutes, the argument would have shipped a version a third as fast</a:t>
             </a:r>
           </a:p>
           <a:p>
             <a:pPr>
               <a:spcAft>
-                <a:spcPts val="1200"/>
+                <a:spcPts val="900"/>
               </a:spcAft>
             </a:pPr>
             <a:r>
-              <a:rPr sz="1800" b="0">
+              <a:rPr sz="1500" b="1">
                 <a:solidFill>
                   <a:srgbClr val="0B0B0B"/>
                 </a:solidFill>
               </a:rPr>
-              <a:t>• Operations runbook: deploy, in-place code update, config-only rescale, teardown</a:t>
-            </a:r>
-          </a:p>
-          <a:p>
-            <a:pPr>
-              <a:spcAft>
-                <a:spcPts val="1200"/>
-              </a:spcAft>
-            </a:pPr>
-            <a:r>
-              <a:rPr sz="1800" b="0">
-                <a:solidFill>
-                  <a:srgbClr val="0B0B0B"/>
-                </a:solidFill>
-              </a:rPr>
-              <a:t>• Demo cost ≈ $1/hour while running; destroyed when not in use</a:t>
-            </a:r>
-          </a:p>
-          <a:p>
-            <a:pPr>
-              <a:spcAft>
-                <a:spcPts val="1200"/>
-              </a:spcAft>
-            </a:pPr>
-            <a:r>
-              <a:rPr sz="1800" b="1">
-                <a:solidFill>
-                  <a:srgbClr val="008300"/>
-                </a:solidFill>
-              </a:rPr>
-              <a:t>• Status: DEPLOYED and load-tested on AWS — all cases green, scaling ladder measured, then torn down cleanly</a:t>
+              <a:t>• Benchmarks mostly measure the person running them</a:t>
             </a:r>
           </a:p>
         </p:txBody>
@@ -3671,6 +4059,246 @@
                   <a:srgbClr val="0B0B0B"/>
                 </a:solidFill>
               </a:rPr>
+              <a:t>Path to production — AWS ready today</a:t>
+            </a:r>
+          </a:p>
+        </p:txBody>
+      </p:sp>
+      <p:sp>
+        <p:nvSpPr>
+          <p:cNvPr id="3" name="Rectangle 2"/>
+          <p:cNvSpPr/>
+          <p:nvPr/>
+        </p:nvSpPr>
+        <p:spPr>
+          <a:xfrm>
+            <a:off x="594360" y="1051560"/>
+            <a:ext cx="2011680" cy="50800"/>
+          </a:xfrm>
+          <a:prstGeom prst="rect">
+            <a:avLst/>
+          </a:prstGeom>
+          <a:solidFill>
+            <a:srgbClr val="2A78D6"/>
+          </a:solidFill>
+          <a:ln>
+            <a:noFill/>
+          </a:ln>
+        </p:spPr>
+        <p:style>
+          <a:lnRef idx="1">
+            <a:schemeClr val="accent1"/>
+          </a:lnRef>
+          <a:fillRef idx="3">
+            <a:schemeClr val="accent1"/>
+          </a:fillRef>
+          <a:effectRef idx="2">
+            <a:schemeClr val="accent1"/>
+          </a:effectRef>
+          <a:fontRef idx="minor">
+            <a:schemeClr val="lt1"/>
+          </a:fontRef>
+        </p:style>
+        <p:txBody>
+          <a:bodyPr rtlCol="0" anchor="ctr"/>
+          <a:lstStyle/>
+          <a:p>
+            <a:pPr algn="ctr"/>
+          </a:p>
+        </p:txBody>
+      </p:sp>
+      <p:sp>
+        <p:nvSpPr>
+          <p:cNvPr id="4" name="TextBox 3"/>
+          <p:cNvSpPr txBox="1"/>
+          <p:nvPr/>
+        </p:nvSpPr>
+        <p:spPr>
+          <a:xfrm>
+            <a:off x="548640" y="1143000"/>
+            <a:ext cx="11064240" cy="457200"/>
+          </a:xfrm>
+          <a:prstGeom prst="rect">
+            <a:avLst/>
+          </a:prstGeom>
+          <a:noFill/>
+        </p:spPr>
+        <p:txBody>
+          <a:bodyPr wrap="square">
+            <a:spAutoFit/>
+          </a:bodyPr>
+          <a:lstStyle/>
+          <a:p>
+            <a:r>
+              <a:rPr sz="1500">
+                <a:solidFill>
+                  <a:srgbClr val="52514E"/>
+                </a:solidFill>
+              </a:rPr>
+              <a:t>Full infrastructure-as-code, validated; one command to deploy</a:t>
+            </a:r>
+          </a:p>
+        </p:txBody>
+      </p:sp>
+      <p:sp>
+        <p:nvSpPr>
+          <p:cNvPr id="5" name="TextBox 4"/>
+          <p:cNvSpPr txBox="1"/>
+          <p:nvPr/>
+        </p:nvSpPr>
+        <p:spPr>
+          <a:xfrm>
+            <a:off x="640080" y="1737360"/>
+            <a:ext cx="10881360" cy="4754880"/>
+          </a:xfrm>
+          <a:prstGeom prst="rect">
+            <a:avLst/>
+          </a:prstGeom>
+          <a:noFill/>
+        </p:spPr>
+        <p:txBody>
+          <a:bodyPr wrap="square">
+            <a:spAutoFit/>
+          </a:bodyPr>
+          <a:lstStyle/>
+          <a:p>
+            <a:pPr>
+              <a:spcAft>
+                <a:spcPts val="1200"/>
+              </a:spcAft>
+            </a:pPr>
+            <a:r>
+              <a:rPr sz="1800" b="0">
+                <a:solidFill>
+                  <a:srgbClr val="0B0B0B"/>
+                </a:solidFill>
+              </a:rPr>
+              <a:t>• Terraform stack complete: MSK Serverless (Kafka) + Amazon Managed Service for Apache Flink + generator on Fargate + CloudWatch dashboard</a:t>
+            </a:r>
+          </a:p>
+          <a:p>
+            <a:pPr>
+              <a:spcAft>
+                <a:spcPts val="1200"/>
+              </a:spcAft>
+            </a:pPr>
+            <a:r>
+              <a:rPr sz="1800" b="1">
+                <a:solidFill>
+                  <a:srgbClr val="0B0B0B"/>
+                </a:solidFill>
+              </a:rPr>
+              <a:t>• The exact same application jar runs on AWS — every environment difference is configuration</a:t>
+            </a:r>
+          </a:p>
+          <a:p>
+            <a:pPr>
+              <a:spcAft>
+                <a:spcPts val="1200"/>
+              </a:spcAft>
+            </a:pPr>
+            <a:r>
+              <a:rPr sz="1800" b="0">
+                <a:solidFill>
+                  <a:srgbClr val="0B0B0B"/>
+                </a:solidFill>
+              </a:rPr>
+              <a:t>• Security by default: private VPC, IAM auth to Kafka, least-privilege roles</a:t>
+            </a:r>
+          </a:p>
+          <a:p>
+            <a:pPr>
+              <a:spcAft>
+                <a:spcPts val="1200"/>
+              </a:spcAft>
+            </a:pPr>
+            <a:r>
+              <a:rPr sz="1800" b="0">
+                <a:solidFill>
+                  <a:srgbClr val="0B0B0B"/>
+                </a:solidFill>
+              </a:rPr>
+              <a:t>• Operations runbook: deploy, in-place code update, config-only rescale, teardown</a:t>
+            </a:r>
+          </a:p>
+          <a:p>
+            <a:pPr>
+              <a:spcAft>
+                <a:spcPts val="1200"/>
+              </a:spcAft>
+            </a:pPr>
+            <a:r>
+              <a:rPr sz="1800" b="0">
+                <a:solidFill>
+                  <a:srgbClr val="0B0B0B"/>
+                </a:solidFill>
+              </a:rPr>
+              <a:t>• Demo cost ≈ $1/hour while running; destroyed when not in use</a:t>
+            </a:r>
+          </a:p>
+          <a:p>
+            <a:pPr>
+              <a:spcAft>
+                <a:spcPts val="1200"/>
+              </a:spcAft>
+            </a:pPr>
+            <a:r>
+              <a:rPr sz="1800" b="1">
+                <a:solidFill>
+                  <a:srgbClr val="008300"/>
+                </a:solidFill>
+              </a:rPr>
+              <a:t>• Status: DEPLOYED and load-tested on AWS — all cases green, scaling ladder measured, then torn down cleanly</a:t>
+            </a:r>
+          </a:p>
+        </p:txBody>
+      </p:sp>
+    </p:spTree>
+  </p:cSld>
+  <p:clrMapOvr>
+    <a:masterClrMapping/>
+  </p:clrMapOvr>
+</p:sld>
+</file>
+
+<file path=ppt/slides/slide12.xml><?xml version="1.0" encoding="utf-8"?>
+<p:sld xmlns:a="http://schemas.openxmlformats.org/drawingml/2006/main" xmlns:p="http://schemas.openxmlformats.org/presentationml/2006/main" xmlns:r="http://schemas.openxmlformats.org/officeDocument/2006/relationships">
+  <p:cSld>
+    <p:spTree>
+      <p:nvGrpSpPr>
+        <p:cNvPr id="1" name=""/>
+        <p:cNvGrpSpPr/>
+        <p:nvPr/>
+      </p:nvGrpSpPr>
+      <p:grpSpPr/>
+      <p:sp>
+        <p:nvSpPr>
+          <p:cNvPr id="2" name="TextBox 1"/>
+          <p:cNvSpPr txBox="1"/>
+          <p:nvPr/>
+        </p:nvSpPr>
+        <p:spPr>
+          <a:xfrm>
+            <a:off x="548640" y="320040"/>
+            <a:ext cx="11064240" cy="914400"/>
+          </a:xfrm>
+          <a:prstGeom prst="rect">
+            <a:avLst/>
+          </a:prstGeom>
+          <a:noFill/>
+        </p:spPr>
+        <p:txBody>
+          <a:bodyPr wrap="square">
+            <a:spAutoFit/>
+          </a:bodyPr>
+          <a:lstStyle/>
+          <a:p>
+            <a:r>
+              <a:rPr sz="3000" b="1">
+                <a:solidFill>
+                  <a:srgbClr val="0B0B0B"/>
+                </a:solidFill>
+              </a:rPr>
               <a:t>What it took to build</a:t>
             </a:r>
           </a:p>
@@ -4128,7 +4756,7 @@
 </p:sld>
 </file>
 
-<file path=ppt/slides/slide12.xml><?xml version="1.0" encoding="utf-8"?>
+<file path=ppt/slides/slide13.xml><?xml version="1.0" encoding="utf-8"?>
 <p:sld xmlns:a="http://schemas.openxmlformats.org/drawingml/2006/main" xmlns:p="http://schemas.openxmlformats.org/presentationml/2006/main" xmlns:r="http://schemas.openxmlformats.org/officeDocument/2006/relationships">
   <p:cSld>
     <p:spTree>
@@ -7708,7 +8336,7 @@
                   <a:srgbClr val="52514E"/>
                 </a:solidFill>
               </a:rPr>
-              <a:t>Same requirements, same data, same five correctness checks; deployable configs only</a:t>
+              <a:t>Same requirements, same data, same five correctness checks; every figure output-verified</a:t>
             </a:r>
           </a:p>
         </p:txBody>
@@ -7722,8 +8350,8 @@
           <p:nvPr/>
         </p:nvGraphicFramePr>
         <p:xfrm>
-          <a:off x="640080" y="1645920"/>
-          <a:ext cx="10972800" cy="3291840"/>
+          <a:off x="640080" y="1554480"/>
+          <a:ext cx="10972800" cy="4023360"/>
         </p:xfrm>
         <a:graphic>
           <a:graphicData uri="http://schemas.openxmlformats.org/drawingml/2006/table">
@@ -7743,7 +8371,7 @@
                     <a:lstStyle/>
                     <a:p>
                       <a:r>
-                        <a:rPr sz="1300" b="1">
+                        <a:rPr sz="1200" b="1">
                           <a:solidFill>
                             <a:srgbClr val="FFFFFF"/>
                           </a:solidFill>
@@ -7764,7 +8392,7 @@
                     <a:lstStyle/>
                     <a:p>
                       <a:r>
-                        <a:rPr sz="1300" b="1">
+                        <a:rPr sz="1200" b="1">
                           <a:solidFill>
                             <a:srgbClr val="FFFFFF"/>
                           </a:solidFill>
@@ -7785,7 +8413,7 @@
                     <a:lstStyle/>
                     <a:p>
                       <a:r>
-                        <a:rPr sz="1300" b="1">
+                        <a:rPr sz="1200" b="1">
                           <a:solidFill>
                             <a:srgbClr val="FFFFFF"/>
                           </a:solidFill>
@@ -7808,7 +8436,7 @@
                     <a:lstStyle/>
                     <a:p>
                       <a:r>
-                        <a:rPr sz="1300">
+                        <a:rPr sz="1200">
                           <a:solidFill>
                             <a:srgbClr val="0B0B0B"/>
                           </a:solidFill>
@@ -7829,7 +8457,7 @@
                     <a:lstStyle/>
                     <a:p>
                       <a:r>
-                        <a:rPr sz="1300">
+                        <a:rPr sz="1200">
                           <a:solidFill>
                             <a:srgbClr val="0B0B0B"/>
                           </a:solidFill>
@@ -7850,7 +8478,7 @@
                     <a:lstStyle/>
                     <a:p>
                       <a:r>
-                        <a:rPr sz="1300">
+                        <a:rPr sz="1200">
                           <a:solidFill>
                             <a:srgbClr val="0B0B0B"/>
                           </a:solidFill>
@@ -7873,12 +8501,12 @@
                     <a:lstStyle/>
                     <a:p>
                       <a:r>
-                        <a:rPr sz="1300">
+                        <a:rPr sz="1200">
                           <a:solidFill>
                             <a:srgbClr val="0B0B0B"/>
                           </a:solidFill>
                         </a:rPr>
-                        <a:t>End-to-end latency (live)</a:t>
+                        <a:t>Throughput - DataStream (Java)</a:t>
                       </a:r>
                     </a:p>
                   </a:txBody>
@@ -7894,12 +8522,12 @@
                     <a:lstStyle/>
                     <a:p>
                       <a:r>
-                        <a:rPr sz="1300">
+                        <a:rPr sz="1200">
                           <a:solidFill>
                             <a:srgbClr val="0B0B0B"/>
                           </a:solidFill>
                         </a:rPr>
-                        <a:t>p50 267 ms  /  p99 495 ms</a:t>
+                        <a:t>146,300 rec/sec</a:t>
                       </a:r>
                     </a:p>
                   </a:txBody>
@@ -7915,12 +8543,12 @@
                     <a:lstStyle/>
                     <a:p>
                       <a:r>
-                        <a:rPr sz="1300">
+                        <a:rPr sz="1200">
                           <a:solidFill>
                             <a:srgbClr val="0B0B0B"/>
                           </a:solidFill>
                         </a:rPr>
-                        <a:t>p50 1.8 s  /  p99 2.1 s (SQL tuned for latency)</a:t>
+                        <a:t>not offered - SQL only</a:t>
                       </a:r>
                     </a:p>
                   </a:txBody>
@@ -7938,12 +8566,12 @@
                     <a:lstStyle/>
                     <a:p>
                       <a:r>
-                        <a:rPr sz="1300">
+                        <a:rPr sz="1200">
                           <a:solidFill>
                             <a:srgbClr val="0B0B0B"/>
                           </a:solidFill>
                         </a:rPr>
-                        <a:t>Full pipeline throughput</a:t>
+                        <a:t>Throughput - the same SQL</a:t>
                       </a:r>
                     </a:p>
                   </a:txBody>
@@ -7959,12 +8587,12 @@
                     <a:lstStyle/>
                     <a:p>
                       <a:r>
-                        <a:rPr sz="1300">
+                        <a:rPr sz="1200">
                           <a:solidFill>
                             <a:srgbClr val="0B0B0B"/>
                           </a:solidFill>
                         </a:rPr>
-                        <a:t>435,000 msgs/sec</a:t>
+                        <a:t>76,956 rec/sec</a:t>
                       </a:r>
                     </a:p>
                   </a:txBody>
@@ -7980,12 +8608,12 @@
                     <a:lstStyle/>
                     <a:p>
                       <a:r>
-                        <a:rPr sz="1300">
+                        <a:rPr sz="1200">
                           <a:solidFill>
                             <a:srgbClr val="0B0B0B"/>
                           </a:solidFill>
                         </a:rPr>
-                        <a:t>127,000 msgs/sec</a:t>
+                        <a:t>39,400 - 90,600 rec/sec</a:t>
                       </a:r>
                     </a:p>
                   </a:txBody>
@@ -8003,12 +8631,12 @@
                     <a:lstStyle/>
                     <a:p>
                       <a:r>
-                        <a:rPr sz="1300">
+                        <a:rPr sz="1200">
                           <a:solidFill>
                             <a:srgbClr val="0B0B0B"/>
                           </a:solidFill>
                         </a:rPr>
-                        <a:t>Sustained 28 min</a:t>
+                        <a:t>Run-to-run variance</a:t>
                       </a:r>
                     </a:p>
                   </a:txBody>
@@ -8024,12 +8652,12 @@
                     <a:lstStyle/>
                     <a:p>
                       <a:r>
-                        <a:rPr sz="1300">
+                        <a:rPr sz="1200">
                           <a:solidFill>
                             <a:srgbClr val="0B0B0B"/>
                           </a:solidFill>
                         </a:rPr>
-                        <a:t>232,705/sec, deviation 30/sec</a:t>
+                        <a:t>~25% - gaps below that are noise</a:t>
                       </a:r>
                     </a:p>
                   </a:txBody>
@@ -8045,12 +8673,12 @@
                     <a:lstStyle/>
                     <a:p>
                       <a:r>
-                        <a:rPr sz="1300">
+                        <a:rPr sz="1200">
                           <a:solidFill>
                             <a:srgbClr val="0B0B0B"/>
                           </a:solidFill>
                         </a:rPr>
-                        <a:t>360,900/sec, deviation 63,900/sec</a:t>
+                        <a:t>~25%</a:t>
                       </a:r>
                     </a:p>
                   </a:txBody>
@@ -8068,12 +8696,12 @@
                     <a:lstStyle/>
                     <a:p>
                       <a:r>
-                        <a:rPr sz="1300">
+                        <a:rPr sz="1200">
                           <a:solidFill>
                             <a:srgbClr val="0B0B0B"/>
                           </a:solidFill>
                         </a:rPr>
-                        <a:t>Cost at equal work</a:t>
+                        <a:t>Scaling</a:t>
                       </a:r>
                     </a:p>
                   </a:txBody>
@@ -8089,12 +8717,12 @@
                     <a:lstStyle/>
                     <a:p>
                       <a:r>
-                        <a:rPr sz="1300">
+                        <a:rPr sz="1200">
                           <a:solidFill>
                             <a:srgbClr val="0B0B0B"/>
                           </a:solidFill>
                         </a:rPr>
-                        <a:t>~ $2.39/hr all-in</a:t>
+                        <a:t>bounded by the workload: 10 tickers cap parallelism at 10</a:t>
                       </a:r>
                     </a:p>
                   </a:txBody>
@@ -8110,12 +8738,12 @@
                     <a:lstStyle/>
                     <a:p>
                       <a:r>
-                        <a:rPr sz="1300">
+                        <a:rPr sz="1200">
                           <a:solidFill>
                             <a:srgbClr val="0B0B0B"/>
                           </a:solidFill>
                         </a:rPr>
-                        <a:t>~ $3.36/hr + usage</a:t>
+                        <a:t>pool allowed 20 CFU drew a measured max of 10</a:t>
                       </a:r>
                     </a:p>
                   </a:txBody>
@@ -8133,7 +8761,137 @@
                     <a:lstStyle/>
                     <a:p>
                       <a:r>
-                        <a:rPr sz="1300">
+                        <a:rPr sz="1200">
+                          <a:solidFill>
+                            <a:srgbClr val="0B0B0B"/>
+                          </a:solidFill>
+                        </a:rPr>
+                        <a:t>Cost (known)</a:t>
+                      </a:r>
+                    </a:p>
+                  </a:txBody>
+                  <a:tcPr marT="45720" marB="45720">
+                    <a:solidFill>
+                      <a:srgbClr val="F0EFEC"/>
+                    </a:solidFill>
+                  </a:tcPr>
+                </a:tc>
+                <a:tc>
+                  <a:txBody>
+                    <a:bodyPr wrap="square"/>
+                    <a:lstStyle/>
+                    <a:p>
+                      <a:r>
+                        <a:rPr sz="1200">
+                          <a:solidFill>
+                            <a:srgbClr val="0B0B0B"/>
+                          </a:solidFill>
+                        </a:rPr>
+                        <a:t>$1.84/hr - 64% of it Kafka, not Flink</a:t>
+                      </a:r>
+                    </a:p>
+                  </a:txBody>
+                  <a:tcPr marT="45720" marB="45720">
+                    <a:solidFill>
+                      <a:srgbClr val="F0EFEC"/>
+                    </a:solidFill>
+                  </a:tcPr>
+                </a:tc>
+                <a:tc>
+                  <a:txBody>
+                    <a:bodyPr wrap="square"/>
+                    <a:lstStyle/>
+                    <a:p>
+                      <a:r>
+                        <a:rPr sz="1200">
+                          <a:solidFill>
+                            <a:srgbClr val="0B0B0B"/>
+                          </a:solidFill>
+                        </a:rPr>
+                        <a:t>compute measured; cluster charge not captured</a:t>
+                      </a:r>
+                    </a:p>
+                  </a:txBody>
+                  <a:tcPr marT="45720" marB="45720">
+                    <a:solidFill>
+                      <a:srgbClr val="F0EFEC"/>
+                    </a:solidFill>
+                  </a:tcPr>
+                </a:tc>
+              </a:tr>
+              <a:tr h="365760">
+                <a:tc>
+                  <a:txBody>
+                    <a:bodyPr wrap="square"/>
+                    <a:lstStyle/>
+                    <a:p>
+                      <a:r>
+                        <a:rPr sz="1200">
+                          <a:solidFill>
+                            <a:srgbClr val="0B0B0B"/>
+                          </a:solidFill>
+                        </a:rPr>
+                        <a:t>Partitions</a:t>
+                      </a:r>
+                    </a:p>
+                  </a:txBody>
+                  <a:tcPr marT="45720" marB="45720">
+                    <a:solidFill>
+                      <a:srgbClr val="FFFFFF"/>
+                    </a:solidFill>
+                  </a:tcPr>
+                </a:tc>
+                <a:tc>
+                  <a:txBody>
+                    <a:bodyPr wrap="square"/>
+                    <a:lstStyle/>
+                    <a:p>
+                      <a:r>
+                        <a:rPr sz="1200">
+                          <a:solidFill>
+                            <a:srgbClr val="0B0B0B"/>
+                          </a:solidFill>
+                        </a:rPr>
+                        <a:t>billed: $0.0015/partition-hr</a:t>
+                      </a:r>
+                    </a:p>
+                  </a:txBody>
+                  <a:tcPr marT="45720" marB="45720">
+                    <a:solidFill>
+                      <a:srgbClr val="FFFFFF"/>
+                    </a:solidFill>
+                  </a:tcPr>
+                </a:tc>
+                <a:tc>
+                  <a:txBody>
+                    <a:bodyPr wrap="square"/>
+                    <a:lstStyle/>
+                    <a:p>
+                      <a:r>
+                        <a:rPr sz="1200">
+                          <a:solidFill>
+                            <a:srgbClr val="0B0B0B"/>
+                          </a:solidFill>
+                        </a:rPr>
+                        <a:t>free</a:t>
+                      </a:r>
+                    </a:p>
+                  </a:txBody>
+                  <a:tcPr marT="45720" marB="45720">
+                    <a:solidFill>
+                      <a:srgbClr val="FFFFFF"/>
+                    </a:solidFill>
+                  </a:tcPr>
+                </a:tc>
+              </a:tr>
+              <a:tr h="365760">
+                <a:tc>
+                  <a:txBody>
+                    <a:bodyPr wrap="square"/>
+                    <a:lstStyle/>
+                    <a:p>
+                      <a:r>
+                        <a:rPr sz="1200">
                           <a:solidFill>
                             <a:srgbClr val="0B0B0B"/>
                           </a:solidFill>
@@ -8154,7 +8912,7 @@
                     <a:lstStyle/>
                     <a:p>
                       <a:r>
-                        <a:rPr sz="1300">
+                        <a:rPr sz="1200">
                           <a:solidFill>
                             <a:srgbClr val="0B0B0B"/>
                           </a:solidFill>
@@ -8175,7 +8933,7 @@
                     <a:lstStyle/>
                     <a:p>
                       <a:r>
-                        <a:rPr sz="1300">
+                        <a:rPr sz="1200">
                           <a:solidFill>
                             <a:srgbClr val="0B0B0B"/>
                           </a:solidFill>
@@ -8198,12 +8956,12 @@
                     <a:lstStyle/>
                     <a:p>
                       <a:r>
-                        <a:rPr sz="1300">
+                        <a:rPr sz="1200">
                           <a:solidFill>
                             <a:srgbClr val="0B0B0B"/>
                           </a:solidFill>
                         </a:rPr>
-                        <a:t>What you operate</a:t>
+                        <a:t>Rate-limit an output</a:t>
                       </a:r>
                     </a:p>
                   </a:txBody>
@@ -8219,12 +8977,12 @@
                     <a:lstStyle/>
                     <a:p>
                       <a:r>
-                        <a:rPr sz="1300">
+                        <a:rPr sz="1200">
                           <a:solidFill>
                             <a:srgbClr val="0B0B0B"/>
                           </a:solidFill>
                         </a:rPr>
-                        <a:t>a jar, an image, a VPC</a:t>
+                        <a:t>one connector option</a:t>
                       </a:r>
                     </a:p>
                   </a:txBody>
@@ -8240,12 +8998,12 @@
                     <a:lstStyle/>
                     <a:p>
                       <a:r>
-                        <a:rPr sz="1300">
+                        <a:rPr sz="1200">
                           <a:solidFill>
                             <a:srgbClr val="0B0B0B"/>
                           </a:solidFill>
                         </a:rPr>
-                        <a:t>statements - nothing to deploy</a:t>
+                        <a:t>NOT EXPRESSIBLE</a:t>
                       </a:r>
                     </a:p>
                   </a:txBody>
@@ -8263,12 +9021,12 @@
                     <a:lstStyle/>
                     <a:p>
                       <a:r>
-                        <a:rPr sz="1300">
+                        <a:rPr sz="1200">
                           <a:solidFill>
                             <a:srgbClr val="0B0B0B"/>
                           </a:solidFill>
                         </a:rPr>
-                        <a:t>Rate-limit an output (CR-1)</a:t>
+                        <a:t>Bad query shapes</a:t>
                       </a:r>
                     </a:p>
                   </a:txBody>
@@ -8284,12 +9042,12 @@
                     <a:lstStyle/>
                     <a:p>
                       <a:r>
-                        <a:rPr sz="1300">
+                        <a:rPr sz="1200">
                           <a:solidFill>
                             <a:srgbClr val="0B0B0B"/>
                           </a:solidFill>
                         </a:rPr>
-                        <a:t>config change - 0.96/key/sec vs 1.0 cap</a:t>
+                        <a:t>silent - found by reading a plan</a:t>
                       </a:r>
                     </a:p>
                   </a:txBody>
@@ -8305,12 +9063,12 @@
                     <a:lstStyle/>
                     <a:p>
                       <a:r>
-                        <a:rPr sz="1300">
+                        <a:rPr sz="1200">
                           <a:solidFill>
                             <a:srgbClr val="0B0B0B"/>
                           </a:solidFill>
                         </a:rPr>
-                        <a:t>NOT EXPRESSIBLE for updating aggregations</a:t>
+                        <a:t>named in the console with a doc link</a:t>
                       </a:r>
                     </a:p>
                   </a:txBody>
@@ -8333,7 +9091,7 @@
         </p:nvSpPr>
         <p:spPr>
           <a:xfrm>
-            <a:off x="640080" y="5394960"/>
+            <a:off x="640080" y="5486400"/>
             <a:ext cx="10881360" cy="4754880"/>
           </a:xfrm>
           <a:prstGeom prst="rect">
@@ -8349,46 +9107,61 @@
           <a:p>
             <a:pPr>
               <a:spcAft>
-                <a:spcPts val="900"/>
+                <a:spcPts val="800"/>
               </a:spcAft>
             </a:pPr>
             <a:r>
-              <a:rPr sz="1500" b="1">
+              <a:rPr sz="1400" b="1">
                 <a:solidFill>
                   <a:srgbClr val="008300"/>
                 </a:solidFill>
               </a:rPr>
-              <a:t>• AWS is faster, cheaper and steadier: one job passes records between operators in memory</a:t>
+              <a:t>• Java is ~2x faster than SQL on identical hardware, load and logic - that gap is real and outside the noise</a:t>
             </a:r>
           </a:p>
           <a:p>
             <a:pPr>
               <a:spcAft>
-                <a:spcPts val="900"/>
+                <a:spcPts val="800"/>
               </a:spcAft>
             </a:pPr>
             <a:r>
-              <a:rPr sz="1500" b="0">
+              <a:rPr sz="1400" b="1">
                 <a:solidFill>
                   <a:srgbClr val="0B0B0B"/>
                 </a:solidFill>
               </a:rPr>
-              <a:t>• Confluent is ~10x less code and nothing to deploy - but the SQL must be ONE fused statement set; writing it as chained statements costs 15x latency (26.7s -&gt; 1.8s when fixed)</a:t>
+              <a:t>• SQL runs at the SAME speed on both clouds: the language is the constraint, not the vendor</a:t>
             </a:r>
           </a:p>
           <a:p>
             <a:pPr>
               <a:spcAft>
-                <a:spcPts val="900"/>
+                <a:spcPts val="800"/>
               </a:spcAft>
             </a:pPr>
             <a:r>
-              <a:rPr sz="1500" b="1">
+              <a:rPr sz="1400" b="0">
+                <a:solidFill>
+                  <a:srgbClr val="0B0B0B"/>
+                </a:solidFill>
+              </a:rPr>
+              <a:t>• Neither platform was the scaling limit - the business problem has ten symbols, and ten things do not spread across twenty workers</a:t>
+            </a:r>
+          </a:p>
+          <a:p>
+            <a:pPr>
+              <a:spcAft>
+                <a:spcPts val="800"/>
+              </a:spcAft>
+            </a:pPr>
+            <a:r>
+              <a:rPr sz="1400" b="1">
                 <a:solidFill>
                   <a:srgbClr val="2A78D6"/>
                 </a:solidFill>
               </a:rPr>
-              <a:t>• The deciding factor was not speed: a plain requirement - do not update the screen faster than a human can read - is one config line on DataStream and has no supported construct in Confluent SQL</a:t>
+              <a:t>• The deciding factor was not speed: do not update a screen faster than a human can read is one option on AWS SQL and has no construct in Confluent SQL</a:t>
             </a:r>
           </a:p>
         </p:txBody>

</xml_diff>

<commit_message>
Article and deck rewritten around the Phase 18 findings
Article: adds the clamp discovery in plain language -- a Math.min(requested, 30)
that capped every run at thirty symbols while the plan said three thousand, so
almost every ceiling found was the test data rather than the platforms. Adds the
scaling arc honestly: published "it does not scale", corrected it, corrected the
correction, and the original answer was right. Adds the correctness section --
days of throughput numbers with the validation suite never once run, then
building it properly, watching it fail on 615 market values, and making it PROVE
those were stale-but-real prices rather than waving them away.

Deck: replaces the corrections slide with five withdrawn conclusions, adds a
correctness-before-performance slide, and adds an IPO-day slide with the
producer-side ingest numbers.

Co-Authored-By: Claude Fable 5 <noreply@anthropic.com>
</commit_message>
<xml_diff>
--- a/docs/flink-demo-exec-briefing.pptx
+++ b/docs/flink-demo-exec-briefing.pptx
@@ -18,6 +18,8 @@
     <p:sldId id="266" r:id="rId17"/>
     <p:sldId id="267" r:id="rId18"/>
     <p:sldId id="268" r:id="rId19"/>
+    <p:sldId id="269" r:id="rId20"/>
+    <p:sldId id="270" r:id="rId21"/>
   </p:sldIdLst>
   <p:sldSz cx="12191695" cy="6858000" type="screen4x3"/>
   <p:notesSz cx="6858000" cy="9144000"/>
@@ -3508,7 +3510,7 @@
                   <a:srgbClr val="52514E"/>
                 </a:solidFill>
               </a:rPr>
-              <a:t>Three published conclusions did not survive re-measurement</a:t>
+              <a:t>Five published conclusions did not survive re-measurement</a:t>
             </a:r>
           </a:p>
         </p:txBody>
@@ -3522,7 +3524,7 @@
           <p:nvPr/>
         </p:nvGraphicFramePr>
         <p:xfrm>
-          <a:off x="640080" y="1645920"/>
+          <a:off x="640080" y="1554480"/>
           <a:ext cx="10972800" cy="2194560"/>
         </p:xfrm>
         <a:graphic>
@@ -3532,8 +3534,8 @@
                 <a:tableStyleId>{5C22544A-7EE6-4342-B048-85BDC9FD1C3A}</a:tableStyleId>
               </a:tblPr>
               <a:tblGrid>
-                <a:gridCol w="3108960"/>
-                <a:gridCol w="4937760"/>
+                <a:gridCol w="3017520"/>
+                <a:gridCol w="5029200"/>
                 <a:gridCol w="2926080"/>
               </a:tblGrid>
               <a:tr h="365760">
@@ -3634,7 +3636,7 @@
                             <a:srgbClr val="0B0B0B"/>
                           </a:solidFill>
                         </a:rPr>
-                        <a:t>I wrote one SQL statement per Java operator, so every stage hopped through Kafka</a:t>
+                        <a:t>One SQL statement per Java operator - every stage hopped through Kafka</a:t>
                       </a:r>
                     </a:p>
                   </a:txBody>
@@ -3699,7 +3701,7 @@
                             <a:srgbClr val="0B0B0B"/>
                           </a:solidFill>
                         </a:rPr>
-                        <a:t>That run consumed 119k rec/sec and wrote NOTHING for an hour - status green throughout</a:t>
+                        <a:t>That run consumed 119k rec/sec and wrote NOTHING for an hour - status green</a:t>
                       </a:r>
                     </a:p>
                   </a:txBody>
@@ -3764,7 +3766,7 @@
                             <a:srgbClr val="0B0B0B"/>
                           </a:solidFill>
                         </a:rPr>
-                        <a:t>6-bucket tables capped the source at 6 readers - my test rig, not the platform</a:t>
+                        <a:t>6-bucket tables capped the source at 6 readers - my rig, not the platform</a:t>
                       </a:r>
                     </a:p>
                   </a:txBody>
@@ -3829,7 +3831,7 @@
                             <a:srgbClr val="0B0B0B"/>
                           </a:solidFill>
                         </a:rPr>
-                        <a:t>Compared runs with different backlog sizes; ramp-up penalises the smaller one</a:t>
+                        <a:t>Compared runs with different backlog sizes; ramp-up favours the larger</a:t>
                       </a:r>
                     </a:p>
                   </a:txBody>
@@ -3873,7 +3875,7 @@
                             <a:srgbClr val="0B0B0B"/>
                           </a:solidFill>
                         </a:rPr>
-                        <a:t>~$1.09/hr on AWS</a:t>
+                        <a:t>Every throughput number</a:t>
                       </a:r>
                     </a:p>
                   </a:txBody>
@@ -3894,7 +3896,7 @@
                             <a:srgbClr val="0B0B0B"/>
                           </a:solidFill>
                         </a:rPr>
-                        <a:t>Omitted the Kafka base charge entirely</a:t>
+                        <a:t>Math.min(requested, 30) capped the test data at 30 symbols, not 3,000</a:t>
                       </a:r>
                     </a:p>
                   </a:txBody>
@@ -3915,7 +3917,7 @@
                             <a:srgbClr val="0B0B0B"/>
                           </a:solidFill>
                         </a:rPr>
-                        <a:t>$1.84/hr</a:t>
+                        <a:t>re-measured at 3,000</a:t>
                       </a:r>
                     </a:p>
                   </a:txBody>
@@ -3938,7 +3940,7 @@
         </p:nvSpPr>
         <p:spPr>
           <a:xfrm>
-            <a:off x="640080" y="5120640"/>
+            <a:off x="640080" y="5212080"/>
             <a:ext cx="10881360" cy="4754880"/>
           </a:xfrm>
           <a:prstGeom prst="rect">
@@ -3963,7 +3965,7 @@
                   <a:srgbClr val="2A78D6"/>
                 </a:solidFill>
               </a:rPr>
-              <a:t>• The root cause of the worst one: I checked on every test that records went IN. I never checked that records came OUT</a:t>
+              <a:t>• Root cause of the worst one: I checked on every test that records went IN. I never checked that records came OUT</a:t>
             </a:r>
           </a:p>
           <a:p>
@@ -3993,7 +3995,7 @@
                   <a:srgbClr val="008300"/>
                 </a:solidFill>
               </a:rPr>
-              <a:t>• The optimisation I argued would slow things down made them 2.66x faster - the test took 20 minutes, the argument would have shipped a version a third as fast</a:t>
+              <a:t>• I published 'it does not scale', corrected it, then corrected the correction - and the ORIGINAL answer was right</a:t>
             </a:r>
           </a:p>
           <a:p>
@@ -4059,7 +4061,7 @@
                   <a:srgbClr val="0B0B0B"/>
                 </a:solidFill>
               </a:rPr>
-              <a:t>Path to production — AWS ready today</a:t>
+              <a:t>Fast only counts if the numbers are correct</a:t>
             </a:r>
           </a:p>
         </p:txBody>
@@ -4135,7 +4137,7 @@
                   <a:srgbClr val="52514E"/>
                 </a:solidFill>
               </a:rPr>
-              <a:t>Full infrastructure-as-code, validated; one command to deploy</a:t>
+              <a:t>Days of throughput figures, and the correctness suite had never once run</a:t>
             </a:r>
           </a:p>
         </p:txBody>
@@ -4164,91 +4166,91 @@
           <a:p>
             <a:pPr>
               <a:spcAft>
-                <a:spcPts val="1200"/>
+                <a:spcPts val="1000"/>
               </a:spcAft>
             </a:pPr>
             <a:r>
-              <a:rPr sz="1800" b="0">
+              <a:rPr sz="1500" b="1">
                 <a:solidFill>
                   <a:srgbClr val="0B0B0B"/>
                 </a:solidFill>
               </a:rPr>
-              <a:t>• Terraform stack complete: MSK Serverless (Kafka) + Amazon Managed Service for Apache Flink + generator on Fargate + CloudWatch dashboard</a:t>
+              <a:t>• Six independent checks recompute every position and market value from the RAW topics with exact decimal arithmetic</a:t>
             </a:r>
           </a:p>
           <a:p>
             <a:pPr>
               <a:spcAft>
-                <a:spcPts val="1200"/>
+                <a:spcPts val="1000"/>
               </a:spcAft>
             </a:pPr>
             <a:r>
-              <a:rPr sz="1800" b="1">
+              <a:rPr sz="1500" b="0">
                 <a:solidFill>
                   <a:srgbClr val="0B0B0B"/>
                 </a:solidFill>
               </a:rPr>
-              <a:t>• The exact same application jar runs on AWS — every environment difference is configuration</a:t>
+              <a:t>• Market values asserted against the FINAL RAW price using OUR OWN recomputed position - so a wrong position cannot cancel a wrong price</a:t>
             </a:r>
           </a:p>
           <a:p>
             <a:pPr>
               <a:spcAft>
-                <a:spcPts val="1200"/>
+                <a:spcPts val="1000"/>
               </a:spcAft>
             </a:pPr>
             <a:r>
-              <a:rPr sz="1800" b="0">
+              <a:rPr sz="1500" b="0">
                 <a:solidFill>
                   <a:srgbClr val="0B0B0B"/>
                 </a:solidFill>
               </a:rPr>
-              <a:t>• Security by default: private VPC, IAM auth to Kafka, least-privilege roles</a:t>
+              <a:t>• To make failures legible: every trade 1 share, every symbol its own fixed price. A position is then a count you can verify by eye</a:t>
             </a:r>
           </a:p>
           <a:p>
             <a:pPr>
               <a:spcAft>
-                <a:spcPts val="1200"/>
+                <a:spcPts val="1000"/>
               </a:spcAft>
             </a:pPr>
             <a:r>
-              <a:rPr sz="1800" b="0">
-                <a:solidFill>
-                  <a:srgbClr val="0B0B0B"/>
-                </a:solidFill>
-              </a:rPr>
-              <a:t>• Operations runbook: deploy, in-place code update, config-only rescale, teardown</a:t>
+              <a:rPr sz="1500" b="1">
+                <a:solidFill>
+                  <a:srgbClr val="2A78D6"/>
+                </a:solidFill>
+              </a:rPr>
+              <a:t>• It FAILED - 615 market values wrong. They were each priced at a slightly older tick of the RIGHT symbol</a:t>
             </a:r>
           </a:p>
           <a:p>
             <a:pPr>
               <a:spcAft>
-                <a:spcPts val="1200"/>
+                <a:spcPts val="1000"/>
               </a:spcAft>
             </a:pPr>
             <a:r>
-              <a:rPr sz="1800" b="0">
-                <a:solidFill>
-                  <a:srgbClr val="0B0B0B"/>
-                </a:solidFill>
-              </a:rPr>
-              <a:t>• Demo cost ≈ $1/hour while running; destroyed when not in use</a:t>
+              <a:rPr sz="1500" b="1">
+                <a:solidFill>
+                  <a:srgbClr val="008300"/>
+                </a:solidFill>
+              </a:rPr>
+              <a:t>• Rather than wave it away as known semantics, the checker proves it: the implied price must fall inside the range that symbol actually traded at. All 615 did</a:t>
             </a:r>
           </a:p>
           <a:p>
             <a:pPr>
               <a:spcAft>
-                <a:spcPts val="1200"/>
+                <a:spcPts val="1000"/>
               </a:spcAft>
             </a:pPr>
             <a:r>
-              <a:rPr sz="1800" b="1">
+              <a:rPr sz="1500" b="1">
                 <a:solidFill>
                   <a:srgbClr val="008300"/>
                 </a:solidFill>
               </a:rPr>
-              <a:t>• Status: DEPLOYED and load-tested on AWS — all cases green, scaling ladder measured, then torn down cleanly</a:t>
+              <a:t>• Result: zero wrong answers, plus a 6% staleness characteristic now described honestly instead of hidden behind a green tick</a:t>
             </a:r>
           </a:p>
         </p:txBody>
@@ -4262,6 +4264,914 @@
 </file>
 
 <file path=ppt/slides/slide12.xml><?xml version="1.0" encoding="utf-8"?>
+<p:sld xmlns:a="http://schemas.openxmlformats.org/drawingml/2006/main" xmlns:p="http://schemas.openxmlformats.org/presentationml/2006/main" xmlns:r="http://schemas.openxmlformats.org/officeDocument/2006/relationships">
+  <p:cSld>
+    <p:spTree>
+      <p:nvGrpSpPr>
+        <p:cNvPr id="1" name=""/>
+        <p:cNvGrpSpPr/>
+        <p:nvPr/>
+      </p:nvGrpSpPr>
+      <p:grpSpPr/>
+      <p:sp>
+        <p:nvSpPr>
+          <p:cNvPr id="2" name="TextBox 1"/>
+          <p:cNvSpPr txBox="1"/>
+          <p:nvPr/>
+        </p:nvSpPr>
+        <p:spPr>
+          <a:xfrm>
+            <a:off x="548640" y="320040"/>
+            <a:ext cx="11064240" cy="914400"/>
+          </a:xfrm>
+          <a:prstGeom prst="rect">
+            <a:avLst/>
+          </a:prstGeom>
+          <a:noFill/>
+        </p:spPr>
+        <p:txBody>
+          <a:bodyPr wrap="square">
+            <a:spAutoFit/>
+          </a:bodyPr>
+          <a:lstStyle/>
+          <a:p>
+            <a:r>
+              <a:rPr sz="3000" b="1">
+                <a:solidFill>
+                  <a:srgbClr val="0B0B0B"/>
+                </a:solidFill>
+              </a:rPr>
+              <a:t>What happens on IPO day</a:t>
+            </a:r>
+          </a:p>
+        </p:txBody>
+      </p:sp>
+      <p:sp>
+        <p:nvSpPr>
+          <p:cNvPr id="3" name="Rectangle 2"/>
+          <p:cNvSpPr/>
+          <p:nvPr/>
+        </p:nvSpPr>
+        <p:spPr>
+          <a:xfrm>
+            <a:off x="594360" y="1051560"/>
+            <a:ext cx="2011680" cy="50800"/>
+          </a:xfrm>
+          <a:prstGeom prst="rect">
+            <a:avLst/>
+          </a:prstGeom>
+          <a:solidFill>
+            <a:srgbClr val="2A78D6"/>
+          </a:solidFill>
+          <a:ln>
+            <a:noFill/>
+          </a:ln>
+        </p:spPr>
+        <p:style>
+          <a:lnRef idx="1">
+            <a:schemeClr val="accent1"/>
+          </a:lnRef>
+          <a:fillRef idx="3">
+            <a:schemeClr val="accent1"/>
+          </a:fillRef>
+          <a:effectRef idx="2">
+            <a:schemeClr val="accent1"/>
+          </a:effectRef>
+          <a:fontRef idx="minor">
+            <a:schemeClr val="lt1"/>
+          </a:fontRef>
+        </p:style>
+        <p:txBody>
+          <a:bodyPr rtlCol="0" anchor="ctr"/>
+          <a:lstStyle/>
+          <a:p>
+            <a:pPr algn="ctr"/>
+          </a:p>
+        </p:txBody>
+      </p:sp>
+      <p:sp>
+        <p:nvSpPr>
+          <p:cNvPr id="4" name="TextBox 3"/>
+          <p:cNvSpPr txBox="1"/>
+          <p:nvPr/>
+        </p:nvSpPr>
+        <p:spPr>
+          <a:xfrm>
+            <a:off x="548640" y="1143000"/>
+            <a:ext cx="11064240" cy="457200"/>
+          </a:xfrm>
+          <a:prstGeom prst="rect">
+            <a:avLst/>
+          </a:prstGeom>
+          <a:noFill/>
+        </p:spPr>
+        <p:txBody>
+          <a:bodyPr wrap="square">
+            <a:spAutoFit/>
+          </a:bodyPr>
+          <a:lstStyle/>
+          <a:p>
+            <a:r>
+              <a:rPr sz="1500">
+                <a:solidFill>
+                  <a:srgbClr val="52514E"/>
+                </a:solidFill>
+              </a:rPr>
+              <a:t>One symbol takes 90% of the tape - measured at the producer</a:t>
+            </a:r>
+          </a:p>
+        </p:txBody>
+      </p:sp>
+      <p:graphicFrame>
+        <p:nvGraphicFramePr>
+          <p:cNvPr id="5" name="Table 4"/>
+          <p:cNvGraphicFramePr>
+            <a:graphicFrameLocks noGrp="1"/>
+          </p:cNvGraphicFramePr>
+          <p:nvPr/>
+        </p:nvGraphicFramePr>
+        <p:xfrm>
+          <a:off x="640080" y="1737360"/>
+          <a:ext cx="10972800" cy="1828800"/>
+        </p:xfrm>
+        <a:graphic>
+          <a:graphicData uri="http://schemas.openxmlformats.org/drawingml/2006/table">
+            <a:tbl>
+              <a:tblPr firstRow="1" bandRow="1">
+                <a:tableStyleId>{5C22544A-7EE6-4342-B048-85BDC9FD1C3A}</a:tableStyleId>
+              </a:tblPr>
+              <a:tblGrid>
+                <a:gridCol w="2743200"/>
+                <a:gridCol w="2377440"/>
+                <a:gridCol w="3108960"/>
+                <a:gridCol w="2743200"/>
+              </a:tblGrid>
+              <a:tr h="365760">
+                <a:tc>
+                  <a:txBody>
+                    <a:bodyPr wrap="square"/>
+                    <a:lstStyle/>
+                    <a:p>
+                      <a:r>
+                        <a:rPr sz="1400" b="1">
+                          <a:solidFill>
+                            <a:srgbClr val="FFFFFF"/>
+                          </a:solidFill>
+                        </a:rPr>
+                        <a:t>Feed</a:t>
+                      </a:r>
+                    </a:p>
+                  </a:txBody>
+                  <a:tcPr marT="45720" marB="45720">
+                    <a:solidFill>
+                      <a:srgbClr val="2A78D6"/>
+                    </a:solidFill>
+                  </a:tcPr>
+                </a:tc>
+                <a:tc>
+                  <a:txBody>
+                    <a:bodyPr wrap="square"/>
+                    <a:lstStyle/>
+                    <a:p>
+                      <a:r>
+                        <a:rPr sz="1400" b="1">
+                          <a:solidFill>
+                            <a:srgbClr val="FFFFFF"/>
+                          </a:solidFill>
+                        </a:rPr>
+                        <a:t>Record key</a:t>
+                      </a:r>
+                    </a:p>
+                  </a:txBody>
+                  <a:tcPr marT="45720" marB="45720">
+                    <a:solidFill>
+                      <a:srgbClr val="2A78D6"/>
+                    </a:solidFill>
+                  </a:tcPr>
+                </a:tc>
+                <a:tc>
+                  <a:txBody>
+                    <a:bodyPr wrap="square"/>
+                    <a:lstStyle/>
+                    <a:p>
+                      <a:r>
+                        <a:rPr sz="1400" b="1">
+                          <a:solidFill>
+                            <a:srgbClr val="FFFFFF"/>
+                          </a:solidFill>
+                        </a:rPr>
+                        <a:t>Ingest</a:t>
+                      </a:r>
+                    </a:p>
+                  </a:txBody>
+                  <a:tcPr marT="45720" marB="45720">
+                    <a:solidFill>
+                      <a:srgbClr val="2A78D6"/>
+                    </a:solidFill>
+                  </a:tcPr>
+                </a:tc>
+                <a:tc>
+                  <a:txBody>
+                    <a:bodyPr wrap="square"/>
+                    <a:lstStyle/>
+                    <a:p>
+                      <a:r>
+                        <a:rPr sz="1400" b="1">
+                          <a:solidFill>
+                            <a:srgbClr val="FFFFFF"/>
+                          </a:solidFill>
+                        </a:rPr>
+                        <a:t>Per-symbol ordering</a:t>
+                      </a:r>
+                    </a:p>
+                  </a:txBody>
+                  <a:tcPr marT="45720" marB="45720">
+                    <a:solidFill>
+                      <a:srgbClr val="2A78D6"/>
+                    </a:solidFill>
+                  </a:tcPr>
+                </a:tc>
+              </a:tr>
+              <a:tr h="365760">
+                <a:tc>
+                  <a:txBody>
+                    <a:bodyPr wrap="square"/>
+                    <a:lstStyle/>
+                    <a:p>
+                      <a:r>
+                        <a:rPr sz="1400">
+                          <a:solidFill>
+                            <a:srgbClr val="0B0B0B"/>
+                          </a:solidFill>
+                        </a:rPr>
+                        <a:t>Uniform</a:t>
+                      </a:r>
+                    </a:p>
+                  </a:txBody>
+                  <a:tcPr marT="45720" marB="45720">
+                    <a:solidFill>
+                      <a:srgbClr val="FFFFFF"/>
+                    </a:solidFill>
+                  </a:tcPr>
+                </a:tc>
+                <a:tc>
+                  <a:txBody>
+                    <a:bodyPr wrap="square"/>
+                    <a:lstStyle/>
+                    <a:p>
+                      <a:r>
+                        <a:rPr sz="1400">
+                          <a:solidFill>
+                            <a:srgbClr val="0B0B0B"/>
+                          </a:solidFill>
+                        </a:rPr>
+                        <a:t>symbol</a:t>
+                      </a:r>
+                    </a:p>
+                  </a:txBody>
+                  <a:tcPr marT="45720" marB="45720">
+                    <a:solidFill>
+                      <a:srgbClr val="FFFFFF"/>
+                    </a:solidFill>
+                  </a:tcPr>
+                </a:tc>
+                <a:tc>
+                  <a:txBody>
+                    <a:bodyPr wrap="square"/>
+                    <a:lstStyle/>
+                    <a:p>
+                      <a:r>
+                        <a:rPr sz="1400">
+                          <a:solidFill>
+                            <a:srgbClr val="0B0B0B"/>
+                          </a:solidFill>
+                        </a:rPr>
+                        <a:t>873,333/sec</a:t>
+                      </a:r>
+                    </a:p>
+                  </a:txBody>
+                  <a:tcPr marT="45720" marB="45720">
+                    <a:solidFill>
+                      <a:srgbClr val="FFFFFF"/>
+                    </a:solidFill>
+                  </a:tcPr>
+                </a:tc>
+                <a:tc>
+                  <a:txBody>
+                    <a:bodyPr wrap="square"/>
+                    <a:lstStyle/>
+                    <a:p>
+                      <a:r>
+                        <a:rPr sz="1400">
+                          <a:solidFill>
+                            <a:srgbClr val="0B0B0B"/>
+                          </a:solidFill>
+                        </a:rPr>
+                        <a:t>kept</a:t>
+                      </a:r>
+                    </a:p>
+                  </a:txBody>
+                  <a:tcPr marT="45720" marB="45720">
+                    <a:solidFill>
+                      <a:srgbClr val="FFFFFF"/>
+                    </a:solidFill>
+                  </a:tcPr>
+                </a:tc>
+              </a:tr>
+              <a:tr h="365760">
+                <a:tc>
+                  <a:txBody>
+                    <a:bodyPr wrap="square"/>
+                    <a:lstStyle/>
+                    <a:p>
+                      <a:r>
+                        <a:rPr sz="1400">
+                          <a:solidFill>
+                            <a:srgbClr val="0B0B0B"/>
+                          </a:solidFill>
+                        </a:rPr>
+                        <a:t>90% one ticker</a:t>
+                      </a:r>
+                    </a:p>
+                  </a:txBody>
+                  <a:tcPr marT="45720" marB="45720">
+                    <a:solidFill>
+                      <a:srgbClr val="F0EFEC"/>
+                    </a:solidFill>
+                  </a:tcPr>
+                </a:tc>
+                <a:tc>
+                  <a:txBody>
+                    <a:bodyPr wrap="square"/>
+                    <a:lstStyle/>
+                    <a:p>
+                      <a:r>
+                        <a:rPr sz="1400">
+                          <a:solidFill>
+                            <a:srgbClr val="0B0B0B"/>
+                          </a:solidFill>
+                        </a:rPr>
+                        <a:t>symbol</a:t>
+                      </a:r>
+                    </a:p>
+                  </a:txBody>
+                  <a:tcPr marT="45720" marB="45720">
+                    <a:solidFill>
+                      <a:srgbClr val="F0EFEC"/>
+                    </a:solidFill>
+                  </a:tcPr>
+                </a:tc>
+                <a:tc>
+                  <a:txBody>
+                    <a:bodyPr wrap="square"/>
+                    <a:lstStyle/>
+                    <a:p>
+                      <a:r>
+                        <a:rPr sz="1400">
+                          <a:solidFill>
+                            <a:srgbClr val="0B0B0B"/>
+                          </a:solidFill>
+                        </a:rPr>
+                        <a:t>293,333/sec  (-66%)</a:t>
+                      </a:r>
+                    </a:p>
+                  </a:txBody>
+                  <a:tcPr marT="45720" marB="45720">
+                    <a:solidFill>
+                      <a:srgbClr val="F0EFEC"/>
+                    </a:solidFill>
+                  </a:tcPr>
+                </a:tc>
+                <a:tc>
+                  <a:txBody>
+                    <a:bodyPr wrap="square"/>
+                    <a:lstStyle/>
+                    <a:p>
+                      <a:r>
+                        <a:rPr sz="1400">
+                          <a:solidFill>
+                            <a:srgbClr val="0B0B0B"/>
+                          </a:solidFill>
+                        </a:rPr>
+                        <a:t>kept</a:t>
+                      </a:r>
+                    </a:p>
+                  </a:txBody>
+                  <a:tcPr marT="45720" marB="45720">
+                    <a:solidFill>
+                      <a:srgbClr val="F0EFEC"/>
+                    </a:solidFill>
+                  </a:tcPr>
+                </a:tc>
+              </a:tr>
+              <a:tr h="365760">
+                <a:tc>
+                  <a:txBody>
+                    <a:bodyPr wrap="square"/>
+                    <a:lstStyle/>
+                    <a:p>
+                      <a:r>
+                        <a:rPr sz="1400">
+                          <a:solidFill>
+                            <a:srgbClr val="0B0B0B"/>
+                          </a:solidFill>
+                        </a:rPr>
+                        <a:t>90% one ticker</a:t>
+                      </a:r>
+                    </a:p>
+                  </a:txBody>
+                  <a:tcPr marT="45720" marB="45720">
+                    <a:solidFill>
+                      <a:srgbClr val="FFFFFF"/>
+                    </a:solidFill>
+                  </a:tcPr>
+                </a:tc>
+                <a:tc>
+                  <a:txBody>
+                    <a:bodyPr wrap="square"/>
+                    <a:lstStyle/>
+                    <a:p>
+                      <a:r>
+                        <a:rPr sz="1400">
+                          <a:solidFill>
+                            <a:srgbClr val="0B0B0B"/>
+                          </a:solidFill>
+                        </a:rPr>
+                        <a:t>salted</a:t>
+                      </a:r>
+                    </a:p>
+                  </a:txBody>
+                  <a:tcPr marT="45720" marB="45720">
+                    <a:solidFill>
+                      <a:srgbClr val="FFFFFF"/>
+                    </a:solidFill>
+                  </a:tcPr>
+                </a:tc>
+                <a:tc>
+                  <a:txBody>
+                    <a:bodyPr wrap="square"/>
+                    <a:lstStyle/>
+                    <a:p>
+                      <a:r>
+                        <a:rPr sz="1400">
+                          <a:solidFill>
+                            <a:srgbClr val="0B0B0B"/>
+                          </a:solidFill>
+                        </a:rPr>
+                        <a:t>764,444/sec  (-12%)</a:t>
+                      </a:r>
+                    </a:p>
+                  </a:txBody>
+                  <a:tcPr marT="45720" marB="45720">
+                    <a:solidFill>
+                      <a:srgbClr val="FFFFFF"/>
+                    </a:solidFill>
+                  </a:tcPr>
+                </a:tc>
+                <a:tc>
+                  <a:txBody>
+                    <a:bodyPr wrap="square"/>
+                    <a:lstStyle/>
+                    <a:p>
+                      <a:r>
+                        <a:rPr sz="1400">
+                          <a:solidFill>
+                            <a:srgbClr val="0B0B0B"/>
+                          </a:solidFill>
+                        </a:rPr>
+                        <a:t>LOST</a:t>
+                      </a:r>
+                    </a:p>
+                  </a:txBody>
+                  <a:tcPr marT="45720" marB="45720">
+                    <a:solidFill>
+                      <a:srgbClr val="FFFFFF"/>
+                    </a:solidFill>
+                  </a:tcPr>
+                </a:tc>
+              </a:tr>
+              <a:tr h="365760">
+                <a:tc>
+                  <a:txBody>
+                    <a:bodyPr wrap="square"/>
+                    <a:lstStyle/>
+                    <a:p>
+                      <a:r>
+                        <a:rPr sz="1400">
+                          <a:solidFill>
+                            <a:srgbClr val="0B0B0B"/>
+                          </a:solidFill>
+                        </a:rPr>
+                        <a:t>90% one ticker</a:t>
+                      </a:r>
+                    </a:p>
+                  </a:txBody>
+                  <a:tcPr marT="45720" marB="45720">
+                    <a:solidFill>
+                      <a:srgbClr val="F0EFEC"/>
+                    </a:solidFill>
+                  </a:tcPr>
+                </a:tc>
+                <a:tc>
+                  <a:txBody>
+                    <a:bodyPr wrap="square"/>
+                    <a:lstStyle/>
+                    <a:p>
+                      <a:r>
+                        <a:rPr sz="1400">
+                          <a:solidFill>
+                            <a:srgbClr val="0B0B0B"/>
+                          </a:solidFill>
+                        </a:rPr>
+                        <a:t>adaptive</a:t>
+                      </a:r>
+                    </a:p>
+                  </a:txBody>
+                  <a:tcPr marT="45720" marB="45720">
+                    <a:solidFill>
+                      <a:srgbClr val="F0EFEC"/>
+                    </a:solidFill>
+                  </a:tcPr>
+                </a:tc>
+                <a:tc>
+                  <a:txBody>
+                    <a:bodyPr wrap="square"/>
+                    <a:lstStyle/>
+                    <a:p>
+                      <a:r>
+                        <a:rPr sz="1400">
+                          <a:solidFill>
+                            <a:srgbClr val="0B0B0B"/>
+                          </a:solidFill>
+                        </a:rPr>
+                        <a:t>788,888/sec  (-10%)</a:t>
+                      </a:r>
+                    </a:p>
+                  </a:txBody>
+                  <a:tcPr marT="45720" marB="45720">
+                    <a:solidFill>
+                      <a:srgbClr val="F0EFEC"/>
+                    </a:solidFill>
+                  </a:tcPr>
+                </a:tc>
+                <a:tc>
+                  <a:txBody>
+                    <a:bodyPr wrap="square"/>
+                    <a:lstStyle/>
+                    <a:p>
+                      <a:r>
+                        <a:rPr sz="1400">
+                          <a:solidFill>
+                            <a:srgbClr val="0B0B0B"/>
+                          </a:solidFill>
+                        </a:rPr>
+                        <a:t>kept for quiet names</a:t>
+                      </a:r>
+                    </a:p>
+                  </a:txBody>
+                  <a:tcPr marT="45720" marB="45720">
+                    <a:solidFill>
+                      <a:srgbClr val="F0EFEC"/>
+                    </a:solidFill>
+                  </a:tcPr>
+                </a:tc>
+              </a:tr>
+            </a:tbl>
+          </a:graphicData>
+        </a:graphic>
+      </p:graphicFrame>
+      <p:sp>
+        <p:nvSpPr>
+          <p:cNvPr id="6" name="TextBox 5"/>
+          <p:cNvSpPr txBox="1"/>
+          <p:nvPr/>
+        </p:nvSpPr>
+        <p:spPr>
+          <a:xfrm>
+            <a:off x="640080" y="4937760"/>
+            <a:ext cx="10881360" cy="4754880"/>
+          </a:xfrm>
+          <a:prstGeom prst="rect">
+            <a:avLst/>
+          </a:prstGeom>
+          <a:noFill/>
+        </p:spPr>
+        <p:txBody>
+          <a:bodyPr wrap="square">
+            <a:spAutoFit/>
+          </a:bodyPr>
+          <a:lstStyle/>
+          <a:p>
+            <a:pPr>
+              <a:spcAft>
+                <a:spcPts val="900"/>
+              </a:spcAft>
+            </a:pPr>
+            <a:r>
+              <a:rPr sz="1400" b="1">
+                <a:solidFill>
+                  <a:srgbClr val="2A78D6"/>
+                </a:solidFill>
+              </a:rPr>
+              <a:t>• A hot listing costs two thirds of ingest BEFORE the stream processor sees a record: every producer queues behind the one broker owning that symbol's partition</a:t>
+            </a:r>
+          </a:p>
+          <a:p>
+            <a:pPr>
+              <a:spcAft>
+                <a:spcPts val="900"/>
+              </a:spcAft>
+            </a:pPr>
+            <a:r>
+              <a:rPr sz="1400" b="0">
+                <a:solidFill>
+                  <a:srgbClr val="0B0B0B"/>
+                </a:solidFill>
+              </a:rPr>
+              <a:t>• Adding producers makes it worse - they contend for the same leader. No downstream tuning can touch this</a:t>
+            </a:r>
+          </a:p>
+          <a:p>
+            <a:pPr>
+              <a:spcAft>
+                <a:spcPts val="900"/>
+              </a:spcAft>
+            </a:pPr>
+            <a:r>
+              <a:rPr sz="1400" b="1">
+                <a:solidFill>
+                  <a:srgbClr val="008300"/>
+                </a:solidFill>
+              </a:rPr>
+              <a:t>• Fix: spread at the KEY, which is upstream of every ceiling. Salt only the hot names so quiet symbols keep ordering and compaction</a:t>
+            </a:r>
+          </a:p>
+          <a:p>
+            <a:pPr>
+              <a:spcAft>
+                <a:spcPts val="900"/>
+              </a:spcAft>
+            </a:pPr>
+            <a:r>
+              <a:rPr sz="1400" b="1">
+                <a:solidFill>
+                  <a:srgbClr val="0B0B0B"/>
+                </a:solidFill>
+              </a:rPr>
+              <a:t>• Keying fixes INGEST only. Surviving an IPO needs both: spread at the key AND conflate before the narrow stage</a:t>
+            </a:r>
+          </a:p>
+        </p:txBody>
+      </p:sp>
+    </p:spTree>
+  </p:cSld>
+  <p:clrMapOvr>
+    <a:masterClrMapping/>
+  </p:clrMapOvr>
+</p:sld>
+</file>
+
+<file path=ppt/slides/slide13.xml><?xml version="1.0" encoding="utf-8"?>
+<p:sld xmlns:a="http://schemas.openxmlformats.org/drawingml/2006/main" xmlns:p="http://schemas.openxmlformats.org/presentationml/2006/main" xmlns:r="http://schemas.openxmlformats.org/officeDocument/2006/relationships">
+  <p:cSld>
+    <p:spTree>
+      <p:nvGrpSpPr>
+        <p:cNvPr id="1" name=""/>
+        <p:cNvGrpSpPr/>
+        <p:nvPr/>
+      </p:nvGrpSpPr>
+      <p:grpSpPr/>
+      <p:sp>
+        <p:nvSpPr>
+          <p:cNvPr id="2" name="TextBox 1"/>
+          <p:cNvSpPr txBox="1"/>
+          <p:nvPr/>
+        </p:nvSpPr>
+        <p:spPr>
+          <a:xfrm>
+            <a:off x="548640" y="320040"/>
+            <a:ext cx="11064240" cy="914400"/>
+          </a:xfrm>
+          <a:prstGeom prst="rect">
+            <a:avLst/>
+          </a:prstGeom>
+          <a:noFill/>
+        </p:spPr>
+        <p:txBody>
+          <a:bodyPr wrap="square">
+            <a:spAutoFit/>
+          </a:bodyPr>
+          <a:lstStyle/>
+          <a:p>
+            <a:r>
+              <a:rPr sz="3000" b="1">
+                <a:solidFill>
+                  <a:srgbClr val="0B0B0B"/>
+                </a:solidFill>
+              </a:rPr>
+              <a:t>Path to production — AWS ready today</a:t>
+            </a:r>
+          </a:p>
+        </p:txBody>
+      </p:sp>
+      <p:sp>
+        <p:nvSpPr>
+          <p:cNvPr id="3" name="Rectangle 2"/>
+          <p:cNvSpPr/>
+          <p:nvPr/>
+        </p:nvSpPr>
+        <p:spPr>
+          <a:xfrm>
+            <a:off x="594360" y="1051560"/>
+            <a:ext cx="2011680" cy="50800"/>
+          </a:xfrm>
+          <a:prstGeom prst="rect">
+            <a:avLst/>
+          </a:prstGeom>
+          <a:solidFill>
+            <a:srgbClr val="2A78D6"/>
+          </a:solidFill>
+          <a:ln>
+            <a:noFill/>
+          </a:ln>
+        </p:spPr>
+        <p:style>
+          <a:lnRef idx="1">
+            <a:schemeClr val="accent1"/>
+          </a:lnRef>
+          <a:fillRef idx="3">
+            <a:schemeClr val="accent1"/>
+          </a:fillRef>
+          <a:effectRef idx="2">
+            <a:schemeClr val="accent1"/>
+          </a:effectRef>
+          <a:fontRef idx="minor">
+            <a:schemeClr val="lt1"/>
+          </a:fontRef>
+        </p:style>
+        <p:txBody>
+          <a:bodyPr rtlCol="0" anchor="ctr"/>
+          <a:lstStyle/>
+          <a:p>
+            <a:pPr algn="ctr"/>
+          </a:p>
+        </p:txBody>
+      </p:sp>
+      <p:sp>
+        <p:nvSpPr>
+          <p:cNvPr id="4" name="TextBox 3"/>
+          <p:cNvSpPr txBox="1"/>
+          <p:nvPr/>
+        </p:nvSpPr>
+        <p:spPr>
+          <a:xfrm>
+            <a:off x="548640" y="1143000"/>
+            <a:ext cx="11064240" cy="457200"/>
+          </a:xfrm>
+          <a:prstGeom prst="rect">
+            <a:avLst/>
+          </a:prstGeom>
+          <a:noFill/>
+        </p:spPr>
+        <p:txBody>
+          <a:bodyPr wrap="square">
+            <a:spAutoFit/>
+          </a:bodyPr>
+          <a:lstStyle/>
+          <a:p>
+            <a:r>
+              <a:rPr sz="1500">
+                <a:solidFill>
+                  <a:srgbClr val="52514E"/>
+                </a:solidFill>
+              </a:rPr>
+              <a:t>Full infrastructure-as-code, validated; one command to deploy</a:t>
+            </a:r>
+          </a:p>
+        </p:txBody>
+      </p:sp>
+      <p:sp>
+        <p:nvSpPr>
+          <p:cNvPr id="5" name="TextBox 4"/>
+          <p:cNvSpPr txBox="1"/>
+          <p:nvPr/>
+        </p:nvSpPr>
+        <p:spPr>
+          <a:xfrm>
+            <a:off x="640080" y="1737360"/>
+            <a:ext cx="10881360" cy="4754880"/>
+          </a:xfrm>
+          <a:prstGeom prst="rect">
+            <a:avLst/>
+          </a:prstGeom>
+          <a:noFill/>
+        </p:spPr>
+        <p:txBody>
+          <a:bodyPr wrap="square">
+            <a:spAutoFit/>
+          </a:bodyPr>
+          <a:lstStyle/>
+          <a:p>
+            <a:pPr>
+              <a:spcAft>
+                <a:spcPts val="1200"/>
+              </a:spcAft>
+            </a:pPr>
+            <a:r>
+              <a:rPr sz="1800" b="0">
+                <a:solidFill>
+                  <a:srgbClr val="0B0B0B"/>
+                </a:solidFill>
+              </a:rPr>
+              <a:t>• Terraform stack complete: MSK Serverless (Kafka) + Amazon Managed Service for Apache Flink + generator on Fargate + CloudWatch dashboard</a:t>
+            </a:r>
+          </a:p>
+          <a:p>
+            <a:pPr>
+              <a:spcAft>
+                <a:spcPts val="1200"/>
+              </a:spcAft>
+            </a:pPr>
+            <a:r>
+              <a:rPr sz="1800" b="1">
+                <a:solidFill>
+                  <a:srgbClr val="0B0B0B"/>
+                </a:solidFill>
+              </a:rPr>
+              <a:t>• The exact same application jar runs on AWS — every environment difference is configuration</a:t>
+            </a:r>
+          </a:p>
+          <a:p>
+            <a:pPr>
+              <a:spcAft>
+                <a:spcPts val="1200"/>
+              </a:spcAft>
+            </a:pPr>
+            <a:r>
+              <a:rPr sz="1800" b="0">
+                <a:solidFill>
+                  <a:srgbClr val="0B0B0B"/>
+                </a:solidFill>
+              </a:rPr>
+              <a:t>• Security by default: private VPC, IAM auth to Kafka, least-privilege roles</a:t>
+            </a:r>
+          </a:p>
+          <a:p>
+            <a:pPr>
+              <a:spcAft>
+                <a:spcPts val="1200"/>
+              </a:spcAft>
+            </a:pPr>
+            <a:r>
+              <a:rPr sz="1800" b="0">
+                <a:solidFill>
+                  <a:srgbClr val="0B0B0B"/>
+                </a:solidFill>
+              </a:rPr>
+              <a:t>• Operations runbook: deploy, in-place code update, config-only rescale, teardown</a:t>
+            </a:r>
+          </a:p>
+          <a:p>
+            <a:pPr>
+              <a:spcAft>
+                <a:spcPts val="1200"/>
+              </a:spcAft>
+            </a:pPr>
+            <a:r>
+              <a:rPr sz="1800" b="0">
+                <a:solidFill>
+                  <a:srgbClr val="0B0B0B"/>
+                </a:solidFill>
+              </a:rPr>
+              <a:t>• Demo cost ≈ $1/hour while running; destroyed when not in use</a:t>
+            </a:r>
+          </a:p>
+          <a:p>
+            <a:pPr>
+              <a:spcAft>
+                <a:spcPts val="1200"/>
+              </a:spcAft>
+            </a:pPr>
+            <a:r>
+              <a:rPr sz="1800" b="1">
+                <a:solidFill>
+                  <a:srgbClr val="008300"/>
+                </a:solidFill>
+              </a:rPr>
+              <a:t>• Status: DEPLOYED and load-tested on AWS — all cases green, scaling ladder measured, then torn down cleanly</a:t>
+            </a:r>
+          </a:p>
+        </p:txBody>
+      </p:sp>
+    </p:spTree>
+  </p:cSld>
+  <p:clrMapOvr>
+    <a:masterClrMapping/>
+  </p:clrMapOvr>
+</p:sld>
+</file>
+
+<file path=ppt/slides/slide14.xml><?xml version="1.0" encoding="utf-8"?>
 <p:sld xmlns:a="http://schemas.openxmlformats.org/drawingml/2006/main" xmlns:p="http://schemas.openxmlformats.org/presentationml/2006/main" xmlns:r="http://schemas.openxmlformats.org/officeDocument/2006/relationships">
   <p:cSld>
     <p:spTree>
@@ -4756,7 +5666,7 @@
 </p:sld>
 </file>
 
-<file path=ppt/slides/slide13.xml><?xml version="1.0" encoding="utf-8"?>
+<file path=ppt/slides/slide15.xml><?xml version="1.0" encoding="utf-8"?>
 <p:sld xmlns:a="http://schemas.openxmlformats.org/drawingml/2006/main" xmlns:p="http://schemas.openxmlformats.org/presentationml/2006/main" xmlns:r="http://schemas.openxmlformats.org/officeDocument/2006/relationships">
   <p:cSld>
     <p:spTree>

</xml_diff>

<commit_message>
Article and deck: the scaling finding, in plain language
Adds the question that matters operationally -- when it falls behind, can you
buy your way out? Java: yes, roughly linear. SQL on AWS: +17% throughput for
+83% cost, and 17% is inside the run-to-run noise band. SQL on Confluent: 0%,
the platform kept drawing ten units whatever the ceiling said.

Records that the threshold was set before the run (>=1.6x genuine, <1.2x none)
so the result could not be rationalised afterwards, and explains the mechanism
plainly: extra workers only help if the work can be split, and a stock's numbers
have to be added up in one place.

Reframes the Java-vs-SQL comparison: the gap is not mainly per-record speed, it
is that Java converts extra hardware into throughput and this SQL does not.
Speed you can live with; not being able to grow is a different problem, and it
is invisible if you only ever test at one size.

Co-Authored-By: Claude Fable 5 <noreply@anthropic.com>
</commit_message>
<xml_diff>
--- a/docs/flink-demo-exec-briefing.pptx
+++ b/docs/flink-demo-exec-briefing.pptx
@@ -20,6 +20,7 @@
     <p:sldId id="268" r:id="rId19"/>
     <p:sldId id="269" r:id="rId20"/>
     <p:sldId id="270" r:id="rId21"/>
+    <p:sldId id="271" r:id="rId22"/>
   </p:sldIdLst>
   <p:sldSz cx="12191695" cy="6858000" type="screen4x3"/>
   <p:notesSz cx="6858000" cy="9144000"/>
@@ -4969,7 +4970,7 @@
                   <a:srgbClr val="0B0B0B"/>
                 </a:solidFill>
               </a:rPr>
-              <a:t>Path to production — AWS ready today</a:t>
+              <a:t>When it falls behind, can you buy your way out?</a:t>
             </a:r>
           </a:p>
         </p:txBody>
@@ -5045,6 +5046,603 @@
                   <a:srgbClr val="52514E"/>
                 </a:solidFill>
               </a:rPr>
+              <a:t>Same load, same market, one variable: the compute knob doubled</a:t>
+            </a:r>
+          </a:p>
+        </p:txBody>
+      </p:sp>
+      <p:graphicFrame>
+        <p:nvGraphicFramePr>
+          <p:cNvPr id="5" name="Table 4"/>
+          <p:cNvGraphicFramePr>
+            <a:graphicFrameLocks noGrp="1"/>
+          </p:cNvGraphicFramePr>
+          <p:nvPr/>
+        </p:nvGraphicFramePr>
+        <p:xfrm>
+          <a:off x="640080" y="1828800"/>
+          <a:ext cx="11887200" cy="1463040"/>
+        </p:xfrm>
+        <a:graphic>
+          <a:graphicData uri="http://schemas.openxmlformats.org/drawingml/2006/table">
+            <a:tbl>
+              <a:tblPr firstRow="1" bandRow="1">
+                <a:tableStyleId>{5C22544A-7EE6-4342-B048-85BDC9FD1C3A}</a:tableStyleId>
+              </a:tblPr>
+              <a:tblGrid>
+                <a:gridCol w="2743200"/>
+                <a:gridCol w="2743200"/>
+                <a:gridCol w="4114800"/>
+                <a:gridCol w="2286000"/>
+              </a:tblGrid>
+              <a:tr h="365760">
+                <a:tc>
+                  <a:txBody>
+                    <a:bodyPr wrap="square"/>
+                    <a:lstStyle/>
+                    <a:p>
+                      <a:r>
+                        <a:rPr sz="1400" b="1">
+                          <a:solidFill>
+                            <a:srgbClr val="FFFFFF"/>
+                          </a:solidFill>
+                        </a:rPr>
+                        <a:t/>
+                      </a:r>
+                    </a:p>
+                  </a:txBody>
+                  <a:tcPr marT="45720" marB="45720">
+                    <a:solidFill>
+                      <a:srgbClr val="2A78D6"/>
+                    </a:solidFill>
+                  </a:tcPr>
+                </a:tc>
+                <a:tc>
+                  <a:txBody>
+                    <a:bodyPr wrap="square"/>
+                    <a:lstStyle/>
+                    <a:p>
+                      <a:r>
+                        <a:rPr sz="1400" b="1">
+                          <a:solidFill>
+                            <a:srgbClr val="FFFFFF"/>
+                          </a:solidFill>
+                        </a:rPr>
+                        <a:t>Knob doubled</a:t>
+                      </a:r>
+                    </a:p>
+                  </a:txBody>
+                  <a:tcPr marT="45720" marB="45720">
+                    <a:solidFill>
+                      <a:srgbClr val="2A78D6"/>
+                    </a:solidFill>
+                  </a:tcPr>
+                </a:tc>
+                <a:tc>
+                  <a:txBody>
+                    <a:bodyPr wrap="square"/>
+                    <a:lstStyle/>
+                    <a:p>
+                      <a:r>
+                        <a:rPr sz="1400" b="1">
+                          <a:solidFill>
+                            <a:srgbClr val="FFFFFF"/>
+                          </a:solidFill>
+                        </a:rPr>
+                        <a:t>Throughput gained</a:t>
+                      </a:r>
+                    </a:p>
+                  </a:txBody>
+                  <a:tcPr marT="45720" marB="45720">
+                    <a:solidFill>
+                      <a:srgbClr val="2A78D6"/>
+                    </a:solidFill>
+                  </a:tcPr>
+                </a:tc>
+                <a:tc>
+                  <a:txBody>
+                    <a:bodyPr wrap="square"/>
+                    <a:lstStyle/>
+                    <a:p>
+                      <a:r>
+                        <a:rPr sz="1400" b="1">
+                          <a:solidFill>
+                            <a:srgbClr val="FFFFFF"/>
+                          </a:solidFill>
+                        </a:rPr>
+                        <a:t>Cost</a:t>
+                      </a:r>
+                    </a:p>
+                  </a:txBody>
+                  <a:tcPr marT="45720" marB="45720">
+                    <a:solidFill>
+                      <a:srgbClr val="2A78D6"/>
+                    </a:solidFill>
+                  </a:tcPr>
+                </a:tc>
+              </a:tr>
+              <a:tr h="365760">
+                <a:tc>
+                  <a:txBody>
+                    <a:bodyPr wrap="square"/>
+                    <a:lstStyle/>
+                    <a:p>
+                      <a:r>
+                        <a:rPr sz="1400">
+                          <a:solidFill>
+                            <a:srgbClr val="0B0B0B"/>
+                          </a:solidFill>
+                        </a:rPr>
+                        <a:t>DataStream (Java)</a:t>
+                      </a:r>
+                    </a:p>
+                  </a:txBody>
+                  <a:tcPr marT="45720" marB="45720">
+                    <a:solidFill>
+                      <a:srgbClr val="FFFFFF"/>
+                    </a:solidFill>
+                  </a:tcPr>
+                </a:tc>
+                <a:tc>
+                  <a:txBody>
+                    <a:bodyPr wrap="square"/>
+                    <a:lstStyle/>
+                    <a:p>
+                      <a:r>
+                        <a:rPr sz="1400">
+                          <a:solidFill>
+                            <a:srgbClr val="0B0B0B"/>
+                          </a:solidFill>
+                        </a:rPr>
+                        <a:t>parallelism</a:t>
+                      </a:r>
+                    </a:p>
+                  </a:txBody>
+                  <a:tcPr marT="45720" marB="45720">
+                    <a:solidFill>
+                      <a:srgbClr val="FFFFFF"/>
+                    </a:solidFill>
+                  </a:tcPr>
+                </a:tc>
+                <a:tc>
+                  <a:txBody>
+                    <a:bodyPr wrap="square"/>
+                    <a:lstStyle/>
+                    <a:p>
+                      <a:r>
+                        <a:rPr sz="1400">
+                          <a:solidFill>
+                            <a:srgbClr val="0B0B0B"/>
+                          </a:solidFill>
+                        </a:rPr>
+                        <a:t>converts extra hardware into throughput</a:t>
+                      </a:r>
+                    </a:p>
+                  </a:txBody>
+                  <a:tcPr marT="45720" marB="45720">
+                    <a:solidFill>
+                      <a:srgbClr val="FFFFFF"/>
+                    </a:solidFill>
+                  </a:tcPr>
+                </a:tc>
+                <a:tc>
+                  <a:txBody>
+                    <a:bodyPr wrap="square"/>
+                    <a:lstStyle/>
+                    <a:p>
+                      <a:r>
+                        <a:rPr sz="1400">
+                          <a:solidFill>
+                            <a:srgbClr val="0B0B0B"/>
+                          </a:solidFill>
+                        </a:rPr>
+                        <a:t>linear</a:t>
+                      </a:r>
+                    </a:p>
+                  </a:txBody>
+                  <a:tcPr marT="45720" marB="45720">
+                    <a:solidFill>
+                      <a:srgbClr val="FFFFFF"/>
+                    </a:solidFill>
+                  </a:tcPr>
+                </a:tc>
+              </a:tr>
+              <a:tr h="365760">
+                <a:tc>
+                  <a:txBody>
+                    <a:bodyPr wrap="square"/>
+                    <a:lstStyle/>
+                    <a:p>
+                      <a:r>
+                        <a:rPr sz="1400">
+                          <a:solidFill>
+                            <a:srgbClr val="0B0B0B"/>
+                          </a:solidFill>
+                        </a:rPr>
+                        <a:t>SQL on AWS</a:t>
+                      </a:r>
+                    </a:p>
+                  </a:txBody>
+                  <a:tcPr marT="45720" marB="45720">
+                    <a:solidFill>
+                      <a:srgbClr val="F0EFEC"/>
+                    </a:solidFill>
+                  </a:tcPr>
+                </a:tc>
+                <a:tc>
+                  <a:txBody>
+                    <a:bodyPr wrap="square"/>
+                    <a:lstStyle/>
+                    <a:p>
+                      <a:r>
+                        <a:rPr sz="1400">
+                          <a:solidFill>
+                            <a:srgbClr val="0B0B0B"/>
+                          </a:solidFill>
+                        </a:rPr>
+                        <a:t>parallelism 20 -&gt; 40</a:t>
+                      </a:r>
+                    </a:p>
+                  </a:txBody>
+                  <a:tcPr marT="45720" marB="45720">
+                    <a:solidFill>
+                      <a:srgbClr val="F0EFEC"/>
+                    </a:solidFill>
+                  </a:tcPr>
+                </a:tc>
+                <a:tc>
+                  <a:txBody>
+                    <a:bodyPr wrap="square"/>
+                    <a:lstStyle/>
+                    <a:p>
+                      <a:r>
+                        <a:rPr sz="1400">
+                          <a:solidFill>
+                            <a:srgbClr val="0B0B0B"/>
+                          </a:solidFill>
+                        </a:rPr>
+                        <a:t>+17% median - INSIDE the +/-25% noise band</a:t>
+                      </a:r>
+                    </a:p>
+                  </a:txBody>
+                  <a:tcPr marT="45720" marB="45720">
+                    <a:solidFill>
+                      <a:srgbClr val="F0EFEC"/>
+                    </a:solidFill>
+                  </a:tcPr>
+                </a:tc>
+                <a:tc>
+                  <a:txBody>
+                    <a:bodyPr wrap="square"/>
+                    <a:lstStyle/>
+                    <a:p>
+                      <a:r>
+                        <a:rPr sz="1400">
+                          <a:solidFill>
+                            <a:srgbClr val="0B0B0B"/>
+                          </a:solidFill>
+                        </a:rPr>
+                        <a:t>+83%</a:t>
+                      </a:r>
+                    </a:p>
+                  </a:txBody>
+                  <a:tcPr marT="45720" marB="45720">
+                    <a:solidFill>
+                      <a:srgbClr val="F0EFEC"/>
+                    </a:solidFill>
+                  </a:tcPr>
+                </a:tc>
+              </a:tr>
+              <a:tr h="365760">
+                <a:tc>
+                  <a:txBody>
+                    <a:bodyPr wrap="square"/>
+                    <a:lstStyle/>
+                    <a:p>
+                      <a:r>
+                        <a:rPr sz="1400">
+                          <a:solidFill>
+                            <a:srgbClr val="0B0B0B"/>
+                          </a:solidFill>
+                        </a:rPr>
+                        <a:t>SQL on Confluent</a:t>
+                      </a:r>
+                    </a:p>
+                  </a:txBody>
+                  <a:tcPr marT="45720" marB="45720">
+                    <a:solidFill>
+                      <a:srgbClr val="FFFFFF"/>
+                    </a:solidFill>
+                  </a:tcPr>
+                </a:tc>
+                <a:tc>
+                  <a:txBody>
+                    <a:bodyPr wrap="square"/>
+                    <a:lstStyle/>
+                    <a:p>
+                      <a:r>
+                        <a:rPr sz="1400">
+                          <a:solidFill>
+                            <a:srgbClr val="0B0B0B"/>
+                          </a:solidFill>
+                        </a:rPr>
+                        <a:t>pool cap 10 -&gt; 20</a:t>
+                      </a:r>
+                    </a:p>
+                  </a:txBody>
+                  <a:tcPr marT="45720" marB="45720">
+                    <a:solidFill>
+                      <a:srgbClr val="FFFFFF"/>
+                    </a:solidFill>
+                  </a:tcPr>
+                </a:tc>
+                <a:tc>
+                  <a:txBody>
+                    <a:bodyPr wrap="square"/>
+                    <a:lstStyle/>
+                    <a:p>
+                      <a:r>
+                        <a:rPr sz="1400">
+                          <a:solidFill>
+                            <a:srgbClr val="0B0B0B"/>
+                          </a:solidFill>
+                        </a:rPr>
+                        <a:t>0% - platform kept drawing 10 units</a:t>
+                      </a:r>
+                    </a:p>
+                  </a:txBody>
+                  <a:tcPr marT="45720" marB="45720">
+                    <a:solidFill>
+                      <a:srgbClr val="FFFFFF"/>
+                    </a:solidFill>
+                  </a:tcPr>
+                </a:tc>
+                <a:tc>
+                  <a:txBody>
+                    <a:bodyPr wrap="square"/>
+                    <a:lstStyle/>
+                    <a:p>
+                      <a:r>
+                        <a:rPr sz="1400">
+                          <a:solidFill>
+                            <a:srgbClr val="0B0B0B"/>
+                          </a:solidFill>
+                        </a:rPr>
+                        <a:t>n/a</a:t>
+                      </a:r>
+                    </a:p>
+                  </a:txBody>
+                  <a:tcPr marT="45720" marB="45720">
+                    <a:solidFill>
+                      <a:srgbClr val="FFFFFF"/>
+                    </a:solidFill>
+                  </a:tcPr>
+                </a:tc>
+              </a:tr>
+            </a:tbl>
+          </a:graphicData>
+        </a:graphic>
+      </p:graphicFrame>
+      <p:sp>
+        <p:nvSpPr>
+          <p:cNvPr id="6" name="TextBox 5"/>
+          <p:cNvSpPr txBox="1"/>
+          <p:nvPr/>
+        </p:nvSpPr>
+        <p:spPr>
+          <a:xfrm>
+            <a:off x="640080" y="5120640"/>
+            <a:ext cx="10881360" cy="4754880"/>
+          </a:xfrm>
+          <a:prstGeom prst="rect">
+            <a:avLst/>
+          </a:prstGeom>
+          <a:noFill/>
+        </p:spPr>
+        <p:txBody>
+          <a:bodyPr wrap="square">
+            <a:spAutoFit/>
+          </a:bodyPr>
+          <a:lstStyle/>
+          <a:p>
+            <a:pPr>
+              <a:spcAft>
+                <a:spcPts val="900"/>
+              </a:spcAft>
+            </a:pPr>
+            <a:r>
+              <a:rPr sz="1500" b="1">
+                <a:solidFill>
+                  <a:srgbClr val="2A78D6"/>
+                </a:solidFill>
+              </a:rPr>
+              <a:t>• One cloud will not sell you the capacity; the other sells it, bills you, and delivers almost none of it</a:t>
+            </a:r>
+          </a:p>
+          <a:p>
+            <a:pPr>
+              <a:spcAft>
+                <a:spcPts val="900"/>
+              </a:spcAft>
+            </a:pPr>
+            <a:r>
+              <a:rPr sz="1500" b="0">
+                <a:solidFill>
+                  <a:srgbClr val="0B0B0B"/>
+                </a:solidFill>
+              </a:rPr>
+              <a:t>• Threshold was set BEFORE the run: &gt;=1.6x genuine, 1.2-1.6x partial, &lt;1.2x none. Median landed at 1.17x</a:t>
+            </a:r>
+          </a:p>
+          <a:p>
+            <a:pPr>
+              <a:spcAft>
+                <a:spcPts val="900"/>
+              </a:spcAft>
+            </a:pPr>
+            <a:r>
+              <a:rPr sz="1500" b="0">
+                <a:solidFill>
+                  <a:srgbClr val="0B0B0B"/>
+                </a:solidFill>
+              </a:rPr>
+              <a:t>• Extra workers only help if the work can be split - a stock's numbers must be added up in one place, so the new workers idle</a:t>
+            </a:r>
+          </a:p>
+          <a:p>
+            <a:pPr>
+              <a:spcAft>
+                <a:spcPts val="900"/>
+              </a:spcAft>
+            </a:pPr>
+            <a:r>
+              <a:rPr sz="1500" b="1">
+                <a:solidFill>
+                  <a:srgbClr val="008300"/>
+                </a:solidFill>
+              </a:rPr>
+              <a:t>• The Java advantage is not mainly SPEED, it is that Java converts extra hardware into throughput and this SQL does not</a:t>
+            </a:r>
+          </a:p>
+          <a:p>
+            <a:pPr>
+              <a:spcAft>
+                <a:spcPts val="900"/>
+              </a:spcAft>
+            </a:pPr>
+            <a:r>
+              <a:rPr sz="1500" b="1">
+                <a:solidFill>
+                  <a:srgbClr val="008300"/>
+                </a:solidFill>
+              </a:rPr>
+              <a:t>• Speed you can live with. Not being able to grow is a different problem - and invisible if you only test at one size</a:t>
+            </a:r>
+          </a:p>
+        </p:txBody>
+      </p:sp>
+    </p:spTree>
+  </p:cSld>
+  <p:clrMapOvr>
+    <a:masterClrMapping/>
+  </p:clrMapOvr>
+</p:sld>
+</file>
+
+<file path=ppt/slides/slide14.xml><?xml version="1.0" encoding="utf-8"?>
+<p:sld xmlns:a="http://schemas.openxmlformats.org/drawingml/2006/main" xmlns:p="http://schemas.openxmlformats.org/presentationml/2006/main" xmlns:r="http://schemas.openxmlformats.org/officeDocument/2006/relationships">
+  <p:cSld>
+    <p:spTree>
+      <p:nvGrpSpPr>
+        <p:cNvPr id="1" name=""/>
+        <p:cNvGrpSpPr/>
+        <p:nvPr/>
+      </p:nvGrpSpPr>
+      <p:grpSpPr/>
+      <p:sp>
+        <p:nvSpPr>
+          <p:cNvPr id="2" name="TextBox 1"/>
+          <p:cNvSpPr txBox="1"/>
+          <p:nvPr/>
+        </p:nvSpPr>
+        <p:spPr>
+          <a:xfrm>
+            <a:off x="548640" y="320040"/>
+            <a:ext cx="11064240" cy="914400"/>
+          </a:xfrm>
+          <a:prstGeom prst="rect">
+            <a:avLst/>
+          </a:prstGeom>
+          <a:noFill/>
+        </p:spPr>
+        <p:txBody>
+          <a:bodyPr wrap="square">
+            <a:spAutoFit/>
+          </a:bodyPr>
+          <a:lstStyle/>
+          <a:p>
+            <a:r>
+              <a:rPr sz="3000" b="1">
+                <a:solidFill>
+                  <a:srgbClr val="0B0B0B"/>
+                </a:solidFill>
+              </a:rPr>
+              <a:t>Path to production — AWS ready today</a:t>
+            </a:r>
+          </a:p>
+        </p:txBody>
+      </p:sp>
+      <p:sp>
+        <p:nvSpPr>
+          <p:cNvPr id="3" name="Rectangle 2"/>
+          <p:cNvSpPr/>
+          <p:nvPr/>
+        </p:nvSpPr>
+        <p:spPr>
+          <a:xfrm>
+            <a:off x="594360" y="1051560"/>
+            <a:ext cx="2011680" cy="50800"/>
+          </a:xfrm>
+          <a:prstGeom prst="rect">
+            <a:avLst/>
+          </a:prstGeom>
+          <a:solidFill>
+            <a:srgbClr val="2A78D6"/>
+          </a:solidFill>
+          <a:ln>
+            <a:noFill/>
+          </a:ln>
+        </p:spPr>
+        <p:style>
+          <a:lnRef idx="1">
+            <a:schemeClr val="accent1"/>
+          </a:lnRef>
+          <a:fillRef idx="3">
+            <a:schemeClr val="accent1"/>
+          </a:fillRef>
+          <a:effectRef idx="2">
+            <a:schemeClr val="accent1"/>
+          </a:effectRef>
+          <a:fontRef idx="minor">
+            <a:schemeClr val="lt1"/>
+          </a:fontRef>
+        </p:style>
+        <p:txBody>
+          <a:bodyPr rtlCol="0" anchor="ctr"/>
+          <a:lstStyle/>
+          <a:p>
+            <a:pPr algn="ctr"/>
+          </a:p>
+        </p:txBody>
+      </p:sp>
+      <p:sp>
+        <p:nvSpPr>
+          <p:cNvPr id="4" name="TextBox 3"/>
+          <p:cNvSpPr txBox="1"/>
+          <p:nvPr/>
+        </p:nvSpPr>
+        <p:spPr>
+          <a:xfrm>
+            <a:off x="548640" y="1143000"/>
+            <a:ext cx="11064240" cy="457200"/>
+          </a:xfrm>
+          <a:prstGeom prst="rect">
+            <a:avLst/>
+          </a:prstGeom>
+          <a:noFill/>
+        </p:spPr>
+        <p:txBody>
+          <a:bodyPr wrap="square">
+            <a:spAutoFit/>
+          </a:bodyPr>
+          <a:lstStyle/>
+          <a:p>
+            <a:r>
+              <a:rPr sz="1500">
+                <a:solidFill>
+                  <a:srgbClr val="52514E"/>
+                </a:solidFill>
+              </a:rPr>
               <a:t>Full infrastructure-as-code, validated; one command to deploy</a:t>
             </a:r>
           </a:p>
@@ -5171,7 +5769,7 @@
 </p:sld>
 </file>
 
-<file path=ppt/slides/slide14.xml><?xml version="1.0" encoding="utf-8"?>
+<file path=ppt/slides/slide15.xml><?xml version="1.0" encoding="utf-8"?>
 <p:sld xmlns:a="http://schemas.openxmlformats.org/drawingml/2006/main" xmlns:p="http://schemas.openxmlformats.org/presentationml/2006/main" xmlns:r="http://schemas.openxmlformats.org/officeDocument/2006/relationships">
   <p:cSld>
     <p:spTree>
@@ -5666,7 +6264,7 @@
 </p:sld>
 </file>
 
-<file path=ppt/slides/slide15.xml><?xml version="1.0" encoding="utf-8"?>
+<file path=ppt/slides/slide16.xml><?xml version="1.0" encoding="utf-8"?>
 <p:sld xmlns:a="http://schemas.openxmlformats.org/drawingml/2006/main" xmlns:p="http://schemas.openxmlformats.org/presentationml/2006/main" xmlns:r="http://schemas.openxmlformats.org/officeDocument/2006/relationships">
   <p:cSld>
     <p:spTree>

</xml_diff>

<commit_message>
Correct the framing: NEITHER platform scaled SQL
The previous wording read as a contrast -- one cloud will not sell you the
capacity, the other sells it and delivers little -- which implies AWS partially
scaled. It did not. +17% is inside the +/-25% run-to-run noise band and
indistinguishable from zero by the threshold declared before the run.

The headline is the outcome: SQL did not scale on either platform. The differing
mechanisms (autoscaler declines to draw vs provisioned-and-billed but
unconverted) are a footnote about how, not a second finding.

Co-Authored-By: Claude Fable 5 <noreply@anthropic.com>
</commit_message>
<xml_diff>
--- a/docs/flink-demo-exec-briefing.pptx
+++ b/docs/flink-demo-exec-briefing.pptx
@@ -4970,7 +4970,7 @@
                   <a:srgbClr val="0B0B0B"/>
                 </a:solidFill>
               </a:rPr>
-              <a:t>When it falls behind, can you buy your way out?</a:t>
+              <a:t>SQL did not scale on either platform</a:t>
             </a:r>
           </a:p>
         </p:txBody>
@@ -5456,7 +5456,7 @@
                   <a:srgbClr val="2A78D6"/>
                 </a:solidFill>
               </a:rPr>
-              <a:t>• One cloud will not sell you the capacity; the other sells it, bills you, and delivers almost none of it</a:t>
+              <a:t>• NEITHER scaled. +17% is inside the noise band - not a weaker form of scaling, a number indistinguishable from zero</a:t>
             </a:r>
           </a:p>
           <a:p>

</xml_diff>

<commit_message>
Reframe everything as DataStream API vs Flink SQL, not AWS vs Confluent
The vendor was never the variable. On the SAME cloud DataStream sustains 5.5x
SQL; on BOTH clouds SQL failed to scale. The axis that explains every
performance result is the API.

Reframes PHASE19_RESULTS, README, the article and the deck accordingly, and
separates out what genuinely IS cloud-specific so it is not confused with the
API finding: CR-1 cadence expressible on AWS SQL and not on Confluent, Confluent
naming expensive query shapes while MSF stays silent, partitions billed on MSK
and free on eCKU, CloudWatch outliving teardown where Confluent telemetry does
not. Those are capability and billing differences, not speed.

Co-Authored-By: Claude Fable 5 <noreply@anthropic.com>
</commit_message>
<xml_diff>
--- a/docs/flink-demo-exec-briefing.pptx
+++ b/docs/flink-demo-exec-briefing.pptx
@@ -4970,7 +4970,7 @@
                   <a:srgbClr val="0B0B0B"/>
                 </a:solidFill>
               </a:rPr>
-              <a:t>SQL did not scale on either platform</a:t>
+              <a:t>Flink SQL did not scale on either cloud</a:t>
             </a:r>
           </a:p>
         </p:txBody>
@@ -9768,7 +9768,7 @@
                   <a:srgbClr val="0B0B0B"/>
                 </a:solidFill>
               </a:rPr>
-              <a:t>Two clouds, one test suite — the measured scoreboard</a:t>
+              <a:t>DataStream API vs Flink SQL — the measured scoreboard</a:t>
             </a:r>
           </a:p>
         </p:txBody>
@@ -9844,7 +9844,7 @@
                   <a:srgbClr val="52514E"/>
                 </a:solidFill>
               </a:rPr>
-              <a:t>Same requirements, same data, same five correctness checks; every figure output-verified</a:t>
+              <a:t>The axis is the API, not the vendor: SQL was run on BOTH clouds and behaved the same on each</a:t>
             </a:r>
           </a:p>
         </p:txBody>
@@ -10636,10 +10636,10 @@
             <a:r>
               <a:rPr sz="1400" b="1">
                 <a:solidFill>
-                  <a:srgbClr val="0B0B0B"/>
-                </a:solidFill>
-              </a:rPr>
-              <a:t>• SQL runs at the SAME speed on both clouds: the language is the constraint, not the vendor</a:t>
+                  <a:srgbClr val="008300"/>
+                </a:solidFill>
+              </a:rPr>
+              <a:t>• SQL runs the SAME on both clouds - same speed, same failure to scale. The API is the variable; the vendor is not</a:t>
             </a:r>
           </a:p>
           <a:p>

</xml_diff>